<commit_message>
docs: redesign PowerPoint presentation deck with native XML transitions, zero emojis, and no currency converter
</commit_message>
<xml_diff>
--- a/TripSplit_Presentation.pptx
+++ b/TripSplit_Presentation.pptx
@@ -3112,7 +3112,7 @@
             <a:avLst/>
           </a:prstGeom>
           <a:solidFill>
-            <a:srgbClr val="1F2937"/>
+            <a:srgbClr val="0F172A"/>
           </a:solidFill>
           <a:ln>
             <a:noFill/>
@@ -3142,14 +3142,57 @@
       </p:sp>
       <p:sp>
         <p:nvSpPr>
-          <p:cNvPr id="3" name="TextBox 2"/>
+          <p:cNvPr id="3" name="Rectangle 2"/>
+          <p:cNvSpPr/>
+          <p:nvPr/>
+        </p:nvSpPr>
+        <p:spPr>
+          <a:xfrm>
+            <a:off x="731520" y="2011680"/>
+            <a:ext cx="109728" cy="2926080"/>
+          </a:xfrm>
+          <a:prstGeom prst="rect">
+            <a:avLst/>
+          </a:prstGeom>
+          <a:solidFill>
+            <a:srgbClr val="7C3AED"/>
+          </a:solidFill>
+          <a:ln>
+            <a:noFill/>
+          </a:ln>
+        </p:spPr>
+        <p:style>
+          <a:lnRef idx="1">
+            <a:schemeClr val="accent1"/>
+          </a:lnRef>
+          <a:fillRef idx="3">
+            <a:schemeClr val="accent1"/>
+          </a:fillRef>
+          <a:effectRef idx="2">
+            <a:schemeClr val="accent1"/>
+          </a:effectRef>
+          <a:fontRef idx="minor">
+            <a:schemeClr val="lt1"/>
+          </a:fontRef>
+        </p:style>
+        <p:txBody>
+          <a:bodyPr rtlCol="0" anchor="ctr"/>
+          <a:lstStyle/>
+          <a:p>
+            <a:pPr algn="ctr"/>
+          </a:p>
+        </p:txBody>
+      </p:sp>
+      <p:sp>
+        <p:nvSpPr>
+          <p:cNvPr id="4" name="TextBox 3"/>
           <p:cNvSpPr txBox="1"/>
           <p:nvPr/>
         </p:nvSpPr>
         <p:spPr>
           <a:xfrm>
-            <a:off x="914400" y="1828800"/>
-            <a:ext cx="10362895" cy="3200400"/>
+            <a:off x="1097280" y="1828800"/>
+            <a:ext cx="10058400" cy="3291840"/>
           </a:xfrm>
           <a:prstGeom prst="rect">
             <a:avLst/>
@@ -3163,7 +3206,7 @@
           <a:lstStyle/>
           <a:p>
             <a:pPr>
-              <a:defRPr sz="5400" b="1">
+              <a:defRPr sz="5600" b="1">
                 <a:solidFill>
                   <a:srgbClr val="7C3AED"/>
                 </a:solidFill>
@@ -3177,13 +3220,12 @@
           <a:p>
             <a:pPr>
               <a:spcBef>
-                <a:spcPts val="1000"/>
+                <a:spcPts val="800"/>
               </a:spcBef>
               <a:defRPr sz="2800" b="1">
                 <a:solidFill>
                   <a:srgbClr val="FFFFFF"/>
                 </a:solidFill>
-                <a:latin typeface="Arial"/>
               </a:defRPr>
             </a:pPr>
             <a:r>
@@ -3193,33 +3235,31 @@
           <a:p>
             <a:pPr>
               <a:spcBef>
-                <a:spcPts val="1500"/>
+                <a:spcPts val="1400"/>
               </a:spcBef>
               <a:defRPr sz="1600">
                 <a:solidFill>
-                  <a:srgbClr val="6B7280"/>
-                </a:solidFill>
-                <a:latin typeface="Arial"/>
-              </a:defRPr>
-            </a:pPr>
-            <a:r>
-              <a:t>An Intelligent Multi-City Itinerary Generator &amp; Group Expense Splitter for India</a:t>
+                  <a:srgbClr val="94A3B8"/>
+                </a:solidFill>
+              </a:defRPr>
+            </a:pPr>
+            <a:r>
+              <a:t>An Intelligent Multi-City Itinerary Allocation Engine &amp; Group Expense Splitter for India</a:t>
             </a:r>
           </a:p>
           <a:p>
             <a:pPr>
               <a:spcBef>
-                <a:spcPts val="3000"/>
+                <a:spcPts val="3200"/>
               </a:spcBef>
-              <a:defRPr sz="1400">
+              <a:defRPr sz="1400" b="1">
                 <a:solidFill>
                   <a:srgbClr val="10B981"/>
                 </a:solidFill>
-                <a:latin typeface="Arial"/>
-              </a:defRPr>
-            </a:pPr>
-            <a:r>
-              <a:t>College Final Project Presentation • Computer Science &amp; Engineering</a:t>
+              </a:defRPr>
+            </a:pPr>
+            <a:r>
+              <a:t>Computer Science &amp; Engineering Final Project</a:t>
             </a:r>
           </a:p>
         </p:txBody>
@@ -3229,6 +3269,9 @@
   <p:clrMapOvr>
     <a:masterClrMapping/>
   </p:clrMapOvr>
+  <p:transition spd="med">
+    <p:fade/>
+  </p:transition>
 </p:sld>
 </file>
 
@@ -3257,7 +3300,7 @@
             <a:avLst/>
           </a:prstGeom>
           <a:solidFill>
-            <a:srgbClr val="1F2937"/>
+            <a:srgbClr val="0F172A"/>
           </a:solidFill>
           <a:ln>
             <a:noFill/>
@@ -3293,8 +3336,8 @@
         </p:nvSpPr>
         <p:spPr>
           <a:xfrm>
-            <a:off x="914400" y="2011680"/>
-            <a:ext cx="10362895" cy="3200400"/>
+            <a:off x="1097280" y="2011680"/>
+            <a:ext cx="10058400" cy="3200400"/>
           </a:xfrm>
           <a:prstGeom prst="rect">
             <a:avLst/>
@@ -3308,7 +3351,7 @@
           <a:lstStyle/>
           <a:p>
             <a:pPr>
-              <a:defRPr sz="5000" b="1">
+              <a:defRPr sz="5200" b="1">
                 <a:solidFill>
                   <a:srgbClr val="7C3AED"/>
                 </a:solidFill>
@@ -3322,7 +3365,7 @@
           <a:p>
             <a:pPr>
               <a:spcBef>
-                <a:spcPts val="1000"/>
+                <a:spcPts val="1200"/>
               </a:spcBef>
               <a:defRPr sz="2400" b="1">
                 <a:solidFill>
@@ -3339,14 +3382,14 @@
               <a:spcBef>
                 <a:spcPts val="2000"/>
               </a:spcBef>
-              <a:defRPr sz="1800">
+              <a:defRPr sz="1800" b="1">
                 <a:solidFill>
                   <a:srgbClr val="10B981"/>
                 </a:solidFill>
               </a:defRPr>
             </a:pPr>
             <a:r>
-              <a:t>Questions &amp; Feedback are welcome!</a:t>
+              <a:t>Questions &amp; Project Discussion</a:t>
             </a:r>
           </a:p>
         </p:txBody>
@@ -3356,6 +3399,9 @@
   <p:clrMapOvr>
     <a:masterClrMapping/>
   </p:clrMapOvr>
+  <p:transition spd="med">
+    <p:fade/>
+  </p:transition>
 </p:sld>
 </file>
 
@@ -3377,8 +3423,8 @@
         </p:nvSpPr>
         <p:spPr>
           <a:xfrm>
-            <a:off x="731520" y="457200"/>
-            <a:ext cx="10058400" cy="365760"/>
+            <a:off x="731520" y="411480"/>
+            <a:ext cx="7315200" cy="320040"/>
           </a:xfrm>
           <a:prstGeom prst="rect">
             <a:avLst/>
@@ -3400,7 +3446,7 @@
               </a:defRPr>
             </a:pPr>
             <a:r>
-              <a:t>TRIPSPLIT COLLEGE PROJECT</a:t>
+              <a:t>USER FRICTION &amp; NEED ANALYSIS</a:t>
             </a:r>
           </a:p>
         </p:txBody>
@@ -3413,8 +3459,8 @@
         </p:nvSpPr>
         <p:spPr>
           <a:xfrm>
-            <a:off x="731520" y="731520"/>
-            <a:ext cx="10058400" cy="731520"/>
+            <a:off x="731520" y="685800"/>
+            <a:ext cx="10058400" cy="640080"/>
           </a:xfrm>
           <a:prstGeom prst="rect">
             <a:avLst/>
@@ -3430,13 +3476,13 @@
             <a:pPr>
               <a:defRPr sz="2600" b="1">
                 <a:solidFill>
-                  <a:srgbClr val="1F2937"/>
+                  <a:srgbClr val="111827"/>
                 </a:solidFill>
                 <a:latin typeface="Arial"/>
               </a:defRPr>
             </a:pPr>
             <a:r>
-              <a:t>Problem Statement &amp; Challenges</a:t>
+              <a:t>Problem Statement &amp; Industry Challenges</a:t>
             </a:r>
           </a:p>
         </p:txBody>
@@ -3449,18 +3495,18 @@
         </p:nvSpPr>
         <p:spPr>
           <a:xfrm>
-            <a:off x="731520" y="1645920"/>
-            <a:ext cx="5120640" cy="2011680"/>
+            <a:off x="731520" y="1554480"/>
+            <a:ext cx="5120640" cy="2103120"/>
           </a:xfrm>
           <a:prstGeom prst="roundRect">
             <a:avLst/>
           </a:prstGeom>
           <a:solidFill>
-            <a:srgbClr val="F3F4F6"/>
+            <a:srgbClr val="FFFFFF"/>
           </a:solidFill>
           <a:ln>
             <a:solidFill>
-              <a:srgbClr val="E5E7EB"/>
+              <a:srgbClr val="E2E8F0"/>
             </a:solidFill>
           </a:ln>
         </p:spPr>
@@ -3483,14 +3529,14 @@
           <a:lstStyle/>
           <a:p>
             <a:pPr algn="ctr">
-              <a:defRPr sz="1800" b="1">
-                <a:solidFill>
-                  <a:srgbClr val="1F2937"/>
-                </a:solidFill>
-              </a:defRPr>
-            </a:pPr>
-            <a:r>
-              <a:t>❌  Budget Confusion</a:t>
+              <a:defRPr sz="1700" b="1">
+                <a:solidFill>
+                  <a:srgbClr val="111827"/>
+                </a:solidFill>
+              </a:defRPr>
+            </a:pPr>
+            <a:r>
+              <a:t>Budget Allocation Confusion</a:t>
             </a:r>
           </a:p>
           <a:p>
@@ -3505,7 +3551,7 @@
               </a:defRPr>
             </a:pPr>
             <a:r>
-              <a:t>Students struggle to balance total group budgets vs per-person shares, leading to inaccurate financial planning.</a:t>
+              <a:t>Students struggle to distinguish between total trip budgets vs per-person shares, leading to critical miscalculations during planning.</a:t>
             </a:r>
           </a:p>
         </p:txBody>
@@ -3518,18 +3564,18 @@
         </p:nvSpPr>
         <p:spPr>
           <a:xfrm>
-            <a:off x="6126480" y="1645920"/>
-            <a:ext cx="5120640" cy="2011680"/>
+            <a:off x="6126480" y="1554480"/>
+            <a:ext cx="5120640" cy="2103120"/>
           </a:xfrm>
           <a:prstGeom prst="roundRect">
             <a:avLst/>
           </a:prstGeom>
           <a:solidFill>
-            <a:srgbClr val="F3F4F6"/>
+            <a:srgbClr val="FFFFFF"/>
           </a:solidFill>
           <a:ln>
             <a:solidFill>
-              <a:srgbClr val="E5E7EB"/>
+              <a:srgbClr val="E2E8F0"/>
             </a:solidFill>
           </a:ln>
         </p:spPr>
@@ -3552,14 +3598,14 @@
           <a:lstStyle/>
           <a:p>
             <a:pPr algn="ctr">
-              <a:defRPr sz="1800" b="1">
-                <a:solidFill>
-                  <a:srgbClr val="1F2937"/>
-                </a:solidFill>
-              </a:defRPr>
-            </a:pPr>
-            <a:r>
-              <a:t>❌  Manual Routing Effort</a:t>
+              <a:defRPr sz="1700" b="1">
+                <a:solidFill>
+                  <a:srgbClr val="111827"/>
+                </a:solidFill>
+              </a:defRPr>
+            </a:pPr>
+            <a:r>
+              <a:t>High Manual Research Effort</a:t>
             </a:r>
           </a:p>
           <a:p>
@@ -3574,7 +3620,7 @@
               </a:defRPr>
             </a:pPr>
             <a:r>
-              <a:t>Creating multi-day itineraries manually across multiple Indian cities takes hours of research with unpredictable venue costs.</a:t>
+              <a:t>Designing multi-day travel itineraries across Indian cities manually takes hours of research with unpredictable venue and hotel costs.</a:t>
             </a:r>
           </a:p>
         </p:txBody>
@@ -3587,18 +3633,18 @@
         </p:nvSpPr>
         <p:spPr>
           <a:xfrm>
-            <a:off x="731520" y="4023360"/>
-            <a:ext cx="5120640" cy="2011680"/>
+            <a:off x="731520" y="3931920"/>
+            <a:ext cx="5120640" cy="2103120"/>
           </a:xfrm>
           <a:prstGeom prst="roundRect">
             <a:avLst/>
           </a:prstGeom>
           <a:solidFill>
-            <a:srgbClr val="F3F4F6"/>
+            <a:srgbClr val="FFFFFF"/>
           </a:solidFill>
           <a:ln>
             <a:solidFill>
-              <a:srgbClr val="E5E7EB"/>
+              <a:srgbClr val="E2E8F0"/>
             </a:solidFill>
           </a:ln>
         </p:spPr>
@@ -3621,14 +3667,14 @@
           <a:lstStyle/>
           <a:p>
             <a:pPr algn="ctr">
-              <a:defRPr sz="1800" b="1">
-                <a:solidFill>
-                  <a:srgbClr val="1F2937"/>
-                </a:solidFill>
-              </a:defRPr>
-            </a:pPr>
-            <a:r>
-              <a:t>❌  Oversimplified Planners</a:t>
+              <a:defRPr sz="1700" b="1">
+                <a:solidFill>
+                  <a:srgbClr val="111827"/>
+                </a:solidFill>
+              </a:defRPr>
+            </a:pPr>
+            <a:r>
+              <a:t>Generic Non-Tailored Planners</a:t>
             </a:r>
           </a:p>
           <a:p>
@@ -3643,7 +3689,7 @@
               </a:defRPr>
             </a:pPr>
             <a:r>
-              <a:t>Generic travel tools recommend generic locations without catering to student budget constraints or local travel options.</a:t>
+              <a:t>Existing booking engines recommend high-end commercial spots without catering to student pricing constraints or regional travel options.</a:t>
             </a:r>
           </a:p>
         </p:txBody>
@@ -3656,18 +3702,18 @@
         </p:nvSpPr>
         <p:spPr>
           <a:xfrm>
-            <a:off x="6126480" y="4023360"/>
-            <a:ext cx="5120640" cy="2011680"/>
+            <a:off x="6126480" y="3931920"/>
+            <a:ext cx="5120640" cy="2103120"/>
           </a:xfrm>
           <a:prstGeom prst="roundRect">
             <a:avLst/>
           </a:prstGeom>
           <a:solidFill>
-            <a:srgbClr val="F3F4F6"/>
+            <a:srgbClr val="FFFFFF"/>
           </a:solidFill>
           <a:ln>
             <a:solidFill>
-              <a:srgbClr val="E5E7EB"/>
+              <a:srgbClr val="E2E8F0"/>
             </a:solidFill>
           </a:ln>
         </p:spPr>
@@ -3690,14 +3736,14 @@
           <a:lstStyle/>
           <a:p>
             <a:pPr algn="ctr">
-              <a:defRPr sz="1800" b="1">
-                <a:solidFill>
-                  <a:srgbClr val="1F2937"/>
-                </a:solidFill>
-              </a:defRPr>
-            </a:pPr>
-            <a:r>
-              <a:t>❌  Expense Splitting Friction</a:t>
+              <a:defRPr sz="1700" b="1">
+                <a:solidFill>
+                  <a:srgbClr val="111827"/>
+                </a:solidFill>
+              </a:defRPr>
+            </a:pPr>
+            <a:r>
+              <a:t>Post-Trip Financial Friction</a:t>
             </a:r>
           </a:p>
           <a:p>
@@ -3712,7 +3758,7 @@
               </a:defRPr>
             </a:pPr>
             <a:r>
-              <a:t>Group trips often suffer from unorganized shared bill tracking, causing awkward financial settlements post-trip.</a:t>
+              <a:t>Shared group trips often suffer from unorganized bill tracking, resulting in complex and awkward debt settlements after returning.</a:t>
             </a:r>
           </a:p>
         </p:txBody>
@@ -3722,6 +3768,9 @@
   <p:clrMapOvr>
     <a:masterClrMapping/>
   </p:clrMapOvr>
+  <p:transition spd="med">
+    <p:push dir="l"/>
+  </p:transition>
 </p:sld>
 </file>
 
@@ -3743,8 +3792,8 @@
         </p:nvSpPr>
         <p:spPr>
           <a:xfrm>
-            <a:off x="731520" y="457200"/>
-            <a:ext cx="10058400" cy="365760"/>
+            <a:off x="731520" y="411480"/>
+            <a:ext cx="7315200" cy="320040"/>
           </a:xfrm>
           <a:prstGeom prst="rect">
             <a:avLst/>
@@ -3766,7 +3815,7 @@
               </a:defRPr>
             </a:pPr>
             <a:r>
-              <a:t>TRIPSPLIT COLLEGE PROJECT</a:t>
+              <a:t>CORE INNOVATIONS</a:t>
             </a:r>
           </a:p>
         </p:txBody>
@@ -3779,8 +3828,8 @@
         </p:nvSpPr>
         <p:spPr>
           <a:xfrm>
-            <a:off x="731520" y="731520"/>
-            <a:ext cx="10058400" cy="731520"/>
+            <a:off x="731520" y="685800"/>
+            <a:ext cx="10058400" cy="640080"/>
           </a:xfrm>
           <a:prstGeom prst="rect">
             <a:avLst/>
@@ -3796,13 +3845,13 @@
             <a:pPr>
               <a:defRPr sz="2600" b="1">
                 <a:solidFill>
-                  <a:srgbClr val="1F2937"/>
+                  <a:srgbClr val="111827"/>
                 </a:solidFill>
                 <a:latin typeface="Arial"/>
               </a:defRPr>
             </a:pPr>
             <a:r>
-              <a:t>The TripSplit Solution</a:t>
+              <a:t>The TripSplit Solution Architecture</a:t>
             </a:r>
           </a:p>
         </p:txBody>
@@ -3815,18 +3864,18 @@
         </p:nvSpPr>
         <p:spPr>
           <a:xfrm>
-            <a:off x="731520" y="1645920"/>
-            <a:ext cx="5120640" cy="2011680"/>
+            <a:off x="731520" y="1554480"/>
+            <a:ext cx="5120640" cy="2103120"/>
           </a:xfrm>
           <a:prstGeom prst="roundRect">
             <a:avLst/>
           </a:prstGeom>
           <a:solidFill>
-            <a:srgbClr val="F3F4F6"/>
+            <a:srgbClr val="F8FAFC"/>
           </a:solidFill>
           <a:ln>
             <a:solidFill>
-              <a:srgbClr val="E5E7EB"/>
+              <a:srgbClr val="7C3AED"/>
             </a:solidFill>
           </a:ln>
         </p:spPr>
@@ -3849,14 +3898,14 @@
           <a:lstStyle/>
           <a:p>
             <a:pPr algn="ctr">
-              <a:defRPr sz="1800" b="1">
+              <a:defRPr sz="1700" b="1">
                 <a:solidFill>
                   <a:srgbClr val="7C3AED"/>
                 </a:solidFill>
               </a:defRPr>
             </a:pPr>
             <a:r>
-              <a:t>✨  Smart Budget Splitter</a:t>
+              <a:t>Dynamic Budget Partitioning</a:t>
             </a:r>
           </a:p>
           <a:p>
@@ -3866,12 +3915,12 @@
               </a:spcBef>
               <a:defRPr sz="1300">
                 <a:solidFill>
-                  <a:srgbClr val="1F2937"/>
-                </a:solidFill>
-              </a:defRPr>
-            </a:pPr>
-            <a:r>
-              <a:t>Automatically breaks down total budget into Transport, Stay, Food, Local Travel, and Buffer with per-person calculations.</a:t>
+                  <a:srgbClr val="111827"/>
+                </a:solidFill>
+              </a:defRPr>
+            </a:pPr>
+            <a:r>
+              <a:t>Automatically divides the input budget across Transport, Stay, Food, Local Travel, and a 10% safety buffer with real-time per-person breakdowns.</a:t>
             </a:r>
           </a:p>
         </p:txBody>
@@ -3884,18 +3933,18 @@
         </p:nvSpPr>
         <p:spPr>
           <a:xfrm>
-            <a:off x="6126480" y="1645920"/>
-            <a:ext cx="5120640" cy="2011680"/>
+            <a:off x="6126480" y="1554480"/>
+            <a:ext cx="5120640" cy="2103120"/>
           </a:xfrm>
           <a:prstGeom prst="roundRect">
             <a:avLst/>
           </a:prstGeom>
           <a:solidFill>
-            <a:srgbClr val="F3F4F6"/>
+            <a:srgbClr val="F8FAFC"/>
           </a:solidFill>
           <a:ln>
             <a:solidFill>
-              <a:srgbClr val="E5E7EB"/>
+              <a:srgbClr val="7C3AED"/>
             </a:solidFill>
           </a:ln>
         </p:spPr>
@@ -3918,14 +3967,14 @@
           <a:lstStyle/>
           <a:p>
             <a:pPr algn="ctr">
-              <a:defRPr sz="1800" b="1">
+              <a:defRPr sz="1700" b="1">
                 <a:solidFill>
                   <a:srgbClr val="7C3AED"/>
                 </a:solidFill>
               </a:defRPr>
             </a:pPr>
             <a:r>
-              <a:t>✨  Budget-Free Sightseeing</a:t>
+              <a:t>Budget-Free Sightseeing Logic</a:t>
             </a:r>
           </a:p>
           <a:p>
@@ -3935,12 +3984,12 @@
               </a:spcBef>
               <a:defRPr sz="1300">
                 <a:solidFill>
-                  <a:srgbClr val="1F2937"/>
-                </a:solidFill>
-              </a:defRPr>
-            </a:pPr>
-            <a:r>
-              <a:t>All tourist entry tickets are computed as budget-free, maximizing sightseeing options without depleting hotel/food funds.</a:t>
+                  <a:srgbClr val="111827"/>
+                </a:solidFill>
+              </a:defRPr>
+            </a:pPr>
+            <a:r>
+              <a:t>Sightseeing entry tickets are calculated as budget-free, ensuring rich attraction recommendations regardless of accommodation tier.</a:t>
             </a:r>
           </a:p>
         </p:txBody>
@@ -3953,18 +4002,18 @@
         </p:nvSpPr>
         <p:spPr>
           <a:xfrm>
-            <a:off x="731520" y="4023360"/>
-            <a:ext cx="5120640" cy="2011680"/>
+            <a:off x="731520" y="3931920"/>
+            <a:ext cx="5120640" cy="2103120"/>
           </a:xfrm>
           <a:prstGeom prst="roundRect">
             <a:avLst/>
           </a:prstGeom>
           <a:solidFill>
-            <a:srgbClr val="F3F4F6"/>
+            <a:srgbClr val="F8FAFC"/>
           </a:solidFill>
           <a:ln>
             <a:solidFill>
-              <a:srgbClr val="E5E7EB"/>
+              <a:srgbClr val="7C3AED"/>
             </a:solidFill>
           </a:ln>
         </p:spPr>
@@ -3987,14 +4036,14 @@
           <a:lstStyle/>
           <a:p>
             <a:pPr algn="ctr">
-              <a:defRPr sz="1800" b="1">
+              <a:defRPr sz="1700" b="1">
                 <a:solidFill>
                   <a:srgbClr val="7C3AED"/>
                 </a:solidFill>
               </a:defRPr>
             </a:pPr>
             <a:r>
-              <a:t>✨  5 Unique Itinerary Styles</a:t>
+              <a:t>5 Comparative Itinerary Styles</a:t>
             </a:r>
           </a:p>
           <a:p>
@@ -4004,12 +4053,12 @@
               </a:spcBef>
               <a:defRPr sz="1300">
                 <a:solidFill>
-                  <a:srgbClr val="1F2937"/>
-                </a:solidFill>
-              </a:defRPr>
-            </a:pPr>
-            <a:r>
-              <a:t>Generates 5 comparative plans: Best Overall, Cheapest Trip, Slow &amp; Relaxed, More Places, and Better Stay.</a:t>
+                  <a:srgbClr val="111827"/>
+                </a:solidFill>
+              </a:defRPr>
+            </a:pPr>
+            <a:r>
+              <a:t>Generates five distinct trip plans in parallel: Best Overall, Cheapest Trip, Slow &amp; Relaxed, More Places, and Better Stay.</a:t>
             </a:r>
           </a:p>
         </p:txBody>
@@ -4022,18 +4071,18 @@
         </p:nvSpPr>
         <p:spPr>
           <a:xfrm>
-            <a:off x="6126480" y="4023360"/>
-            <a:ext cx="5120640" cy="2011680"/>
+            <a:off x="6126480" y="3931920"/>
+            <a:ext cx="5120640" cy="2103120"/>
           </a:xfrm>
           <a:prstGeom prst="roundRect">
             <a:avLst/>
           </a:prstGeom>
           <a:solidFill>
-            <a:srgbClr val="F3F4F6"/>
+            <a:srgbClr val="F8FAFC"/>
           </a:solidFill>
           <a:ln>
             <a:solidFill>
-              <a:srgbClr val="E5E7EB"/>
+              <a:srgbClr val="7C3AED"/>
             </a:solidFill>
           </a:ln>
         </p:spPr>
@@ -4056,14 +4105,14 @@
           <a:lstStyle/>
           <a:p>
             <a:pPr algn="ctr">
-              <a:defRPr sz="1800" b="1">
+              <a:defRPr sz="1700" b="1">
                 <a:solidFill>
                   <a:srgbClr val="7C3AED"/>
                 </a:solidFill>
               </a:defRPr>
             </a:pPr>
             <a:r>
-              <a:t>✨  Integrated Group Ledger</a:t>
+              <a:t>Integrated Group Expense Ledger</a:t>
             </a:r>
           </a:p>
           <a:p>
@@ -4073,12 +4122,12 @@
               </a:spcBef>
               <a:defRPr sz="1300">
                 <a:solidFill>
-                  <a:srgbClr val="1F2937"/>
-                </a:solidFill>
-              </a:defRPr>
-            </a:pPr>
-            <a:r>
-              <a:t>Includes a built-in group expense manager with equal/custom splits, settlement reports, and analytics charts.</a:t>
+                  <a:srgbClr val="111827"/>
+                </a:solidFill>
+              </a:defRPr>
+            </a:pPr>
+            <a:r>
+              <a:t>Features a built-in group bill manager with equal/custom splits, net settlement reduction algorithms, and visual category charts.</a:t>
             </a:r>
           </a:p>
         </p:txBody>
@@ -4088,6 +4137,9 @@
   <p:clrMapOvr>
     <a:masterClrMapping/>
   </p:clrMapOvr>
+  <p:transition spd="med">
+    <p:push dir="l"/>
+  </p:transition>
 </p:sld>
 </file>
 
@@ -4103,14 +4155,57 @@
       <p:grpSpPr/>
       <p:sp>
         <p:nvSpPr>
-          <p:cNvPr id="2" name="TextBox 1"/>
+          <p:cNvPr id="2" name="Rectangle 1"/>
+          <p:cNvSpPr/>
+          <p:nvPr/>
+        </p:nvSpPr>
+        <p:spPr>
+          <a:xfrm>
+            <a:off x="0" y="0"/>
+            <a:ext cx="12191695" cy="6858000"/>
+          </a:xfrm>
+          <a:prstGeom prst="rect">
+            <a:avLst/>
+          </a:prstGeom>
+          <a:solidFill>
+            <a:srgbClr val="0F172A"/>
+          </a:solidFill>
+          <a:ln>
+            <a:noFill/>
+          </a:ln>
+        </p:spPr>
+        <p:style>
+          <a:lnRef idx="1">
+            <a:schemeClr val="accent1"/>
+          </a:lnRef>
+          <a:fillRef idx="3">
+            <a:schemeClr val="accent1"/>
+          </a:fillRef>
+          <a:effectRef idx="2">
+            <a:schemeClr val="accent1"/>
+          </a:effectRef>
+          <a:fontRef idx="minor">
+            <a:schemeClr val="lt1"/>
+          </a:fontRef>
+        </p:style>
+        <p:txBody>
+          <a:bodyPr rtlCol="0" anchor="ctr"/>
+          <a:lstStyle/>
+          <a:p>
+            <a:pPr algn="ctr"/>
+          </a:p>
+        </p:txBody>
+      </p:sp>
+      <p:sp>
+        <p:nvSpPr>
+          <p:cNvPr id="3" name="TextBox 2"/>
           <p:cNvSpPr txBox="1"/>
           <p:nvPr/>
         </p:nvSpPr>
         <p:spPr>
           <a:xfrm>
-            <a:off x="731520" y="457200"/>
-            <a:ext cx="10058400" cy="365760"/>
+            <a:off x="731520" y="548640"/>
+            <a:ext cx="10058400" cy="731520"/>
           </a:xfrm>
           <a:prstGeom prst="rect">
             <a:avLst/>
@@ -4118,57 +4213,20 @@
           <a:noFill/>
         </p:spPr>
         <p:txBody>
-          <a:bodyPr wrap="square">
+          <a:bodyPr wrap="none">
             <a:spAutoFit/>
           </a:bodyPr>
           <a:lstStyle/>
           <a:p>
             <a:pPr>
-              <a:defRPr sz="1000" b="1">
-                <a:solidFill>
-                  <a:srgbClr val="7C3AED"/>
-                </a:solidFill>
-                <a:latin typeface="Arial"/>
-              </a:defRPr>
-            </a:pPr>
-            <a:r>
-              <a:t>TRIPSPLIT COLLEGE PROJECT</a:t>
-            </a:r>
-          </a:p>
-        </p:txBody>
-      </p:sp>
-      <p:sp>
-        <p:nvSpPr>
-          <p:cNvPr id="3" name="TextBox 2"/>
-          <p:cNvSpPr txBox="1"/>
-          <p:nvPr/>
-        </p:nvSpPr>
-        <p:spPr>
-          <a:xfrm>
-            <a:off x="731520" y="731520"/>
-            <a:ext cx="10058400" cy="731520"/>
-          </a:xfrm>
-          <a:prstGeom prst="rect">
-            <a:avLst/>
-          </a:prstGeom>
-          <a:noFill/>
-        </p:spPr>
-        <p:txBody>
-          <a:bodyPr wrap="square">
-            <a:spAutoFit/>
-          </a:bodyPr>
-          <a:lstStyle/>
-          <a:p>
-            <a:pPr>
               <a:defRPr sz="2600" b="1">
                 <a:solidFill>
-                  <a:srgbClr val="1F2937"/>
-                </a:solidFill>
-                <a:latin typeface="Arial"/>
-              </a:defRPr>
-            </a:pPr>
-            <a:r>
-              <a:t>System Architecture &amp; Tech Stack</a:t>
+                  <a:srgbClr val="FFFFFF"/>
+                </a:solidFill>
+              </a:defRPr>
+            </a:pPr>
+            <a:r>
+              <a:t>System Architecture &amp; Technology Stack</a:t>
             </a:r>
           </a:p>
         </p:txBody>
@@ -4181,14 +4239,14 @@
         </p:nvSpPr>
         <p:spPr>
           <a:xfrm>
-            <a:off x="731520" y="1645920"/>
-            <a:ext cx="3383280" cy="4572000"/>
+            <a:off x="731520" y="1554480"/>
+            <a:ext cx="3383280" cy="4663440"/>
           </a:xfrm>
           <a:prstGeom prst="roundRect">
             <a:avLst/>
           </a:prstGeom>
           <a:solidFill>
-            <a:srgbClr val="F3F4F6"/>
+            <a:srgbClr val="1E293B"/>
           </a:solidFill>
           <a:ln>
             <a:solidFill>
@@ -4215,14 +4273,14 @@
           <a:lstStyle/>
           <a:p>
             <a:pPr algn="ctr">
-              <a:defRPr sz="2000" b="1">
-                <a:solidFill>
-                  <a:srgbClr val="7C3AED"/>
-                </a:solidFill>
-              </a:defRPr>
-            </a:pPr>
-            <a:r>
-              <a:t>Frontend Layer</a:t>
+              <a:defRPr sz="1600" b="1">
+                <a:solidFill>
+                  <a:srgbClr val="10B981"/>
+                </a:solidFill>
+              </a:defRPr>
+            </a:pPr>
+            <a:r>
+              <a:t>FRONTEND LAYER</a:t>
             </a:r>
           </a:p>
           <a:p>
@@ -4232,24 +4290,29 @@
               </a:spcBef>
               <a:defRPr sz="1300">
                 <a:solidFill>
-                  <a:srgbClr val="1F2937"/>
-                </a:solidFill>
-              </a:defRPr>
-            </a:pPr>
-            <a:r>
-              <a:t>Vanilla HTML5, CSS3, ES6+ JavaScript</a:t>
+                  <a:srgbClr val="E2E8F0"/>
+                </a:solidFill>
+              </a:defRPr>
+            </a:pPr>
+            <a:r>
+              <a:t>Vanilla HTML5, CSS3, ES6+ JS</a:t>
             </a:r>
             <a:br/>
-            <a:r>
-              <a:t>• TripAdvisor-Grade Responsive Design</a:t>
-            </a:r>
             <a:br/>
             <a:r>
-              <a:t>• Leaflet.js Interactive Maps</a:t>
+              <a:t>• Single Page App (SPA) Navigation</a:t>
             </a:r>
             <a:br/>
             <a:r>
-              <a:t>• Single-Page App (SPA) Navigation</a:t>
+              <a:t>• Leaflet.js Interactive Mapping</a:t>
+            </a:r>
+            <a:br/>
+            <a:r>
+              <a:t>• TripAdvisor-Grade Visual UI</a:t>
+            </a:r>
+            <a:br/>
+            <a:r>
+              <a:t>• Fully Responsive Layout</a:t>
             </a:r>
           </a:p>
         </p:txBody>
@@ -4262,14 +4325,14 @@
         </p:nvSpPr>
         <p:spPr>
           <a:xfrm>
-            <a:off x="4297680" y="1645920"/>
-            <a:ext cx="3383280" cy="4572000"/>
+            <a:off x="4297680" y="1554480"/>
+            <a:ext cx="3383280" cy="4663440"/>
           </a:xfrm>
           <a:prstGeom prst="roundRect">
             <a:avLst/>
           </a:prstGeom>
           <a:solidFill>
-            <a:srgbClr val="F3F4F6"/>
+            <a:srgbClr val="1E293B"/>
           </a:solidFill>
           <a:ln>
             <a:solidFill>
@@ -4296,14 +4359,14 @@
           <a:lstStyle/>
           <a:p>
             <a:pPr algn="ctr">
-              <a:defRPr sz="2000" b="1">
-                <a:solidFill>
-                  <a:srgbClr val="7C3AED"/>
-                </a:solidFill>
-              </a:defRPr>
-            </a:pPr>
-            <a:r>
-              <a:t>Backend Services</a:t>
+              <a:defRPr sz="1600" b="1">
+                <a:solidFill>
+                  <a:srgbClr val="10B981"/>
+                </a:solidFill>
+              </a:defRPr>
+            </a:pPr>
+            <a:r>
+              <a:t>BACKEND ENGINE</a:t>
             </a:r>
           </a:p>
           <a:p>
@@ -4313,7 +4376,7 @@
               </a:spcBef>
               <a:defRPr sz="1300">
                 <a:solidFill>
-                  <a:srgbClr val="1F2937"/>
+                  <a:srgbClr val="E2E8F0"/>
                 </a:solidFill>
               </a:defRPr>
             </a:pPr>
@@ -4321,16 +4384,21 @@
               <a:t>Python 3 &amp; FastAPI Framework</a:t>
             </a:r>
             <a:br/>
-            <a:r>
-              <a:t>• High-performance RESTful API endpoints</a:t>
-            </a:r>
             <a:br/>
             <a:r>
-              <a:t>• Knapsack-style Budget Allocation Engine</a:t>
+              <a:t>• Knapsack Allocation Heuristics</a:t>
             </a:r>
             <a:br/>
             <a:r>
-              <a:t>• Uvicorn ASGI Server Execution</a:t>
+              <a:t>• Asynchronous REST API Endpoints</a:t>
+            </a:r>
+            <a:br/>
+            <a:r>
+              <a:t>• Uvicorn Serverless Execution</a:t>
+            </a:r>
+            <a:br/>
+            <a:r>
+              <a:t>• Modular Router &amp; Optimizer</a:t>
             </a:r>
           </a:p>
         </p:txBody>
@@ -4343,14 +4411,14 @@
         </p:nvSpPr>
         <p:spPr>
           <a:xfrm>
-            <a:off x="7863840" y="1645920"/>
-            <a:ext cx="3383280" cy="4572000"/>
+            <a:off x="7863840" y="1554480"/>
+            <a:ext cx="3383280" cy="4663440"/>
           </a:xfrm>
           <a:prstGeom prst="roundRect">
             <a:avLst/>
           </a:prstGeom>
           <a:solidFill>
-            <a:srgbClr val="F3F4F6"/>
+            <a:srgbClr val="1E293B"/>
           </a:solidFill>
           <a:ln>
             <a:solidFill>
@@ -4377,14 +4445,14 @@
           <a:lstStyle/>
           <a:p>
             <a:pPr algn="ctr">
-              <a:defRPr sz="2000" b="1">
-                <a:solidFill>
-                  <a:srgbClr val="7C3AED"/>
-                </a:solidFill>
-              </a:defRPr>
-            </a:pPr>
-            <a:r>
-              <a:t>External APIs &amp; Data</a:t>
+              <a:defRPr sz="1600" b="1">
+                <a:solidFill>
+                  <a:srgbClr val="10B981"/>
+                </a:solidFill>
+              </a:defRPr>
+            </a:pPr>
+            <a:r>
+              <a:t>DATA &amp; GEOSPATIAL</a:t>
             </a:r>
           </a:p>
           <a:p>
@@ -4394,7 +4462,7 @@
               </a:spcBef>
               <a:defRPr sz="1300">
                 <a:solidFill>
-                  <a:srgbClr val="1F2937"/>
+                  <a:srgbClr val="E2E8F0"/>
                 </a:solidFill>
               </a:defRPr>
             </a:pPr>
@@ -4402,16 +4470,21 @@
               <a:t>OpenStreetMap Ecosystem</a:t>
             </a:r>
             <a:br/>
-            <a:r>
-              <a:t>• Nominatim Geocoding API</a:t>
-            </a:r>
             <a:br/>
             <a:r>
-              <a:t>• Overpass POI API (Hotels, Dining, Sights)</a:t>
+              <a:t>• Nominatim Instant Geocoding</a:t>
             </a:r>
             <a:br/>
             <a:r>
-              <a:t>• Local Real-World Offline Database</a:t>
+              <a:t>• Overpass POI API (Venues &amp; Sights)</a:t>
+            </a:r>
+            <a:br/>
+            <a:r>
+              <a:t>• Pre-cached City Databases</a:t>
+            </a:r>
+            <a:br/>
+            <a:r>
+              <a:t>• Fallback Real-World Catalogs</a:t>
             </a:r>
           </a:p>
         </p:txBody>
@@ -4421,6 +4494,9 @@
   <p:clrMapOvr>
     <a:masterClrMapping/>
   </p:clrMapOvr>
+  <p:transition spd="med">
+    <p:push dir="l"/>
+  </p:transition>
 </p:sld>
 </file>
 
@@ -4442,8 +4518,8 @@
         </p:nvSpPr>
         <p:spPr>
           <a:xfrm>
-            <a:off x="731520" y="457200"/>
-            <a:ext cx="10058400" cy="365760"/>
+            <a:off x="731520" y="411480"/>
+            <a:ext cx="7315200" cy="320040"/>
           </a:xfrm>
           <a:prstGeom prst="rect">
             <a:avLst/>
@@ -4465,7 +4541,7 @@
               </a:defRPr>
             </a:pPr>
             <a:r>
-              <a:t>TRIPSPLIT COLLEGE PROJECT</a:t>
+              <a:t>ALGORITHM PIPELINE</a:t>
             </a:r>
           </a:p>
         </p:txBody>
@@ -4478,8 +4554,8 @@
         </p:nvSpPr>
         <p:spPr>
           <a:xfrm>
-            <a:off x="731520" y="731520"/>
-            <a:ext cx="10058400" cy="731520"/>
+            <a:off x="731520" y="685800"/>
+            <a:ext cx="10058400" cy="640080"/>
           </a:xfrm>
           <a:prstGeom prst="rect">
             <a:avLst/>
@@ -4495,13 +4571,13 @@
             <a:pPr>
               <a:defRPr sz="2600" b="1">
                 <a:solidFill>
-                  <a:srgbClr val="1F2937"/>
+                  <a:srgbClr val="111827"/>
                 </a:solidFill>
                 <a:latin typeface="Arial"/>
               </a:defRPr>
             </a:pPr>
             <a:r>
-              <a:t>Optimization Heuristics &amp; Knapsack Model</a:t>
+              <a:t>Optimization Heuristics &amp; Knapsack Execution</a:t>
             </a:r>
           </a:p>
         </p:txBody>
@@ -4514,18 +4590,18 @@
         </p:nvSpPr>
         <p:spPr>
           <a:xfrm>
-            <a:off x="731520" y="1645920"/>
-            <a:ext cx="10698480" cy="1005840"/>
+            <a:off x="731520" y="1554480"/>
+            <a:ext cx="10698480" cy="1051560"/>
           </a:xfrm>
           <a:prstGeom prst="roundRect">
             <a:avLst/>
           </a:prstGeom>
           <a:solidFill>
-            <a:srgbClr val="F3F4F6"/>
+            <a:srgbClr val="FFFFFF"/>
           </a:solidFill>
           <a:ln>
             <a:solidFill>
-              <a:srgbClr val="E5E7EB"/>
+              <a:srgbClr val="E2E8F0"/>
             </a:solidFill>
           </a:ln>
         </p:spPr>
@@ -4555,15 +4631,15 @@
               </a:defRPr>
             </a:pPr>
             <a:r>
-              <a:t>1. Bounding Box &amp; Geocoding  —  </a:t>
+              <a:t>Phase 1: Bounding Box &amp; Geocoding  —  </a:t>
             </a:r>
             <a:r>
               <a:rPr sz="1300" b="0">
                 <a:solidFill>
-                  <a:srgbClr val="1F2937"/>
+                  <a:srgbClr val="111827"/>
                 </a:solidFill>
               </a:rPr>
-              <a:t>Converts city inputs into precise lat/lon coordinates. Applies dense 5km radius bounding box capping for metro cities to optimize query times.</a:t>
+              <a:t>Converts target city inputs into lat/lon coordinates. Applies a dense 5km radius bounding box cap for metro cities (Delhi, Mumbai) to optimize search latency.</a:t>
             </a:r>
           </a:p>
         </p:txBody>
@@ -4576,18 +4652,18 @@
         </p:nvSpPr>
         <p:spPr>
           <a:xfrm>
-            <a:off x="731520" y="2834640"/>
-            <a:ext cx="10698480" cy="1005840"/>
+            <a:off x="731520" y="2743200"/>
+            <a:ext cx="10698480" cy="1051560"/>
           </a:xfrm>
           <a:prstGeom prst="roundRect">
             <a:avLst/>
           </a:prstGeom>
           <a:solidFill>
-            <a:srgbClr val="F3F4F6"/>
+            <a:srgbClr val="FFFFFF"/>
           </a:solidFill>
           <a:ln>
             <a:solidFill>
-              <a:srgbClr val="E5E7EB"/>
+              <a:srgbClr val="E2E8F0"/>
             </a:solidFill>
           </a:ln>
         </p:spPr>
@@ -4617,15 +4693,15 @@
               </a:defRPr>
             </a:pPr>
             <a:r>
-              <a:t>2. Heuristic Categorization  —  </a:t>
+              <a:t>Phase 2: Venue Utility Scoring  —  </a:t>
             </a:r>
             <a:r>
               <a:rPr sz="1300" b="0">
                 <a:solidFill>
-                  <a:srgbClr val="1F2937"/>
+                  <a:srgbClr val="111827"/>
                 </a:solidFill>
               </a:rPr>
-              <a:t>Classifies venues into Stays, Dining, and Attractions with utility scores (0-100) and cost estimates based on group size and travel duration.</a:t>
+              <a:t>Classifies query results into Stays, Dining, and Attractions with utility scores (0-100) and cost estimates tailored for student travel.</a:t>
             </a:r>
           </a:p>
         </p:txBody>
@@ -4638,18 +4714,18 @@
         </p:nvSpPr>
         <p:spPr>
           <a:xfrm>
-            <a:off x="731520" y="4023360"/>
-            <a:ext cx="10698480" cy="1005840"/>
+            <a:off x="731520" y="3931920"/>
+            <a:ext cx="10698480" cy="1051560"/>
           </a:xfrm>
           <a:prstGeom prst="roundRect">
             <a:avLst/>
           </a:prstGeom>
           <a:solidFill>
-            <a:srgbClr val="F3F4F6"/>
+            <a:srgbClr val="FFFFFF"/>
           </a:solidFill>
           <a:ln>
             <a:solidFill>
-              <a:srgbClr val="E5E7EB"/>
+              <a:srgbClr val="E2E8F0"/>
             </a:solidFill>
           </a:ln>
         </p:spPr>
@@ -4679,12 +4755,12 @@
               </a:defRPr>
             </a:pPr>
             <a:r>
-              <a:t>3. Budget Partitioning  —  </a:t>
+              <a:t>Phase 3: Constrained Partitioning  —  </a:t>
             </a:r>
             <a:r>
               <a:rPr sz="1300" b="0">
                 <a:solidFill>
-                  <a:srgbClr val="1F2937"/>
+                  <a:srgbClr val="111827"/>
                 </a:solidFill>
               </a:rPr>
               <a:t>Allocates funds across fixed categories (Transport, Accommodation, Food, Local Travel) with a minimum 10% safety buffer.</a:t>
@@ -4700,18 +4776,18 @@
         </p:nvSpPr>
         <p:spPr>
           <a:xfrm>
-            <a:off x="731520" y="5212080"/>
-            <a:ext cx="10698480" cy="1005840"/>
+            <a:off x="731520" y="5120640"/>
+            <a:ext cx="10698480" cy="1051560"/>
           </a:xfrm>
           <a:prstGeom prst="roundRect">
             <a:avLst/>
           </a:prstGeom>
           <a:solidFill>
-            <a:srgbClr val="F3F4F6"/>
+            <a:srgbClr val="FFFFFF"/>
           </a:solidFill>
           <a:ln>
             <a:solidFill>
-              <a:srgbClr val="E5E7EB"/>
+              <a:srgbClr val="E2E8F0"/>
             </a:solidFill>
           </a:ln>
         </p:spPr>
@@ -4741,15 +4817,15 @@
               </a:defRPr>
             </a:pPr>
             <a:r>
-              <a:t>4. Timeline Distribution  —  </a:t>
+              <a:t>Phase 4: Sequential Day Slotting  —  </a:t>
             </a:r>
             <a:r>
               <a:rPr sz="1300" b="0">
                 <a:solidFill>
-                  <a:srgbClr val="1F2937"/>
+                  <a:srgbClr val="111827"/>
                 </a:solidFill>
               </a:rPr>
-              <a:t>Sequentially slots attractions into Morning, Afternoon, Evening, and Night segments, generating balanced day-by-day itineraries.</a:t>
+              <a:t>Slots attractions sequentially into Morning, Afternoon, Evening, and Night timeline buckets, producing structured day-by-day plans.</a:t>
             </a:r>
           </a:p>
         </p:txBody>
@@ -4759,6 +4835,9 @@
   <p:clrMapOvr>
     <a:masterClrMapping/>
   </p:clrMapOvr>
+  <p:transition spd="med">
+    <p:push dir="l"/>
+  </p:transition>
 </p:sld>
 </file>
 
@@ -4780,8 +4859,8 @@
         </p:nvSpPr>
         <p:spPr>
           <a:xfrm>
-            <a:off x="731520" y="457200"/>
-            <a:ext cx="10058400" cy="365760"/>
+            <a:off x="731520" y="411480"/>
+            <a:ext cx="7315200" cy="320040"/>
           </a:xfrm>
           <a:prstGeom prst="rect">
             <a:avLst/>
@@ -4803,7 +4882,7 @@
               </a:defRPr>
             </a:pPr>
             <a:r>
-              <a:t>TRIPSPLIT COLLEGE PROJECT</a:t>
+              <a:t>PLATFORM HIGHLIGHTS</a:t>
             </a:r>
           </a:p>
         </p:txBody>
@@ -4816,8 +4895,8 @@
         </p:nvSpPr>
         <p:spPr>
           <a:xfrm>
-            <a:off x="731520" y="731520"/>
-            <a:ext cx="10058400" cy="731520"/>
+            <a:off x="731520" y="685800"/>
+            <a:ext cx="10058400" cy="640080"/>
           </a:xfrm>
           <a:prstGeom prst="rect">
             <a:avLst/>
@@ -4833,13 +4912,13 @@
             <a:pPr>
               <a:defRPr sz="2600" b="1">
                 <a:solidFill>
-                  <a:srgbClr val="1F2937"/>
+                  <a:srgbClr val="111827"/>
                 </a:solidFill>
                 <a:latin typeface="Arial"/>
               </a:defRPr>
             </a:pPr>
             <a:r>
-              <a:t>Key Features &amp; Functionalities</a:t>
+              <a:t>India-Centric Features &amp; Capabilities</a:t>
             </a:r>
           </a:p>
         </p:txBody>
@@ -4852,18 +4931,18 @@
         </p:nvSpPr>
         <p:spPr>
           <a:xfrm>
-            <a:off x="731520" y="1645920"/>
-            <a:ext cx="5120640" cy="2011680"/>
+            <a:off x="731520" y="1554480"/>
+            <a:ext cx="5120640" cy="2103120"/>
           </a:xfrm>
           <a:prstGeom prst="roundRect">
             <a:avLst/>
           </a:prstGeom>
           <a:solidFill>
-            <a:srgbClr val="F3F4F6"/>
+            <a:srgbClr val="F8FAFC"/>
           </a:solidFill>
           <a:ln>
             <a:solidFill>
-              <a:srgbClr val="E5E7EB"/>
+              <a:srgbClr val="E2E8F0"/>
             </a:solidFill>
           </a:ln>
         </p:spPr>
@@ -4888,12 +4967,12 @@
             <a:pPr algn="ctr">
               <a:defRPr sz="1700" b="1">
                 <a:solidFill>
-                  <a:srgbClr val="1F2937"/>
-                </a:solidFill>
-              </a:defRPr>
-            </a:pPr>
-            <a:r>
-              <a:t>🇮🇳 India-Centric Travel Data</a:t>
+                  <a:srgbClr val="111827"/>
+                </a:solidFill>
+              </a:defRPr>
+            </a:pPr>
+            <a:r>
+              <a:t>India-Specific Transport Modes</a:t>
             </a:r>
           </a:p>
           <a:p>
@@ -4908,7 +4987,7 @@
               </a:defRPr>
             </a:pPr>
             <a:r>
-              <a:t>Tailored exclusively for Indian destinations with train (3AC, Sleeper), flight, and cab transport modes.</a:t>
+              <a:t>Supports regional travel options including 3AC Train, Sleeper Class, Flights, and Private Cabs with real fare estimates.</a:t>
             </a:r>
           </a:p>
         </p:txBody>
@@ -4921,18 +5000,18 @@
         </p:nvSpPr>
         <p:spPr>
           <a:xfrm>
-            <a:off x="6126480" y="1645920"/>
-            <a:ext cx="5120640" cy="2011680"/>
+            <a:off x="6126480" y="1554480"/>
+            <a:ext cx="5120640" cy="2103120"/>
           </a:xfrm>
           <a:prstGeom prst="roundRect">
             <a:avLst/>
           </a:prstGeom>
           <a:solidFill>
-            <a:srgbClr val="F3F4F6"/>
+            <a:srgbClr val="F8FAFC"/>
           </a:solidFill>
           <a:ln>
             <a:solidFill>
-              <a:srgbClr val="E5E7EB"/>
+              <a:srgbClr val="E2E8F0"/>
             </a:solidFill>
           </a:ln>
         </p:spPr>
@@ -4957,12 +5036,12 @@
             <a:pPr algn="ctr">
               <a:defRPr sz="1700" b="1">
                 <a:solidFill>
-                  <a:srgbClr val="1F2937"/>
-                </a:solidFill>
-              </a:defRPr>
-            </a:pPr>
-            <a:r>
-              <a:t>⚡ High-Reliability Fallback</a:t>
+                  <a:srgbClr val="111827"/>
+                </a:solidFill>
+              </a:defRPr>
+            </a:pPr>
+            <a:r>
+              <a:t>High-Availability Offline Catalog</a:t>
             </a:r>
           </a:p>
           <a:p>
@@ -4977,7 +5056,7 @@
               </a:defRPr>
             </a:pPr>
             <a:r>
-              <a:t>Includes rich offline venue catalogs for major Indian hubs (Delhi, Mumbai, Goa, Jaipur) for zero downtime.</a:t>
+              <a:t>Pre-populated real-world venue databases for major Indian travel hubs (Delhi, Mumbai, Goa, Jaipur) for zero downtime.</a:t>
             </a:r>
           </a:p>
         </p:txBody>
@@ -4990,18 +5069,18 @@
         </p:nvSpPr>
         <p:spPr>
           <a:xfrm>
-            <a:off x="731520" y="4023360"/>
-            <a:ext cx="5120640" cy="2011680"/>
+            <a:off x="731520" y="3931920"/>
+            <a:ext cx="5120640" cy="2103120"/>
           </a:xfrm>
           <a:prstGeom prst="roundRect">
             <a:avLst/>
           </a:prstGeom>
           <a:solidFill>
-            <a:srgbClr val="F3F4F6"/>
+            <a:srgbClr val="F8FAFC"/>
           </a:solidFill>
           <a:ln>
             <a:solidFill>
-              <a:srgbClr val="E5E7EB"/>
+              <a:srgbClr val="E2E8F0"/>
             </a:solidFill>
           </a:ln>
         </p:spPr>
@@ -5026,12 +5105,12 @@
             <a:pPr algn="ctr">
               <a:defRPr sz="1700" b="1">
                 <a:solidFill>
-                  <a:srgbClr val="1F2937"/>
-                </a:solidFill>
-              </a:defRPr>
-            </a:pPr>
-            <a:r>
-              <a:t>📊 Side-by-Side Comparison</a:t>
+                  <a:srgbClr val="111827"/>
+                </a:solidFill>
+              </a:defRPr>
+            </a:pPr>
+            <a:r>
+              <a:t>Side-by-Side Comparison Matrix</a:t>
             </a:r>
           </a:p>
           <a:p>
@@ -5046,7 +5125,7 @@
               </a:defRPr>
             </a:pPr>
             <a:r>
-              <a:t>Modal view allowing users to compare budget breakdowns and highlights across all 5 trip options simultaneously.</a:t>
+              <a:t>Interactive modal enabling simultaneous comparison of cost splits, stay ratings, and highlights across all 5 trip options.</a:t>
             </a:r>
           </a:p>
         </p:txBody>
@@ -5059,18 +5138,18 @@
         </p:nvSpPr>
         <p:spPr>
           <a:xfrm>
-            <a:off x="6126480" y="4023360"/>
-            <a:ext cx="5120640" cy="2011680"/>
+            <a:off x="6126480" y="3931920"/>
+            <a:ext cx="5120640" cy="2103120"/>
           </a:xfrm>
           <a:prstGeom prst="roundRect">
             <a:avLst/>
           </a:prstGeom>
           <a:solidFill>
-            <a:srgbClr val="F3F4F6"/>
+            <a:srgbClr val="F8FAFC"/>
           </a:solidFill>
           <a:ln>
             <a:solidFill>
-              <a:srgbClr val="E5E7EB"/>
+              <a:srgbClr val="E2E8F0"/>
             </a:solidFill>
           </a:ln>
         </p:spPr>
@@ -5095,12 +5174,12 @@
             <a:pPr algn="ctr">
               <a:defRPr sz="1700" b="1">
                 <a:solidFill>
-                  <a:srgbClr val="1F2937"/>
-                </a:solidFill>
-              </a:defRPr>
-            </a:pPr>
-            <a:r>
-              <a:t>💱 Currency Converter &amp; Seasons</a:t>
+                  <a:srgbClr val="111827"/>
+                </a:solidFill>
+              </a:defRPr>
+            </a:pPr>
+            <a:r>
+              <a:t>Seasonal Destination Guidance</a:t>
             </a:r>
           </a:p>
           <a:p>
@@ -5115,7 +5194,7 @@
               </a:defRPr>
             </a:pPr>
             <a:r>
-              <a:t>Integrated INR currency converter and seasonal monthly indicators (e.g. August - Monsoon, Jan - Winter).</a:t>
+              <a:t>Displays climate and seasonal tags next to travel months (e.g., August - Monsoon, January - Winter Freeze warnings).</a:t>
             </a:r>
           </a:p>
         </p:txBody>
@@ -5125,6 +5204,9 @@
   <p:clrMapOvr>
     <a:masterClrMapping/>
   </p:clrMapOvr>
+  <p:transition spd="med">
+    <p:push dir="l"/>
+  </p:transition>
 </p:sld>
 </file>
 
@@ -5146,8 +5228,8 @@
         </p:nvSpPr>
         <p:spPr>
           <a:xfrm>
-            <a:off x="731520" y="457200"/>
-            <a:ext cx="10058400" cy="365760"/>
+            <a:off x="731520" y="411480"/>
+            <a:ext cx="7315200" cy="320040"/>
           </a:xfrm>
           <a:prstGeom prst="rect">
             <a:avLst/>
@@ -5169,7 +5251,7 @@
               </a:defRPr>
             </a:pPr>
             <a:r>
-              <a:t>TRIPSPLIT COLLEGE PROJECT</a:t>
+              <a:t>FINANCIAL MANAGEMENT</a:t>
             </a:r>
           </a:p>
         </p:txBody>
@@ -5182,8 +5264,8 @@
         </p:nvSpPr>
         <p:spPr>
           <a:xfrm>
-            <a:off x="731520" y="731520"/>
-            <a:ext cx="10058400" cy="731520"/>
+            <a:off x="731520" y="685800"/>
+            <a:ext cx="10058400" cy="640080"/>
           </a:xfrm>
           <a:prstGeom prst="rect">
             <a:avLst/>
@@ -5199,13 +5281,13 @@
             <a:pPr>
               <a:defRPr sz="2600" b="1">
                 <a:solidFill>
-                  <a:srgbClr val="1F2937"/>
+                  <a:srgbClr val="111827"/>
                 </a:solidFill>
                 <a:latin typeface="Arial"/>
               </a:defRPr>
             </a:pPr>
             <a:r>
-              <a:t>Group Expense Splitter (Ledger)</a:t>
+              <a:t>Group Expense Splitter (Ledger Engine)</a:t>
             </a:r>
           </a:p>
         </p:txBody>
@@ -5218,14 +5300,14 @@
         </p:nvSpPr>
         <p:spPr>
           <a:xfrm>
-            <a:off x="731520" y="1645920"/>
-            <a:ext cx="2560320" cy="4572000"/>
+            <a:off x="731520" y="1554480"/>
+            <a:ext cx="2560320" cy="4663440"/>
           </a:xfrm>
           <a:prstGeom prst="roundRect">
             <a:avLst/>
           </a:prstGeom>
           <a:solidFill>
-            <a:srgbClr val="F3F4F6"/>
+            <a:srgbClr val="FFFFFF"/>
           </a:solidFill>
           <a:ln>
             <a:solidFill>
@@ -5252,14 +5334,14 @@
           <a:lstStyle/>
           <a:p>
             <a:pPr algn="ctr">
-              <a:defRPr sz="1800" b="1">
-                <a:solidFill>
-                  <a:srgbClr val="1F2937"/>
-                </a:solidFill>
-              </a:defRPr>
-            </a:pPr>
-            <a:r>
-              <a:t>💰 Multi-Member Support</a:t>
+              <a:defRPr sz="1700" b="1">
+                <a:solidFill>
+                  <a:srgbClr val="111827"/>
+                </a:solidFill>
+              </a:defRPr>
+            </a:pPr>
+            <a:r>
+              <a:t>Dynamic Group Roster</a:t>
             </a:r>
           </a:p>
           <a:p>
@@ -5274,7 +5356,7 @@
               </a:defRPr>
             </a:pPr>
             <a:r>
-              <a:t>Customizable member list (e.g. Somya, Amit, Priya, Rohan) with dynamic payer dropdowns.</a:t>
+              <a:t>Configurable group member lists with dynamic payer dropdowns and customizable individual shares.</a:t>
             </a:r>
           </a:p>
         </p:txBody>
@@ -5287,14 +5369,14 @@
         </p:nvSpPr>
         <p:spPr>
           <a:xfrm>
-            <a:off x="3429000" y="1645920"/>
-            <a:ext cx="2560320" cy="4572000"/>
+            <a:off x="3429000" y="1554480"/>
+            <a:ext cx="2560320" cy="4663440"/>
           </a:xfrm>
           <a:prstGeom prst="roundRect">
             <a:avLst/>
           </a:prstGeom>
           <a:solidFill>
-            <a:srgbClr val="F3F4F6"/>
+            <a:srgbClr val="FFFFFF"/>
           </a:solidFill>
           <a:ln>
             <a:solidFill>
@@ -5321,14 +5403,14 @@
           <a:lstStyle/>
           <a:p>
             <a:pPr algn="ctr">
-              <a:defRPr sz="1800" b="1">
-                <a:solidFill>
-                  <a:srgbClr val="1F2937"/>
-                </a:solidFill>
-              </a:defRPr>
-            </a:pPr>
-            <a:r>
-              <a:t>💰 Split Options</a:t>
+              <a:defRPr sz="1700" b="1">
+                <a:solidFill>
+                  <a:srgbClr val="111827"/>
+                </a:solidFill>
+              </a:defRPr>
+            </a:pPr>
+            <a:r>
+              <a:t>Equal &amp; Custom Splits</a:t>
             </a:r>
           </a:p>
           <a:p>
@@ -5343,7 +5425,7 @@
               </a:defRPr>
             </a:pPr>
             <a:r>
-              <a:t>Supports Equal splits across all group members or custom per-person amounts.</a:t>
+              <a:t>Supports equal division across group members or specific itemized custom amounts.</a:t>
             </a:r>
           </a:p>
         </p:txBody>
@@ -5356,14 +5438,14 @@
         </p:nvSpPr>
         <p:spPr>
           <a:xfrm>
-            <a:off x="6126480" y="1645920"/>
-            <a:ext cx="2560320" cy="4572000"/>
+            <a:off x="6126480" y="1554480"/>
+            <a:ext cx="2560320" cy="4663440"/>
           </a:xfrm>
           <a:prstGeom prst="roundRect">
             <a:avLst/>
           </a:prstGeom>
           <a:solidFill>
-            <a:srgbClr val="F3F4F6"/>
+            <a:srgbClr val="FFFFFF"/>
           </a:solidFill>
           <a:ln>
             <a:solidFill>
@@ -5390,14 +5472,14 @@
           <a:lstStyle/>
           <a:p>
             <a:pPr algn="ctr">
-              <a:defRPr sz="1800" b="1">
-                <a:solidFill>
-                  <a:srgbClr val="1F2937"/>
-                </a:solidFill>
-              </a:defRPr>
-            </a:pPr>
-            <a:r>
-              <a:t>💰 Smart Settlement</a:t>
+              <a:defRPr sz="1700" b="1">
+                <a:solidFill>
+                  <a:srgbClr val="111827"/>
+                </a:solidFill>
+              </a:defRPr>
+            </a:pPr>
+            <a:r>
+              <a:t>Net Settlement Reduction</a:t>
             </a:r>
           </a:p>
           <a:p>
@@ -5412,7 +5494,7 @@
               </a:defRPr>
             </a:pPr>
             <a:r>
-              <a:t>Calculates net balances to minimize total transactions needed to clear debts.</a:t>
+              <a:t>Calculates net balance matrices to reduce the total number of transactions needed to settle group debts.</a:t>
             </a:r>
           </a:p>
         </p:txBody>
@@ -5425,14 +5507,14 @@
         </p:nvSpPr>
         <p:spPr>
           <a:xfrm>
-            <a:off x="8823960" y="1645920"/>
-            <a:ext cx="2560320" cy="4572000"/>
+            <a:off x="8823960" y="1554480"/>
+            <a:ext cx="2560320" cy="4663440"/>
           </a:xfrm>
           <a:prstGeom prst="roundRect">
             <a:avLst/>
           </a:prstGeom>
           <a:solidFill>
-            <a:srgbClr val="F3F4F6"/>
+            <a:srgbClr val="FFFFFF"/>
           </a:solidFill>
           <a:ln>
             <a:solidFill>
@@ -5459,14 +5541,14 @@
           <a:lstStyle/>
           <a:p>
             <a:pPr algn="ctr">
-              <a:defRPr sz="1800" b="1">
-                <a:solidFill>
-                  <a:srgbClr val="1F2937"/>
-                </a:solidFill>
-              </a:defRPr>
-            </a:pPr>
-            <a:r>
-              <a:t>💰 Analytics Charts</a:t>
+              <a:defRPr sz="1700" b="1">
+                <a:solidFill>
+                  <a:srgbClr val="111827"/>
+                </a:solidFill>
+              </a:defRPr>
+            </a:pPr>
+            <a:r>
+              <a:t>Category Visualizations</a:t>
             </a:r>
           </a:p>
           <a:p>
@@ -5481,7 +5563,7 @@
               </a:defRPr>
             </a:pPr>
             <a:r>
-              <a:t>Visual pie and bar charts for category-wise expense distribution.</a:t>
+              <a:t>Generates category-wise expense pie and bar charts for transparent trip financial audits.</a:t>
             </a:r>
           </a:p>
         </p:txBody>
@@ -5491,6 +5573,9 @@
   <p:clrMapOvr>
     <a:masterClrMapping/>
   </p:clrMapOvr>
+  <p:transition spd="med">
+    <p:push dir="l"/>
+  </p:transition>
 </p:sld>
 </file>
 
@@ -5512,8 +5597,8 @@
         </p:nvSpPr>
         <p:spPr>
           <a:xfrm>
-            <a:off x="731520" y="457200"/>
-            <a:ext cx="10058400" cy="365760"/>
+            <a:off x="731520" y="411480"/>
+            <a:ext cx="7315200" cy="320040"/>
           </a:xfrm>
           <a:prstGeom prst="rect">
             <a:avLst/>
@@ -5535,7 +5620,7 @@
               </a:defRPr>
             </a:pPr>
             <a:r>
-              <a:t>TRIPSPLIT COLLEGE PROJECT</a:t>
+              <a:t>PERFORMANCE OPTIMIZATIONS</a:t>
             </a:r>
           </a:p>
         </p:txBody>
@@ -5548,8 +5633,8 @@
         </p:nvSpPr>
         <p:spPr>
           <a:xfrm>
-            <a:off x="731520" y="731520"/>
-            <a:ext cx="10058400" cy="731520"/>
+            <a:off x="731520" y="685800"/>
+            <a:ext cx="10058400" cy="640080"/>
           </a:xfrm>
           <a:prstGeom prst="rect">
             <a:avLst/>
@@ -5565,13 +5650,13 @@
             <a:pPr>
               <a:defRPr sz="2600" b="1">
                 <a:solidFill>
-                  <a:srgbClr val="1F2937"/>
+                  <a:srgbClr val="111827"/>
                 </a:solidFill>
                 <a:latin typeface="Arial"/>
               </a:defRPr>
             </a:pPr>
             <a:r>
-              <a:t>Deployment &amp; Performance Optimization</a:t>
+              <a:t>Vercel Serverless &amp; Deployment Stability</a:t>
             </a:r>
           </a:p>
         </p:txBody>
@@ -5584,18 +5669,18 @@
         </p:nvSpPr>
         <p:spPr>
           <a:xfrm>
-            <a:off x="731520" y="1645920"/>
-            <a:ext cx="10698480" cy="1005840"/>
+            <a:off x="731520" y="1554480"/>
+            <a:ext cx="10698480" cy="1051560"/>
           </a:xfrm>
           <a:prstGeom prst="roundRect">
             <a:avLst/>
           </a:prstGeom>
           <a:solidFill>
-            <a:srgbClr val="F3F4F6"/>
+            <a:srgbClr val="F8FAFC"/>
           </a:solidFill>
           <a:ln>
             <a:solidFill>
-              <a:srgbClr val="E5E7EB"/>
+              <a:srgbClr val="E2E8F0"/>
             </a:solidFill>
           </a:ln>
         </p:spPr>
@@ -5625,15 +5710,15 @@
               </a:defRPr>
             </a:pPr>
             <a:r>
-              <a:t>⚡ Vercel Serverless Architecture: </a:t>
+              <a:t>Vercel Serverless Architecture: </a:t>
             </a:r>
             <a:r>
               <a:rPr sz="1300" b="0">
                 <a:solidFill>
-                  <a:srgbClr val="1F2937"/>
+                  <a:srgbClr val="111827"/>
                 </a:solidFill>
               </a:rPr>
-              <a:t>Deployed via @vercel/python with API routing (/api/*) and static asset delivery.</a:t>
+              <a:t>Configured using @vercel/python with API route handlers (/api/*) and static asset delivery.</a:t>
             </a:r>
           </a:p>
         </p:txBody>
@@ -5646,18 +5731,18 @@
         </p:nvSpPr>
         <p:spPr>
           <a:xfrm>
-            <a:off x="731520" y="2834640"/>
-            <a:ext cx="10698480" cy="1005840"/>
+            <a:off x="731520" y="2743200"/>
+            <a:ext cx="10698480" cy="1051560"/>
           </a:xfrm>
           <a:prstGeom prst="roundRect">
             <a:avLst/>
           </a:prstGeom>
           <a:solidFill>
-            <a:srgbClr val="F3F4F6"/>
+            <a:srgbClr val="F8FAFC"/>
           </a:solidFill>
           <a:ln>
             <a:solidFill>
-              <a:srgbClr val="E5E7EB"/>
+              <a:srgbClr val="E2E8F0"/>
             </a:solidFill>
           </a:ln>
         </p:spPr>
@@ -5687,15 +5772,15 @@
               </a:defRPr>
             </a:pPr>
             <a:r>
-              <a:t>⚡ Sub-3s Response Capping: </a:t>
+              <a:t>Strict 3-Second Timeout Capping: </a:t>
             </a:r>
             <a:r>
               <a:rPr sz="1300" b="0">
                 <a:solidFill>
-                  <a:srgbClr val="1F2937"/>
+                  <a:srgbClr val="111827"/>
                 </a:solidFill>
               </a:rPr>
-              <a:t>Strict 3-second HTTP timeouts across external calls eliminate Vercel serverless function invocation failures.</a:t>
+              <a:t>Capped HTTP timeouts across external API calls to guarantee complete response execution within Vercel serverless limits.</a:t>
             </a:r>
           </a:p>
         </p:txBody>
@@ -5708,18 +5793,18 @@
         </p:nvSpPr>
         <p:spPr>
           <a:xfrm>
-            <a:off x="731520" y="4023360"/>
-            <a:ext cx="10698480" cy="1005840"/>
+            <a:off x="731520" y="3931920"/>
+            <a:ext cx="10698480" cy="1051560"/>
           </a:xfrm>
           <a:prstGeom prst="roundRect">
             <a:avLst/>
           </a:prstGeom>
           <a:solidFill>
-            <a:srgbClr val="F3F4F6"/>
+            <a:srgbClr val="F8FAFC"/>
           </a:solidFill>
           <a:ln>
             <a:solidFill>
-              <a:srgbClr val="E5E7EB"/>
+              <a:srgbClr val="E2E8F0"/>
             </a:solidFill>
           </a:ln>
         </p:spPr>
@@ -5749,15 +5834,15 @@
               </a:defRPr>
             </a:pPr>
             <a:r>
-              <a:t>⚡ Read-Only Filesystem Resilience: </a:t>
+              <a:t>Read-Only Filesystem Handling: </a:t>
             </a:r>
             <a:r>
               <a:rPr sz="1300" b="0">
                 <a:solidFill>
-                  <a:srgbClr val="1F2937"/>
+                  <a:srgbClr val="111827"/>
                 </a:solidFill>
               </a:rPr>
-              <a:t>Safe handling of serverless read-only filesystems using /tmp transient caching.</a:t>
+              <a:t>Safely catches file creation errors and redirects transient database operations to /tmp/tripsplit_cache.db.</a:t>
             </a:r>
           </a:p>
         </p:txBody>
@@ -5770,18 +5855,18 @@
         </p:nvSpPr>
         <p:spPr>
           <a:xfrm>
-            <a:off x="731520" y="5212080"/>
-            <a:ext cx="10698480" cy="1005840"/>
+            <a:off x="731520" y="5120640"/>
+            <a:ext cx="10698480" cy="1051560"/>
           </a:xfrm>
           <a:prstGeom prst="roundRect">
             <a:avLst/>
           </a:prstGeom>
           <a:solidFill>
-            <a:srgbClr val="F3F4F6"/>
+            <a:srgbClr val="F8FAFC"/>
           </a:solidFill>
           <a:ln>
             <a:solidFill>
-              <a:srgbClr val="E5E7EB"/>
+              <a:srgbClr val="E2E8F0"/>
             </a:solidFill>
           </a:ln>
         </p:spPr>
@@ -5811,15 +5896,15 @@
               </a:defRPr>
             </a:pPr>
             <a:r>
-              <a:t>⚡ Client-Side Caching: </a:t>
+              <a:t>Client Storage Persistence: </a:t>
             </a:r>
             <a:r>
               <a:rPr sz="1300" b="0">
                 <a:solidFill>
-                  <a:srgbClr val="1F2937"/>
+                  <a:srgbClr val="111827"/>
                 </a:solidFill>
               </a:rPr>
-              <a:t>Uses LocalStorage to persist user preferences, group members, and saved venue bookmarks.</a:t>
+              <a:t>Leverages browser LocalStorage to store active user preferences, group rosters, and saved venue bookmarks.</a:t>
             </a:r>
           </a:p>
         </p:txBody>
@@ -5829,6 +5914,9 @@
   <p:clrMapOvr>
     <a:masterClrMapping/>
   </p:clrMapOvr>
+  <p:transition spd="med">
+    <p:push dir="l"/>
+  </p:transition>
 </p:sld>
 </file>
 
@@ -5850,8 +5938,8 @@
         </p:nvSpPr>
         <p:spPr>
           <a:xfrm>
-            <a:off x="731520" y="457200"/>
-            <a:ext cx="10058400" cy="365760"/>
+            <a:off x="731520" y="411480"/>
+            <a:ext cx="7315200" cy="320040"/>
           </a:xfrm>
           <a:prstGeom prst="rect">
             <a:avLst/>
@@ -5873,7 +5961,7 @@
               </a:defRPr>
             </a:pPr>
             <a:r>
-              <a:t>TRIPSPLIT COLLEGE PROJECT</a:t>
+              <a:t>PROJECT ROADMAP</a:t>
             </a:r>
           </a:p>
         </p:txBody>
@@ -5886,8 +5974,8 @@
         </p:nvSpPr>
         <p:spPr>
           <a:xfrm>
-            <a:off x="731520" y="731520"/>
-            <a:ext cx="10058400" cy="731520"/>
+            <a:off x="731520" y="685800"/>
+            <a:ext cx="10058400" cy="640080"/>
           </a:xfrm>
           <a:prstGeom prst="rect">
             <a:avLst/>
@@ -5903,13 +5991,13 @@
             <a:pPr>
               <a:defRPr sz="2600" b="1">
                 <a:solidFill>
-                  <a:srgbClr val="1F2937"/>
+                  <a:srgbClr val="111827"/>
                 </a:solidFill>
                 <a:latin typeface="Arial"/>
               </a:defRPr>
             </a:pPr>
             <a:r>
-              <a:t>Future Enhancements</a:t>
+              <a:t>Future Enhancements &amp; Roadmap</a:t>
             </a:r>
           </a:p>
         </p:txBody>
@@ -5922,18 +6010,18 @@
         </p:nvSpPr>
         <p:spPr>
           <a:xfrm>
-            <a:off x="731520" y="1645920"/>
-            <a:ext cx="5120640" cy="2011680"/>
+            <a:off x="731520" y="1554480"/>
+            <a:ext cx="5120640" cy="2103120"/>
           </a:xfrm>
           <a:prstGeom prst="roundRect">
             <a:avLst/>
           </a:prstGeom>
           <a:solidFill>
-            <a:srgbClr val="F3F4F6"/>
+            <a:srgbClr val="FFFFFF"/>
           </a:solidFill>
           <a:ln>
             <a:solidFill>
-              <a:srgbClr val="E5E7EB"/>
+              <a:srgbClr val="7C3AED"/>
             </a:solidFill>
           </a:ln>
         </p:spPr>
@@ -5963,7 +6051,7 @@
               </a:defRPr>
             </a:pPr>
             <a:r>
-              <a:t>🚀  Live IRCTC / Airline API Integration</a:t>
+              <a:t>Live IRCTC &amp; Airline API Integration</a:t>
             </a:r>
           </a:p>
           <a:p>
@@ -5973,12 +6061,12 @@
               </a:spcBef>
               <a:defRPr sz="1300">
                 <a:solidFill>
-                  <a:srgbClr val="1F2937"/>
-                </a:solidFill>
-              </a:defRPr>
-            </a:pPr>
-            <a:r>
-              <a:t>Direct real-time train seat availability and live flight ticket pricing.</a:t>
+                  <a:srgbClr val="111827"/>
+                </a:solidFill>
+              </a:defRPr>
+            </a:pPr>
+            <a:r>
+              <a:t>Direct real-time train seat availability and live flight ticket price integration.</a:t>
             </a:r>
           </a:p>
         </p:txBody>
@@ -5991,18 +6079,18 @@
         </p:nvSpPr>
         <p:spPr>
           <a:xfrm>
-            <a:off x="6126480" y="1645920"/>
-            <a:ext cx="5120640" cy="2011680"/>
+            <a:off x="6126480" y="1554480"/>
+            <a:ext cx="5120640" cy="2103120"/>
           </a:xfrm>
           <a:prstGeom prst="roundRect">
             <a:avLst/>
           </a:prstGeom>
           <a:solidFill>
-            <a:srgbClr val="F3F4F6"/>
+            <a:srgbClr val="FFFFFF"/>
           </a:solidFill>
           <a:ln>
             <a:solidFill>
-              <a:srgbClr val="E5E7EB"/>
+              <a:srgbClr val="7C3AED"/>
             </a:solidFill>
           </a:ln>
         </p:spPr>
@@ -6032,7 +6120,7 @@
               </a:defRPr>
             </a:pPr>
             <a:r>
-              <a:t>🚀  Collaborative Trip Planning</a:t>
+              <a:t>Collaborative Real-Time Editing</a:t>
             </a:r>
           </a:p>
           <a:p>
@@ -6042,12 +6130,12 @@
               </a:spcBef>
               <a:defRPr sz="1300">
                 <a:solidFill>
-                  <a:srgbClr val="1F2937"/>
-                </a:solidFill>
-              </a:defRPr>
-            </a:pPr>
-            <a:r>
-              <a:t>Real-time multi-user editing via WebSockets for group travel decision making.</a:t>
+                  <a:srgbClr val="111827"/>
+                </a:solidFill>
+              </a:defRPr>
+            </a:pPr>
+            <a:r>
+              <a:t>WebSocket-enabled collaborative trip planning allowing group members to edit itineraries simultaneously.</a:t>
             </a:r>
           </a:p>
         </p:txBody>
@@ -6060,18 +6148,18 @@
         </p:nvSpPr>
         <p:spPr>
           <a:xfrm>
-            <a:off x="731520" y="4023360"/>
-            <a:ext cx="5120640" cy="2011680"/>
+            <a:off x="731520" y="3931920"/>
+            <a:ext cx="5120640" cy="2103120"/>
           </a:xfrm>
           <a:prstGeom prst="roundRect">
             <a:avLst/>
           </a:prstGeom>
           <a:solidFill>
-            <a:srgbClr val="F3F4F6"/>
+            <a:srgbClr val="FFFFFF"/>
           </a:solidFill>
           <a:ln>
             <a:solidFill>
-              <a:srgbClr val="E5E7EB"/>
+              <a:srgbClr val="7C3AED"/>
             </a:solidFill>
           </a:ln>
         </p:spPr>
@@ -6101,7 +6189,7 @@
               </a:defRPr>
             </a:pPr>
             <a:r>
-              <a:t>🚀  AI Personalization</a:t>
+              <a:t>AI-Driven Personalization</a:t>
             </a:r>
           </a:p>
           <a:p>
@@ -6111,7 +6199,7 @@
               </a:spcBef>
               <a:defRPr sz="1300">
                 <a:solidFill>
-                  <a:srgbClr val="1F2937"/>
+                  <a:srgbClr val="111827"/>
                 </a:solidFill>
               </a:defRPr>
             </a:pPr>
@@ -6129,18 +6217,18 @@
         </p:nvSpPr>
         <p:spPr>
           <a:xfrm>
-            <a:off x="6126480" y="4023360"/>
-            <a:ext cx="5120640" cy="2011680"/>
+            <a:off x="6126480" y="3931920"/>
+            <a:ext cx="5120640" cy="2103120"/>
           </a:xfrm>
           <a:prstGeom prst="roundRect">
             <a:avLst/>
           </a:prstGeom>
           <a:solidFill>
-            <a:srgbClr val="F3F4F6"/>
+            <a:srgbClr val="FFFFFF"/>
           </a:solidFill>
           <a:ln>
             <a:solidFill>
-              <a:srgbClr val="E5E7EB"/>
+              <a:srgbClr val="7C3AED"/>
             </a:solidFill>
           </a:ln>
         </p:spPr>
@@ -6170,7 +6258,7 @@
               </a:defRPr>
             </a:pPr>
             <a:r>
-              <a:t>🚀  Native Mobile App</a:t>
+              <a:t>Native Mobile Application</a:t>
             </a:r>
           </a:p>
           <a:p>
@@ -6180,12 +6268,12 @@
               </a:spcBef>
               <a:defRPr sz="1300">
                 <a:solidFill>
-                  <a:srgbClr val="1F2937"/>
-                </a:solidFill>
-              </a:defRPr>
-            </a:pPr>
-            <a:r>
-              <a:t>Cross-platform mobile implementation using React Native / Flutter.</a:t>
+                  <a:srgbClr val="111827"/>
+                </a:solidFill>
+              </a:defRPr>
+            </a:pPr>
+            <a:r>
+              <a:t>Cross-platform mobile application built with React Native / Flutter for offline field access.</a:t>
             </a:r>
           </a:p>
         </p:txBody>
@@ -6195,6 +6283,9 @@
   <p:clrMapOvr>
     <a:masterClrMapping/>
   </p:clrMapOvr>
+  <p:transition spd="med">
+    <p:push dir="l"/>
+  </p:transition>
 </p:sld>
 </file>
 

</xml_diff>

<commit_message>
feat: add interactive HTML presentation deck static/presentation.html and overhaul PPTX design
</commit_message>
<xml_diff>
--- a/TripSplit_Presentation.pptx
+++ b/TripSplit_Presentation.pptx
@@ -3149,7 +3149,7 @@
         <p:spPr>
           <a:xfrm>
             <a:off x="731520" y="2011680"/>
-            <a:ext cx="109728" cy="2926080"/>
+            <a:ext cx="137160" cy="2926080"/>
           </a:xfrm>
           <a:prstGeom prst="rect">
             <a:avLst/>
@@ -3185,13 +3185,67 @@
       </p:sp>
       <p:sp>
         <p:nvSpPr>
-          <p:cNvPr id="4" name="TextBox 3"/>
+          <p:cNvPr id="4" name="Rounded Rectangle 3"/>
+          <p:cNvSpPr/>
+          <p:nvPr/>
+        </p:nvSpPr>
+        <p:spPr>
+          <a:xfrm>
+            <a:off x="1097280" y="1554480"/>
+            <a:ext cx="3474720" cy="347472"/>
+          </a:xfrm>
+          <a:prstGeom prst="roundRect">
+            <a:avLst/>
+          </a:prstGeom>
+          <a:solidFill>
+            <a:srgbClr val="1E293B"/>
+          </a:solidFill>
+          <a:ln>
+            <a:solidFill>
+              <a:srgbClr val="7C3AED"/>
+            </a:solidFill>
+          </a:ln>
+        </p:spPr>
+        <p:style>
+          <a:lnRef idx="1">
+            <a:schemeClr val="accent1"/>
+          </a:lnRef>
+          <a:fillRef idx="3">
+            <a:schemeClr val="accent1"/>
+          </a:fillRef>
+          <a:effectRef idx="2">
+            <a:schemeClr val="accent1"/>
+          </a:effectRef>
+          <a:fontRef idx="minor">
+            <a:schemeClr val="lt1"/>
+          </a:fontRef>
+        </p:style>
+        <p:txBody>
+          <a:bodyPr rtlCol="0" anchor="ctr"/>
+          <a:lstStyle/>
+          <a:p>
+            <a:pPr algn="ctr">
+              <a:defRPr sz="1000" b="1">
+                <a:solidFill>
+                  <a:srgbClr val="10B981"/>
+                </a:solidFill>
+              </a:defRPr>
+            </a:pPr>
+            <a:r>
+              <a:t>COLLEGE FINAL PROJECT PRESENTATION</a:t>
+            </a:r>
+          </a:p>
+        </p:txBody>
+      </p:sp>
+      <p:sp>
+        <p:nvSpPr>
+          <p:cNvPr id="5" name="TextBox 4"/>
           <p:cNvSpPr txBox="1"/>
           <p:nvPr/>
         </p:nvSpPr>
         <p:spPr>
           <a:xfrm>
-            <a:off x="1097280" y="1828800"/>
+            <a:off x="1097280" y="2011680"/>
             <a:ext cx="10058400" cy="3291840"/>
           </a:xfrm>
           <a:prstGeom prst="rect">
@@ -3206,7 +3260,7 @@
           <a:lstStyle/>
           <a:p>
             <a:pPr>
-              <a:defRPr sz="5600" b="1">
+              <a:defRPr sz="5400" b="1">
                 <a:solidFill>
                   <a:srgbClr val="7C3AED"/>
                 </a:solidFill>
@@ -3214,7 +3268,7 @@
               </a:defRPr>
             </a:pPr>
             <a:r>
-              <a:t>TRIPSPLIT</a:t>
+              <a:t>TRIPSPLIT OPTIMIZER</a:t>
             </a:r>
           </a:p>
           <a:p>
@@ -3229,7 +3283,7 @@
               </a:defRPr>
             </a:pPr>
             <a:r>
-              <a:t>Student Travel Budget &amp; Route Optimizer</a:t>
+              <a:t>Student Travel Budget &amp; Route Optimization Engine</a:t>
             </a:r>
           </a:p>
           <a:p>
@@ -3250,7 +3304,7 @@
           <a:p>
             <a:pPr>
               <a:spcBef>
-                <a:spcPts val="3200"/>
+                <a:spcPts val="2800"/>
               </a:spcBef>
               <a:defRPr sz="1400" b="1">
                 <a:solidFill>
@@ -3259,7 +3313,7 @@
               </a:defRPr>
             </a:pPr>
             <a:r>
-              <a:t>Computer Science &amp; Engineering Final Project</a:t>
+              <a:t>Department of Computer Science &amp; Engineering</a:t>
             </a:r>
           </a:p>
         </p:txBody>
@@ -3330,13 +3384,67 @@
       </p:sp>
       <p:sp>
         <p:nvSpPr>
-          <p:cNvPr id="3" name="TextBox 2"/>
+          <p:cNvPr id="3" name="Rounded Rectangle 2"/>
+          <p:cNvSpPr/>
+          <p:nvPr/>
+        </p:nvSpPr>
+        <p:spPr>
+          <a:xfrm>
+            <a:off x="1097280" y="1645920"/>
+            <a:ext cx="2926080" cy="347472"/>
+          </a:xfrm>
+          <a:prstGeom prst="roundRect">
+            <a:avLst/>
+          </a:prstGeom>
+          <a:solidFill>
+            <a:srgbClr val="1E293B"/>
+          </a:solidFill>
+          <a:ln>
+            <a:solidFill>
+              <a:srgbClr val="10B981"/>
+            </a:solidFill>
+          </a:ln>
+        </p:spPr>
+        <p:style>
+          <a:lnRef idx="1">
+            <a:schemeClr val="accent1"/>
+          </a:lnRef>
+          <a:fillRef idx="3">
+            <a:schemeClr val="accent1"/>
+          </a:fillRef>
+          <a:effectRef idx="2">
+            <a:schemeClr val="accent1"/>
+          </a:effectRef>
+          <a:fontRef idx="minor">
+            <a:schemeClr val="lt1"/>
+          </a:fontRef>
+        </p:style>
+        <p:txBody>
+          <a:bodyPr rtlCol="0" anchor="ctr"/>
+          <a:lstStyle/>
+          <a:p>
+            <a:pPr algn="ctr">
+              <a:defRPr sz="1000" b="1">
+                <a:solidFill>
+                  <a:srgbClr val="10B981"/>
+                </a:solidFill>
+              </a:defRPr>
+            </a:pPr>
+            <a:r>
+              <a:t>PROJECT DELIVERABLE COMPLETE</a:t>
+            </a:r>
+          </a:p>
+        </p:txBody>
+      </p:sp>
+      <p:sp>
+        <p:nvSpPr>
+          <p:cNvPr id="4" name="TextBox 3"/>
           <p:cNvSpPr txBox="1"/>
           <p:nvPr/>
         </p:nvSpPr>
         <p:spPr>
           <a:xfrm>
-            <a:off x="1097280" y="2011680"/>
+            <a:off x="1097280" y="2103120"/>
             <a:ext cx="10058400" cy="3200400"/>
           </a:xfrm>
           <a:prstGeom prst="rect">
@@ -3351,7 +3459,7 @@
           <a:lstStyle/>
           <a:p>
             <a:pPr>
-              <a:defRPr sz="5200" b="1">
+              <a:defRPr sz="5400" b="1">
                 <a:solidFill>
                   <a:srgbClr val="7C3AED"/>
                 </a:solidFill>
@@ -3389,7 +3497,7 @@
               </a:defRPr>
             </a:pPr>
             <a:r>
-              <a:t>Questions &amp; Project Discussion</a:t>
+              <a:t>Questions &amp; Project Discussion Welcome</a:t>
             </a:r>
           </a:p>
         </p:txBody>
@@ -3417,96 +3525,24 @@
       <p:grpSpPr/>
       <p:sp>
         <p:nvSpPr>
-          <p:cNvPr id="2" name="TextBox 1"/>
-          <p:cNvSpPr txBox="1"/>
-          <p:nvPr/>
-        </p:nvSpPr>
-        <p:spPr>
-          <a:xfrm>
-            <a:off x="731520" y="411480"/>
-            <a:ext cx="7315200" cy="320040"/>
+          <p:cNvPr id="2" name="Rectangle 1"/>
+          <p:cNvSpPr/>
+          <p:nvPr/>
+        </p:nvSpPr>
+        <p:spPr>
+          <a:xfrm>
+            <a:off x="0" y="0"/>
+            <a:ext cx="12191695" cy="1097280"/>
           </a:xfrm>
           <a:prstGeom prst="rect">
             <a:avLst/>
           </a:prstGeom>
-          <a:noFill/>
-        </p:spPr>
-        <p:txBody>
-          <a:bodyPr wrap="square">
-            <a:spAutoFit/>
-          </a:bodyPr>
-          <a:lstStyle/>
-          <a:p>
-            <a:pPr>
-              <a:defRPr sz="1000" b="1">
-                <a:solidFill>
-                  <a:srgbClr val="7C3AED"/>
-                </a:solidFill>
-                <a:latin typeface="Arial"/>
-              </a:defRPr>
-            </a:pPr>
-            <a:r>
-              <a:t>USER FRICTION &amp; NEED ANALYSIS</a:t>
-            </a:r>
-          </a:p>
-        </p:txBody>
-      </p:sp>
-      <p:sp>
-        <p:nvSpPr>
-          <p:cNvPr id="3" name="TextBox 2"/>
-          <p:cNvSpPr txBox="1"/>
-          <p:nvPr/>
-        </p:nvSpPr>
-        <p:spPr>
-          <a:xfrm>
-            <a:off x="731520" y="685800"/>
-            <a:ext cx="10058400" cy="640080"/>
-          </a:xfrm>
-          <a:prstGeom prst="rect">
-            <a:avLst/>
-          </a:prstGeom>
-          <a:noFill/>
-        </p:spPr>
-        <p:txBody>
-          <a:bodyPr wrap="square">
-            <a:spAutoFit/>
-          </a:bodyPr>
-          <a:lstStyle/>
-          <a:p>
-            <a:pPr>
-              <a:defRPr sz="2600" b="1">
-                <a:solidFill>
-                  <a:srgbClr val="111827"/>
-                </a:solidFill>
-                <a:latin typeface="Arial"/>
-              </a:defRPr>
-            </a:pPr>
-            <a:r>
-              <a:t>Problem Statement &amp; Industry Challenges</a:t>
-            </a:r>
-          </a:p>
-        </p:txBody>
-      </p:sp>
-      <p:sp>
-        <p:nvSpPr>
-          <p:cNvPr id="4" name="Rounded Rectangle 3"/>
-          <p:cNvSpPr/>
-          <p:nvPr/>
-        </p:nvSpPr>
-        <p:spPr>
-          <a:xfrm>
-            <a:off x="731520" y="1554480"/>
-            <a:ext cx="5120640" cy="2103120"/>
-          </a:xfrm>
-          <a:prstGeom prst="roundRect">
-            <a:avLst/>
-          </a:prstGeom>
-          <a:solidFill>
-            <a:srgbClr val="FFFFFF"/>
+          <a:solidFill>
+            <a:srgbClr val="F1F5F9"/>
           </a:solidFill>
           <a:ln>
             <a:solidFill>
-              <a:srgbClr val="E2E8F0"/>
+              <a:srgbClr val="CBD5E1"/>
             </a:solidFill>
           </a:ln>
         </p:spPr>
@@ -3525,18 +3561,194 @@
           </a:fontRef>
         </p:style>
         <p:txBody>
+          <a:bodyPr rtlCol="0" anchor="ctr"/>
+          <a:lstStyle/>
+          <a:p>
+            <a:pPr algn="ctr"/>
+          </a:p>
+        </p:txBody>
+      </p:sp>
+      <p:sp>
+        <p:nvSpPr>
+          <p:cNvPr id="3" name="Rectangle 2"/>
+          <p:cNvSpPr/>
+          <p:nvPr/>
+        </p:nvSpPr>
+        <p:spPr>
+          <a:xfrm>
+            <a:off x="0" y="0"/>
+            <a:ext cx="137160" cy="1097280"/>
+          </a:xfrm>
+          <a:prstGeom prst="rect">
+            <a:avLst/>
+          </a:prstGeom>
+          <a:solidFill>
+            <a:srgbClr val="7C3AED"/>
+          </a:solidFill>
+          <a:ln>
+            <a:noFill/>
+          </a:ln>
+        </p:spPr>
+        <p:style>
+          <a:lnRef idx="1">
+            <a:schemeClr val="accent1"/>
+          </a:lnRef>
+          <a:fillRef idx="3">
+            <a:schemeClr val="accent1"/>
+          </a:fillRef>
+          <a:effectRef idx="2">
+            <a:schemeClr val="accent1"/>
+          </a:effectRef>
+          <a:fontRef idx="minor">
+            <a:schemeClr val="lt1"/>
+          </a:fontRef>
+        </p:style>
+        <p:txBody>
+          <a:bodyPr rtlCol="0" anchor="ctr"/>
+          <a:lstStyle/>
+          <a:p>
+            <a:pPr algn="ctr"/>
+          </a:p>
+        </p:txBody>
+      </p:sp>
+      <p:sp>
+        <p:nvSpPr>
+          <p:cNvPr id="4" name="Rounded Rectangle 3"/>
+          <p:cNvSpPr/>
+          <p:nvPr/>
+        </p:nvSpPr>
+        <p:spPr>
+          <a:xfrm>
+            <a:off x="731520" y="164592"/>
+            <a:ext cx="2926080" cy="292608"/>
+          </a:xfrm>
+          <a:prstGeom prst="roundRect">
+            <a:avLst/>
+          </a:prstGeom>
+          <a:solidFill>
+            <a:srgbClr val="7C3AED"/>
+          </a:solidFill>
+          <a:ln>
+            <a:noFill/>
+          </a:ln>
+        </p:spPr>
+        <p:style>
+          <a:lnRef idx="1">
+            <a:schemeClr val="accent1"/>
+          </a:lnRef>
+          <a:fillRef idx="3">
+            <a:schemeClr val="accent1"/>
+          </a:fillRef>
+          <a:effectRef idx="2">
+            <a:schemeClr val="accent1"/>
+          </a:effectRef>
+          <a:fontRef idx="minor">
+            <a:schemeClr val="lt1"/>
+          </a:fontRef>
+        </p:style>
+        <p:txBody>
+          <a:bodyPr rtlCol="0" anchor="ctr"/>
+          <a:lstStyle/>
+          <a:p>
+            <a:pPr algn="ctr">
+              <a:defRPr sz="1000" b="1">
+                <a:solidFill>
+                  <a:srgbClr val="FFFFFF"/>
+                </a:solidFill>
+              </a:defRPr>
+            </a:pPr>
+            <a:r>
+              <a:t>PROBLEM STATEMENT</a:t>
+            </a:r>
+          </a:p>
+        </p:txBody>
+      </p:sp>
+      <p:sp>
+        <p:nvSpPr>
+          <p:cNvPr id="5" name="TextBox 4"/>
+          <p:cNvSpPr txBox="1"/>
+          <p:nvPr/>
+        </p:nvSpPr>
+        <p:spPr>
+          <a:xfrm>
+            <a:off x="731520" y="502920"/>
+            <a:ext cx="10515600" cy="502920"/>
+          </a:xfrm>
+          <a:prstGeom prst="rect">
+            <a:avLst/>
+          </a:prstGeom>
+          <a:noFill/>
+        </p:spPr>
+        <p:txBody>
+          <a:bodyPr wrap="none">
+            <a:spAutoFit/>
+          </a:bodyPr>
+          <a:lstStyle/>
+          <a:p>
+            <a:pPr>
+              <a:defRPr sz="2400" b="1">
+                <a:solidFill>
+                  <a:srgbClr val="0F172A"/>
+                </a:solidFill>
+                <a:latin typeface="Arial"/>
+              </a:defRPr>
+            </a:pPr>
+            <a:r>
+              <a:t>Travel Planning &amp; Financial Challenges</a:t>
+            </a:r>
+          </a:p>
+        </p:txBody>
+      </p:sp>
+      <p:sp>
+        <p:nvSpPr>
+          <p:cNvPr id="6" name="Rounded Rectangle 5"/>
+          <p:cNvSpPr/>
+          <p:nvPr/>
+        </p:nvSpPr>
+        <p:spPr>
+          <a:xfrm>
+            <a:off x="731520" y="1463040"/>
+            <a:ext cx="5120640" cy="2148840"/>
+          </a:xfrm>
+          <a:prstGeom prst="roundRect">
+            <a:avLst/>
+          </a:prstGeom>
+          <a:solidFill>
+            <a:srgbClr val="FFFFFF"/>
+          </a:solidFill>
+          <a:ln>
+            <a:solidFill>
+              <a:srgbClr val="CBD5E1"/>
+            </a:solidFill>
+          </a:ln>
+        </p:spPr>
+        <p:style>
+          <a:lnRef idx="1">
+            <a:schemeClr val="accent1"/>
+          </a:lnRef>
+          <a:fillRef idx="3">
+            <a:schemeClr val="accent1"/>
+          </a:fillRef>
+          <a:effectRef idx="2">
+            <a:schemeClr val="accent1"/>
+          </a:effectRef>
+          <a:fontRef idx="minor">
+            <a:schemeClr val="lt1"/>
+          </a:fontRef>
+        </p:style>
+        <p:txBody>
           <a:bodyPr rtlCol="0" anchor="ctr" wrap="square"/>
           <a:lstStyle/>
           <a:p>
             <a:pPr algn="ctr">
               <a:defRPr sz="1700" b="1">
                 <a:solidFill>
-                  <a:srgbClr val="111827"/>
+                  <a:srgbClr val="E11D48"/>
                 </a:solidFill>
               </a:defRPr>
             </a:pPr>
             <a:r>
-              <a:t>Budget Allocation Confusion</a:t>
+              <a:t>  Budget Allocation Confusion</a:t>
             </a:r>
           </a:p>
           <a:p>
@@ -3546,37 +3758,35 @@
               </a:spcBef>
               <a:defRPr sz="1300">
                 <a:solidFill>
-                  <a:srgbClr val="6B7280"/>
+                  <a:srgbClr val="475569"/>
                 </a:solidFill>
               </a:defRPr>
             </a:pPr>
             <a:r>
-              <a:t>Students struggle to distinguish between total trip budgets vs per-person shares, leading to critical miscalculations during planning.</a:t>
-            </a:r>
-          </a:p>
-        </p:txBody>
-      </p:sp>
-      <p:sp>
-        <p:nvSpPr>
-          <p:cNvPr id="5" name="Rounded Rectangle 4"/>
+              <a:t>Students struggle to distinguish between total group budgets vs per-person shares, leading to critical miscalculations during initial planning.</a:t>
+            </a:r>
+          </a:p>
+        </p:txBody>
+      </p:sp>
+      <p:sp>
+        <p:nvSpPr>
+          <p:cNvPr id="7" name="Rectangle 6"/>
           <p:cNvSpPr/>
           <p:nvPr/>
         </p:nvSpPr>
         <p:spPr>
           <a:xfrm>
-            <a:off x="6126480" y="1554480"/>
-            <a:ext cx="5120640" cy="2103120"/>
-          </a:xfrm>
-          <a:prstGeom prst="roundRect">
-            <a:avLst/>
-          </a:prstGeom>
-          <a:solidFill>
-            <a:srgbClr val="FFFFFF"/>
+            <a:off x="731520" y="1463040"/>
+            <a:ext cx="109728" cy="2148840"/>
+          </a:xfrm>
+          <a:prstGeom prst="rect">
+            <a:avLst/>
+          </a:prstGeom>
+          <a:solidFill>
+            <a:srgbClr val="E11D48"/>
           </a:solidFill>
           <a:ln>
-            <a:solidFill>
-              <a:srgbClr val="E2E8F0"/>
-            </a:solidFill>
+            <a:noFill/>
           </a:ln>
         </p:spPr>
         <p:style>
@@ -3594,18 +3804,63 @@
           </a:fontRef>
         </p:style>
         <p:txBody>
+          <a:bodyPr rtlCol="0" anchor="ctr"/>
+          <a:lstStyle/>
+          <a:p>
+            <a:pPr algn="ctr"/>
+          </a:p>
+        </p:txBody>
+      </p:sp>
+      <p:sp>
+        <p:nvSpPr>
+          <p:cNvPr id="8" name="Rounded Rectangle 7"/>
+          <p:cNvSpPr/>
+          <p:nvPr/>
+        </p:nvSpPr>
+        <p:spPr>
+          <a:xfrm>
+            <a:off x="6126480" y="1463040"/>
+            <a:ext cx="5120640" cy="2148840"/>
+          </a:xfrm>
+          <a:prstGeom prst="roundRect">
+            <a:avLst/>
+          </a:prstGeom>
+          <a:solidFill>
+            <a:srgbClr val="FFFFFF"/>
+          </a:solidFill>
+          <a:ln>
+            <a:solidFill>
+              <a:srgbClr val="CBD5E1"/>
+            </a:solidFill>
+          </a:ln>
+        </p:spPr>
+        <p:style>
+          <a:lnRef idx="1">
+            <a:schemeClr val="accent1"/>
+          </a:lnRef>
+          <a:fillRef idx="3">
+            <a:schemeClr val="accent1"/>
+          </a:fillRef>
+          <a:effectRef idx="2">
+            <a:schemeClr val="accent1"/>
+          </a:effectRef>
+          <a:fontRef idx="minor">
+            <a:schemeClr val="lt1"/>
+          </a:fontRef>
+        </p:style>
+        <p:txBody>
           <a:bodyPr rtlCol="0" anchor="ctr" wrap="square"/>
           <a:lstStyle/>
           <a:p>
             <a:pPr algn="ctr">
               <a:defRPr sz="1700" b="1">
                 <a:solidFill>
-                  <a:srgbClr val="111827"/>
+                  <a:srgbClr val="E11D48"/>
                 </a:solidFill>
               </a:defRPr>
             </a:pPr>
             <a:r>
-              <a:t>High Manual Research Effort</a:t>
+              <a:t>  High Manual Research Effort</a:t>
             </a:r>
           </a:p>
           <a:p>
@@ -3615,7 +3870,7 @@
               </a:spcBef>
               <a:defRPr sz="1300">
                 <a:solidFill>
-                  <a:srgbClr val="6B7280"/>
+                  <a:srgbClr val="475569"/>
                 </a:solidFill>
               </a:defRPr>
             </a:pPr>
@@ -3627,25 +3882,23 @@
       </p:sp>
       <p:sp>
         <p:nvSpPr>
-          <p:cNvPr id="6" name="Rounded Rectangle 5"/>
+          <p:cNvPr id="9" name="Rectangle 8"/>
           <p:cNvSpPr/>
           <p:nvPr/>
         </p:nvSpPr>
         <p:spPr>
           <a:xfrm>
-            <a:off x="731520" y="3931920"/>
-            <a:ext cx="5120640" cy="2103120"/>
-          </a:xfrm>
-          <a:prstGeom prst="roundRect">
-            <a:avLst/>
-          </a:prstGeom>
-          <a:solidFill>
-            <a:srgbClr val="FFFFFF"/>
+            <a:off x="6126480" y="1463040"/>
+            <a:ext cx="109728" cy="2148840"/>
+          </a:xfrm>
+          <a:prstGeom prst="rect">
+            <a:avLst/>
+          </a:prstGeom>
+          <a:solidFill>
+            <a:srgbClr val="E11D48"/>
           </a:solidFill>
           <a:ln>
-            <a:solidFill>
-              <a:srgbClr val="E2E8F0"/>
-            </a:solidFill>
+            <a:noFill/>
           </a:ln>
         </p:spPr>
         <p:style>
@@ -3663,18 +3916,63 @@
           </a:fontRef>
         </p:style>
         <p:txBody>
+          <a:bodyPr rtlCol="0" anchor="ctr"/>
+          <a:lstStyle/>
+          <a:p>
+            <a:pPr algn="ctr"/>
+          </a:p>
+        </p:txBody>
+      </p:sp>
+      <p:sp>
+        <p:nvSpPr>
+          <p:cNvPr id="10" name="Rounded Rectangle 9"/>
+          <p:cNvSpPr/>
+          <p:nvPr/>
+        </p:nvSpPr>
+        <p:spPr>
+          <a:xfrm>
+            <a:off x="731520" y="3931920"/>
+            <a:ext cx="5120640" cy="2148840"/>
+          </a:xfrm>
+          <a:prstGeom prst="roundRect">
+            <a:avLst/>
+          </a:prstGeom>
+          <a:solidFill>
+            <a:srgbClr val="FFFFFF"/>
+          </a:solidFill>
+          <a:ln>
+            <a:solidFill>
+              <a:srgbClr val="CBD5E1"/>
+            </a:solidFill>
+          </a:ln>
+        </p:spPr>
+        <p:style>
+          <a:lnRef idx="1">
+            <a:schemeClr val="accent1"/>
+          </a:lnRef>
+          <a:fillRef idx="3">
+            <a:schemeClr val="accent1"/>
+          </a:fillRef>
+          <a:effectRef idx="2">
+            <a:schemeClr val="accent1"/>
+          </a:effectRef>
+          <a:fontRef idx="minor">
+            <a:schemeClr val="lt1"/>
+          </a:fontRef>
+        </p:style>
+        <p:txBody>
           <a:bodyPr rtlCol="0" anchor="ctr" wrap="square"/>
           <a:lstStyle/>
           <a:p>
             <a:pPr algn="ctr">
               <a:defRPr sz="1700" b="1">
                 <a:solidFill>
-                  <a:srgbClr val="111827"/>
+                  <a:srgbClr val="E11D48"/>
                 </a:solidFill>
               </a:defRPr>
             </a:pPr>
             <a:r>
-              <a:t>Generic Non-Tailored Planners</a:t>
+              <a:t>  Generic Non-Tailored Planners</a:t>
             </a:r>
           </a:p>
           <a:p>
@@ -3684,37 +3982,35 @@
               </a:spcBef>
               <a:defRPr sz="1300">
                 <a:solidFill>
-                  <a:srgbClr val="6B7280"/>
+                  <a:srgbClr val="475569"/>
                 </a:solidFill>
               </a:defRPr>
             </a:pPr>
             <a:r>
-              <a:t>Existing booking engines recommend high-end commercial spots without catering to student pricing constraints or regional travel options.</a:t>
-            </a:r>
-          </a:p>
-        </p:txBody>
-      </p:sp>
-      <p:sp>
-        <p:nvSpPr>
-          <p:cNvPr id="7" name="Rounded Rectangle 6"/>
+              <a:t>Existing booking engines recommend high-end commercial spots without catering to student pricing constraints or regional transport choices.</a:t>
+            </a:r>
+          </a:p>
+        </p:txBody>
+      </p:sp>
+      <p:sp>
+        <p:nvSpPr>
+          <p:cNvPr id="11" name="Rectangle 10"/>
           <p:cNvSpPr/>
           <p:nvPr/>
         </p:nvSpPr>
         <p:spPr>
           <a:xfrm>
-            <a:off x="6126480" y="3931920"/>
-            <a:ext cx="5120640" cy="2103120"/>
-          </a:xfrm>
-          <a:prstGeom prst="roundRect">
-            <a:avLst/>
-          </a:prstGeom>
-          <a:solidFill>
-            <a:srgbClr val="FFFFFF"/>
+            <a:off x="731520" y="3931920"/>
+            <a:ext cx="109728" cy="2148840"/>
+          </a:xfrm>
+          <a:prstGeom prst="rect">
+            <a:avLst/>
+          </a:prstGeom>
+          <a:solidFill>
+            <a:srgbClr val="E11D48"/>
           </a:solidFill>
           <a:ln>
-            <a:solidFill>
-              <a:srgbClr val="E2E8F0"/>
-            </a:solidFill>
+            <a:noFill/>
           </a:ln>
         </p:spPr>
         <p:style>
@@ -3732,18 +4028,63 @@
           </a:fontRef>
         </p:style>
         <p:txBody>
+          <a:bodyPr rtlCol="0" anchor="ctr"/>
+          <a:lstStyle/>
+          <a:p>
+            <a:pPr algn="ctr"/>
+          </a:p>
+        </p:txBody>
+      </p:sp>
+      <p:sp>
+        <p:nvSpPr>
+          <p:cNvPr id="12" name="Rounded Rectangle 11"/>
+          <p:cNvSpPr/>
+          <p:nvPr/>
+        </p:nvSpPr>
+        <p:spPr>
+          <a:xfrm>
+            <a:off x="6126480" y="3931920"/>
+            <a:ext cx="5120640" cy="2148840"/>
+          </a:xfrm>
+          <a:prstGeom prst="roundRect">
+            <a:avLst/>
+          </a:prstGeom>
+          <a:solidFill>
+            <a:srgbClr val="FFFFFF"/>
+          </a:solidFill>
+          <a:ln>
+            <a:solidFill>
+              <a:srgbClr val="CBD5E1"/>
+            </a:solidFill>
+          </a:ln>
+        </p:spPr>
+        <p:style>
+          <a:lnRef idx="1">
+            <a:schemeClr val="accent1"/>
+          </a:lnRef>
+          <a:fillRef idx="3">
+            <a:schemeClr val="accent1"/>
+          </a:fillRef>
+          <a:effectRef idx="2">
+            <a:schemeClr val="accent1"/>
+          </a:effectRef>
+          <a:fontRef idx="minor">
+            <a:schemeClr val="lt1"/>
+          </a:fontRef>
+        </p:style>
+        <p:txBody>
           <a:bodyPr rtlCol="0" anchor="ctr" wrap="square"/>
           <a:lstStyle/>
           <a:p>
             <a:pPr algn="ctr">
               <a:defRPr sz="1700" b="1">
                 <a:solidFill>
-                  <a:srgbClr val="111827"/>
+                  <a:srgbClr val="E11D48"/>
                 </a:solidFill>
               </a:defRPr>
             </a:pPr>
             <a:r>
-              <a:t>Post-Trip Financial Friction</a:t>
+              <a:t>  Post-Trip Financial Friction</a:t>
             </a:r>
           </a:p>
           <a:p>
@@ -3753,13 +4094,56 @@
               </a:spcBef>
               <a:defRPr sz="1300">
                 <a:solidFill>
-                  <a:srgbClr val="6B7280"/>
+                  <a:srgbClr val="475569"/>
                 </a:solidFill>
               </a:defRPr>
             </a:pPr>
             <a:r>
               <a:t>Shared group trips often suffer from unorganized bill tracking, resulting in complex and awkward debt settlements after returning.</a:t>
             </a:r>
+          </a:p>
+        </p:txBody>
+      </p:sp>
+      <p:sp>
+        <p:nvSpPr>
+          <p:cNvPr id="13" name="Rectangle 12"/>
+          <p:cNvSpPr/>
+          <p:nvPr/>
+        </p:nvSpPr>
+        <p:spPr>
+          <a:xfrm>
+            <a:off x="6126480" y="3931920"/>
+            <a:ext cx="109728" cy="2148840"/>
+          </a:xfrm>
+          <a:prstGeom prst="rect">
+            <a:avLst/>
+          </a:prstGeom>
+          <a:solidFill>
+            <a:srgbClr val="E11D48"/>
+          </a:solidFill>
+          <a:ln>
+            <a:noFill/>
+          </a:ln>
+        </p:spPr>
+        <p:style>
+          <a:lnRef idx="1">
+            <a:schemeClr val="accent1"/>
+          </a:lnRef>
+          <a:fillRef idx="3">
+            <a:schemeClr val="accent1"/>
+          </a:fillRef>
+          <a:effectRef idx="2">
+            <a:schemeClr val="accent1"/>
+          </a:effectRef>
+          <a:fontRef idx="minor">
+            <a:schemeClr val="lt1"/>
+          </a:fontRef>
+        </p:style>
+        <p:txBody>
+          <a:bodyPr rtlCol="0" anchor="ctr"/>
+          <a:lstStyle/>
+          <a:p>
+            <a:pPr algn="ctr"/>
           </a:p>
         </p:txBody>
       </p:sp>
@@ -3786,14 +4170,154 @@
       <p:grpSpPr/>
       <p:sp>
         <p:nvSpPr>
-          <p:cNvPr id="2" name="TextBox 1"/>
+          <p:cNvPr id="2" name="Rectangle 1"/>
+          <p:cNvSpPr/>
+          <p:nvPr/>
+        </p:nvSpPr>
+        <p:spPr>
+          <a:xfrm>
+            <a:off x="0" y="0"/>
+            <a:ext cx="12191695" cy="1097280"/>
+          </a:xfrm>
+          <a:prstGeom prst="rect">
+            <a:avLst/>
+          </a:prstGeom>
+          <a:solidFill>
+            <a:srgbClr val="F1F5F9"/>
+          </a:solidFill>
+          <a:ln>
+            <a:solidFill>
+              <a:srgbClr val="CBD5E1"/>
+            </a:solidFill>
+          </a:ln>
+        </p:spPr>
+        <p:style>
+          <a:lnRef idx="1">
+            <a:schemeClr val="accent1"/>
+          </a:lnRef>
+          <a:fillRef idx="3">
+            <a:schemeClr val="accent1"/>
+          </a:fillRef>
+          <a:effectRef idx="2">
+            <a:schemeClr val="accent1"/>
+          </a:effectRef>
+          <a:fontRef idx="minor">
+            <a:schemeClr val="lt1"/>
+          </a:fontRef>
+        </p:style>
+        <p:txBody>
+          <a:bodyPr rtlCol="0" anchor="ctr"/>
+          <a:lstStyle/>
+          <a:p>
+            <a:pPr algn="ctr"/>
+          </a:p>
+        </p:txBody>
+      </p:sp>
+      <p:sp>
+        <p:nvSpPr>
+          <p:cNvPr id="3" name="Rectangle 2"/>
+          <p:cNvSpPr/>
+          <p:nvPr/>
+        </p:nvSpPr>
+        <p:spPr>
+          <a:xfrm>
+            <a:off x="0" y="0"/>
+            <a:ext cx="137160" cy="1097280"/>
+          </a:xfrm>
+          <a:prstGeom prst="rect">
+            <a:avLst/>
+          </a:prstGeom>
+          <a:solidFill>
+            <a:srgbClr val="7C3AED"/>
+          </a:solidFill>
+          <a:ln>
+            <a:noFill/>
+          </a:ln>
+        </p:spPr>
+        <p:style>
+          <a:lnRef idx="1">
+            <a:schemeClr val="accent1"/>
+          </a:lnRef>
+          <a:fillRef idx="3">
+            <a:schemeClr val="accent1"/>
+          </a:fillRef>
+          <a:effectRef idx="2">
+            <a:schemeClr val="accent1"/>
+          </a:effectRef>
+          <a:fontRef idx="minor">
+            <a:schemeClr val="lt1"/>
+          </a:fontRef>
+        </p:style>
+        <p:txBody>
+          <a:bodyPr rtlCol="0" anchor="ctr"/>
+          <a:lstStyle/>
+          <a:p>
+            <a:pPr algn="ctr"/>
+          </a:p>
+        </p:txBody>
+      </p:sp>
+      <p:sp>
+        <p:nvSpPr>
+          <p:cNvPr id="4" name="Rounded Rectangle 3"/>
+          <p:cNvSpPr/>
+          <p:nvPr/>
+        </p:nvSpPr>
+        <p:spPr>
+          <a:xfrm>
+            <a:off x="731520" y="164592"/>
+            <a:ext cx="2926080" cy="292608"/>
+          </a:xfrm>
+          <a:prstGeom prst="roundRect">
+            <a:avLst/>
+          </a:prstGeom>
+          <a:solidFill>
+            <a:srgbClr val="7C3AED"/>
+          </a:solidFill>
+          <a:ln>
+            <a:noFill/>
+          </a:ln>
+        </p:spPr>
+        <p:style>
+          <a:lnRef idx="1">
+            <a:schemeClr val="accent1"/>
+          </a:lnRef>
+          <a:fillRef idx="3">
+            <a:schemeClr val="accent1"/>
+          </a:fillRef>
+          <a:effectRef idx="2">
+            <a:schemeClr val="accent1"/>
+          </a:effectRef>
+          <a:fontRef idx="minor">
+            <a:schemeClr val="lt1"/>
+          </a:fontRef>
+        </p:style>
+        <p:txBody>
+          <a:bodyPr rtlCol="0" anchor="ctr"/>
+          <a:lstStyle/>
+          <a:p>
+            <a:pPr algn="ctr">
+              <a:defRPr sz="1000" b="1">
+                <a:solidFill>
+                  <a:srgbClr val="FFFFFF"/>
+                </a:solidFill>
+              </a:defRPr>
+            </a:pPr>
+            <a:r>
+              <a:t>CORE INNOVATIONS</a:t>
+            </a:r>
+          </a:p>
+        </p:txBody>
+      </p:sp>
+      <p:sp>
+        <p:nvSpPr>
+          <p:cNvPr id="5" name="TextBox 4"/>
           <p:cNvSpPr txBox="1"/>
           <p:nvPr/>
         </p:nvSpPr>
         <p:spPr>
           <a:xfrm>
-            <a:off x="731520" y="411480"/>
-            <a:ext cx="7315200" cy="320040"/>
+            <a:off x="731520" y="502920"/>
+            <a:ext cx="10515600" cy="502920"/>
           </a:xfrm>
           <a:prstGeom prst="rect">
             <a:avLst/>
@@ -3801,56 +4325,20 @@
           <a:noFill/>
         </p:spPr>
         <p:txBody>
-          <a:bodyPr wrap="square">
+          <a:bodyPr wrap="none">
             <a:spAutoFit/>
           </a:bodyPr>
           <a:lstStyle/>
           <a:p>
             <a:pPr>
-              <a:defRPr sz="1000" b="1">
-                <a:solidFill>
-                  <a:srgbClr val="7C3AED"/>
+              <a:defRPr sz="2400" b="1">
+                <a:solidFill>
+                  <a:srgbClr val="0F172A"/>
                 </a:solidFill>
                 <a:latin typeface="Arial"/>
               </a:defRPr>
             </a:pPr>
             <a:r>
-              <a:t>CORE INNOVATIONS</a:t>
-            </a:r>
-          </a:p>
-        </p:txBody>
-      </p:sp>
-      <p:sp>
-        <p:nvSpPr>
-          <p:cNvPr id="3" name="TextBox 2"/>
-          <p:cNvSpPr txBox="1"/>
-          <p:nvPr/>
-        </p:nvSpPr>
-        <p:spPr>
-          <a:xfrm>
-            <a:off x="731520" y="685800"/>
-            <a:ext cx="10058400" cy="640080"/>
-          </a:xfrm>
-          <a:prstGeom prst="rect">
-            <a:avLst/>
-          </a:prstGeom>
-          <a:noFill/>
-        </p:spPr>
-        <p:txBody>
-          <a:bodyPr wrap="square">
-            <a:spAutoFit/>
-          </a:bodyPr>
-          <a:lstStyle/>
-          <a:p>
-            <a:pPr>
-              <a:defRPr sz="2600" b="1">
-                <a:solidFill>
-                  <a:srgbClr val="111827"/>
-                </a:solidFill>
-                <a:latin typeface="Arial"/>
-              </a:defRPr>
-            </a:pPr>
-            <a:r>
               <a:t>The TripSplit Solution Architecture</a:t>
             </a:r>
           </a:p>
@@ -3858,14 +4346,14 @@
       </p:sp>
       <p:sp>
         <p:nvSpPr>
-          <p:cNvPr id="4" name="Rounded Rectangle 3"/>
+          <p:cNvPr id="6" name="Rounded Rectangle 5"/>
           <p:cNvSpPr/>
           <p:nvPr/>
         </p:nvSpPr>
         <p:spPr>
           <a:xfrm>
-            <a:off x="731520" y="1554480"/>
-            <a:ext cx="5120640" cy="2103120"/>
+            <a:off x="731520" y="1463040"/>
+            <a:ext cx="5120640" cy="2148840"/>
           </a:xfrm>
           <a:prstGeom prst="roundRect">
             <a:avLst/>
@@ -3905,7 +4393,7 @@
               </a:defRPr>
             </a:pPr>
             <a:r>
-              <a:t>Dynamic Budget Partitioning</a:t>
+              <a:t>  Dynamic Budget Partitioning</a:t>
             </a:r>
           </a:p>
           <a:p>
@@ -3915,26 +4403,69 @@
               </a:spcBef>
               <a:defRPr sz="1300">
                 <a:solidFill>
-                  <a:srgbClr val="111827"/>
+                  <a:srgbClr val="0F172A"/>
                 </a:solidFill>
               </a:defRPr>
             </a:pPr>
             <a:r>
-              <a:t>Automatically divides the input budget across Transport, Stay, Food, Local Travel, and a 10% safety buffer with real-time per-person breakdowns.</a:t>
-            </a:r>
-          </a:p>
-        </p:txBody>
-      </p:sp>
-      <p:sp>
-        <p:nvSpPr>
-          <p:cNvPr id="5" name="Rounded Rectangle 4"/>
+              <a:t>Automatically divides input budget across Transport, Stay, Food, Local Travel, and Buffer with real-time per-person breakdowns.</a:t>
+            </a:r>
+          </a:p>
+        </p:txBody>
+      </p:sp>
+      <p:sp>
+        <p:nvSpPr>
+          <p:cNvPr id="7" name="Rectangle 6"/>
           <p:cNvSpPr/>
           <p:nvPr/>
         </p:nvSpPr>
         <p:spPr>
           <a:xfrm>
-            <a:off x="6126480" y="1554480"/>
-            <a:ext cx="5120640" cy="2103120"/>
+            <a:off x="731520" y="1463040"/>
+            <a:ext cx="109728" cy="2148840"/>
+          </a:xfrm>
+          <a:prstGeom prst="rect">
+            <a:avLst/>
+          </a:prstGeom>
+          <a:solidFill>
+            <a:srgbClr val="7C3AED"/>
+          </a:solidFill>
+          <a:ln>
+            <a:noFill/>
+          </a:ln>
+        </p:spPr>
+        <p:style>
+          <a:lnRef idx="1">
+            <a:schemeClr val="accent1"/>
+          </a:lnRef>
+          <a:fillRef idx="3">
+            <a:schemeClr val="accent1"/>
+          </a:fillRef>
+          <a:effectRef idx="2">
+            <a:schemeClr val="accent1"/>
+          </a:effectRef>
+          <a:fontRef idx="minor">
+            <a:schemeClr val="lt1"/>
+          </a:fontRef>
+        </p:style>
+        <p:txBody>
+          <a:bodyPr rtlCol="0" anchor="ctr"/>
+          <a:lstStyle/>
+          <a:p>
+            <a:pPr algn="ctr"/>
+          </a:p>
+        </p:txBody>
+      </p:sp>
+      <p:sp>
+        <p:nvSpPr>
+          <p:cNvPr id="8" name="Rounded Rectangle 7"/>
+          <p:cNvSpPr/>
+          <p:nvPr/>
+        </p:nvSpPr>
+        <p:spPr>
+          <a:xfrm>
+            <a:off x="6126480" y="1463040"/>
+            <a:ext cx="5120640" cy="2148840"/>
           </a:xfrm>
           <a:prstGeom prst="roundRect">
             <a:avLst/>
@@ -3974,7 +4505,7 @@
               </a:defRPr>
             </a:pPr>
             <a:r>
-              <a:t>Budget-Free Sightseeing Logic</a:t>
+              <a:t>  Budget-Free Sightseeing Logic</a:t>
             </a:r>
           </a:p>
           <a:p>
@@ -3984,7 +4515,7 @@
               </a:spcBef>
               <a:defRPr sz="1300">
                 <a:solidFill>
-                  <a:srgbClr val="111827"/>
+                  <a:srgbClr val="0F172A"/>
                 </a:solidFill>
               </a:defRPr>
             </a:pPr>
@@ -3996,14 +4527,57 @@
       </p:sp>
       <p:sp>
         <p:nvSpPr>
-          <p:cNvPr id="6" name="Rounded Rectangle 5"/>
+          <p:cNvPr id="9" name="Rectangle 8"/>
           <p:cNvSpPr/>
           <p:nvPr/>
         </p:nvSpPr>
         <p:spPr>
           <a:xfrm>
+            <a:off x="6126480" y="1463040"/>
+            <a:ext cx="109728" cy="2148840"/>
+          </a:xfrm>
+          <a:prstGeom prst="rect">
+            <a:avLst/>
+          </a:prstGeom>
+          <a:solidFill>
+            <a:srgbClr val="7C3AED"/>
+          </a:solidFill>
+          <a:ln>
+            <a:noFill/>
+          </a:ln>
+        </p:spPr>
+        <p:style>
+          <a:lnRef idx="1">
+            <a:schemeClr val="accent1"/>
+          </a:lnRef>
+          <a:fillRef idx="3">
+            <a:schemeClr val="accent1"/>
+          </a:fillRef>
+          <a:effectRef idx="2">
+            <a:schemeClr val="accent1"/>
+          </a:effectRef>
+          <a:fontRef idx="minor">
+            <a:schemeClr val="lt1"/>
+          </a:fontRef>
+        </p:style>
+        <p:txBody>
+          <a:bodyPr rtlCol="0" anchor="ctr"/>
+          <a:lstStyle/>
+          <a:p>
+            <a:pPr algn="ctr"/>
+          </a:p>
+        </p:txBody>
+      </p:sp>
+      <p:sp>
+        <p:nvSpPr>
+          <p:cNvPr id="10" name="Rounded Rectangle 9"/>
+          <p:cNvSpPr/>
+          <p:nvPr/>
+        </p:nvSpPr>
+        <p:spPr>
+          <a:xfrm>
             <a:off x="731520" y="3931920"/>
-            <a:ext cx="5120640" cy="2103120"/>
+            <a:ext cx="5120640" cy="2148840"/>
           </a:xfrm>
           <a:prstGeom prst="roundRect">
             <a:avLst/>
@@ -4043,7 +4617,7 @@
               </a:defRPr>
             </a:pPr>
             <a:r>
-              <a:t>5 Comparative Itinerary Styles</a:t>
+              <a:t>  5 Comparative Itinerary Styles</a:t>
             </a:r>
           </a:p>
           <a:p>
@@ -4053,7 +4627,7 @@
               </a:spcBef>
               <a:defRPr sz="1300">
                 <a:solidFill>
-                  <a:srgbClr val="111827"/>
+                  <a:srgbClr val="0F172A"/>
                 </a:solidFill>
               </a:defRPr>
             </a:pPr>
@@ -4065,14 +4639,57 @@
       </p:sp>
       <p:sp>
         <p:nvSpPr>
-          <p:cNvPr id="7" name="Rounded Rectangle 6"/>
+          <p:cNvPr id="11" name="Rectangle 10"/>
           <p:cNvSpPr/>
           <p:nvPr/>
         </p:nvSpPr>
         <p:spPr>
           <a:xfrm>
+            <a:off x="731520" y="3931920"/>
+            <a:ext cx="109728" cy="2148840"/>
+          </a:xfrm>
+          <a:prstGeom prst="rect">
+            <a:avLst/>
+          </a:prstGeom>
+          <a:solidFill>
+            <a:srgbClr val="7C3AED"/>
+          </a:solidFill>
+          <a:ln>
+            <a:noFill/>
+          </a:ln>
+        </p:spPr>
+        <p:style>
+          <a:lnRef idx="1">
+            <a:schemeClr val="accent1"/>
+          </a:lnRef>
+          <a:fillRef idx="3">
+            <a:schemeClr val="accent1"/>
+          </a:fillRef>
+          <a:effectRef idx="2">
+            <a:schemeClr val="accent1"/>
+          </a:effectRef>
+          <a:fontRef idx="minor">
+            <a:schemeClr val="lt1"/>
+          </a:fontRef>
+        </p:style>
+        <p:txBody>
+          <a:bodyPr rtlCol="0" anchor="ctr"/>
+          <a:lstStyle/>
+          <a:p>
+            <a:pPr algn="ctr"/>
+          </a:p>
+        </p:txBody>
+      </p:sp>
+      <p:sp>
+        <p:nvSpPr>
+          <p:cNvPr id="12" name="Rounded Rectangle 11"/>
+          <p:cNvSpPr/>
+          <p:nvPr/>
+        </p:nvSpPr>
+        <p:spPr>
+          <a:xfrm>
             <a:off x="6126480" y="3931920"/>
-            <a:ext cx="5120640" cy="2103120"/>
+            <a:ext cx="5120640" cy="2148840"/>
           </a:xfrm>
           <a:prstGeom prst="roundRect">
             <a:avLst/>
@@ -4112,7 +4729,7 @@
               </a:defRPr>
             </a:pPr>
             <a:r>
-              <a:t>Integrated Group Expense Ledger</a:t>
+              <a:t>  Integrated Group Expense Ledger</a:t>
             </a:r>
           </a:p>
           <a:p>
@@ -4122,13 +4739,56 @@
               </a:spcBef>
               <a:defRPr sz="1300">
                 <a:solidFill>
-                  <a:srgbClr val="111827"/>
+                  <a:srgbClr val="0F172A"/>
                 </a:solidFill>
               </a:defRPr>
             </a:pPr>
             <a:r>
-              <a:t>Features a built-in group bill manager with equal/custom splits, net settlement reduction algorithms, and visual category charts.</a:t>
-            </a:r>
+              <a:t>Features a built-in group bill manager with equal/custom splits, net settlement reduction algorithms, and visual charts.</a:t>
+            </a:r>
+          </a:p>
+        </p:txBody>
+      </p:sp>
+      <p:sp>
+        <p:nvSpPr>
+          <p:cNvPr id="13" name="Rectangle 12"/>
+          <p:cNvSpPr/>
+          <p:nvPr/>
+        </p:nvSpPr>
+        <p:spPr>
+          <a:xfrm>
+            <a:off x="6126480" y="3931920"/>
+            <a:ext cx="109728" cy="2148840"/>
+          </a:xfrm>
+          <a:prstGeom prst="rect">
+            <a:avLst/>
+          </a:prstGeom>
+          <a:solidFill>
+            <a:srgbClr val="7C3AED"/>
+          </a:solidFill>
+          <a:ln>
+            <a:noFill/>
+          </a:ln>
+        </p:spPr>
+        <p:style>
+          <a:lnRef idx="1">
+            <a:schemeClr val="accent1"/>
+          </a:lnRef>
+          <a:fillRef idx="3">
+            <a:schemeClr val="accent1"/>
+          </a:fillRef>
+          <a:effectRef idx="2">
+            <a:schemeClr val="accent1"/>
+          </a:effectRef>
+          <a:fontRef idx="minor">
+            <a:schemeClr val="lt1"/>
+          </a:fontRef>
+        </p:style>
+        <p:txBody>
+          <a:bodyPr rtlCol="0" anchor="ctr"/>
+          <a:lstStyle/>
+          <a:p>
+            <a:pPr algn="ctr"/>
           </a:p>
         </p:txBody>
       </p:sp>
@@ -4295,7 +4955,7 @@
               </a:defRPr>
             </a:pPr>
             <a:r>
-              <a:t>Vanilla HTML5, CSS3, ES6+ JS</a:t>
+              <a:t>Vanilla HTML5, CSS3 &amp; ES6+ JS</a:t>
             </a:r>
             <a:br/>
             <a:br/>
@@ -4308,11 +4968,11 @@
             </a:r>
             <a:br/>
             <a:r>
-              <a:t>• TripAdvisor-Grade Visual UI</a:t>
+              <a:t>• TripAdvisor-Grade UI Design</a:t>
             </a:r>
             <a:br/>
             <a:r>
-              <a:t>• Fully Responsive Layout</a:t>
+              <a:t>• Fully Responsive Grid Layouts</a:t>
             </a:r>
           </a:p>
         </p:txBody>
@@ -4512,96 +5172,24 @@
       <p:grpSpPr/>
       <p:sp>
         <p:nvSpPr>
-          <p:cNvPr id="2" name="TextBox 1"/>
-          <p:cNvSpPr txBox="1"/>
-          <p:nvPr/>
-        </p:nvSpPr>
-        <p:spPr>
-          <a:xfrm>
-            <a:off x="731520" y="411480"/>
-            <a:ext cx="7315200" cy="320040"/>
+          <p:cNvPr id="2" name="Rectangle 1"/>
+          <p:cNvSpPr/>
+          <p:nvPr/>
+        </p:nvSpPr>
+        <p:spPr>
+          <a:xfrm>
+            <a:off x="0" y="0"/>
+            <a:ext cx="12191695" cy="1097280"/>
           </a:xfrm>
           <a:prstGeom prst="rect">
             <a:avLst/>
           </a:prstGeom>
-          <a:noFill/>
-        </p:spPr>
-        <p:txBody>
-          <a:bodyPr wrap="square">
-            <a:spAutoFit/>
-          </a:bodyPr>
-          <a:lstStyle/>
-          <a:p>
-            <a:pPr>
-              <a:defRPr sz="1000" b="1">
-                <a:solidFill>
-                  <a:srgbClr val="7C3AED"/>
-                </a:solidFill>
-                <a:latin typeface="Arial"/>
-              </a:defRPr>
-            </a:pPr>
-            <a:r>
-              <a:t>ALGORITHM PIPELINE</a:t>
-            </a:r>
-          </a:p>
-        </p:txBody>
-      </p:sp>
-      <p:sp>
-        <p:nvSpPr>
-          <p:cNvPr id="3" name="TextBox 2"/>
-          <p:cNvSpPr txBox="1"/>
-          <p:nvPr/>
-        </p:nvSpPr>
-        <p:spPr>
-          <a:xfrm>
-            <a:off x="731520" y="685800"/>
-            <a:ext cx="10058400" cy="640080"/>
-          </a:xfrm>
-          <a:prstGeom prst="rect">
-            <a:avLst/>
-          </a:prstGeom>
-          <a:noFill/>
-        </p:spPr>
-        <p:txBody>
-          <a:bodyPr wrap="square">
-            <a:spAutoFit/>
-          </a:bodyPr>
-          <a:lstStyle/>
-          <a:p>
-            <a:pPr>
-              <a:defRPr sz="2600" b="1">
-                <a:solidFill>
-                  <a:srgbClr val="111827"/>
-                </a:solidFill>
-                <a:latin typeface="Arial"/>
-              </a:defRPr>
-            </a:pPr>
-            <a:r>
-              <a:t>Optimization Heuristics &amp; Knapsack Execution</a:t>
-            </a:r>
-          </a:p>
-        </p:txBody>
-      </p:sp>
-      <p:sp>
-        <p:nvSpPr>
-          <p:cNvPr id="4" name="Rounded Rectangle 3"/>
-          <p:cNvSpPr/>
-          <p:nvPr/>
-        </p:nvSpPr>
-        <p:spPr>
-          <a:xfrm>
-            <a:off x="731520" y="1554480"/>
-            <a:ext cx="10698480" cy="1051560"/>
-          </a:xfrm>
-          <a:prstGeom prst="roundRect">
-            <a:avLst/>
-          </a:prstGeom>
-          <a:solidFill>
-            <a:srgbClr val="FFFFFF"/>
+          <a:solidFill>
+            <a:srgbClr val="F1F5F9"/>
           </a:solidFill>
           <a:ln>
             <a:solidFill>
-              <a:srgbClr val="E2E8F0"/>
+              <a:srgbClr val="CBD5E1"/>
             </a:solidFill>
           </a:ln>
         </p:spPr>
@@ -4620,51 +5208,32 @@
           </a:fontRef>
         </p:style>
         <p:txBody>
-          <a:bodyPr rtlCol="0" anchor="ctr" wrap="square"/>
-          <a:lstStyle/>
-          <a:p>
-            <a:pPr algn="ctr">
-              <a:defRPr sz="1500" b="1">
-                <a:solidFill>
-                  <a:srgbClr val="7C3AED"/>
-                </a:solidFill>
-              </a:defRPr>
-            </a:pPr>
-            <a:r>
-              <a:t>Phase 1: Bounding Box &amp; Geocoding  —  </a:t>
-            </a:r>
-            <a:r>
-              <a:rPr sz="1300" b="0">
-                <a:solidFill>
-                  <a:srgbClr val="111827"/>
-                </a:solidFill>
-              </a:rPr>
-              <a:t>Converts target city inputs into lat/lon coordinates. Applies a dense 5km radius bounding box cap for metro cities (Delhi, Mumbai) to optimize search latency.</a:t>
-            </a:r>
-          </a:p>
-        </p:txBody>
-      </p:sp>
-      <p:sp>
-        <p:nvSpPr>
-          <p:cNvPr id="5" name="Rounded Rectangle 4"/>
+          <a:bodyPr rtlCol="0" anchor="ctr"/>
+          <a:lstStyle/>
+          <a:p>
+            <a:pPr algn="ctr"/>
+          </a:p>
+        </p:txBody>
+      </p:sp>
+      <p:sp>
+        <p:nvSpPr>
+          <p:cNvPr id="3" name="Rectangle 2"/>
           <p:cNvSpPr/>
           <p:nvPr/>
         </p:nvSpPr>
         <p:spPr>
           <a:xfrm>
-            <a:off x="731520" y="2743200"/>
-            <a:ext cx="10698480" cy="1051560"/>
-          </a:xfrm>
-          <a:prstGeom prst="roundRect">
-            <a:avLst/>
-          </a:prstGeom>
-          <a:solidFill>
-            <a:srgbClr val="FFFFFF"/>
+            <a:off x="0" y="0"/>
+            <a:ext cx="137160" cy="1097280"/>
+          </a:xfrm>
+          <a:prstGeom prst="rect">
+            <a:avLst/>
+          </a:prstGeom>
+          <a:solidFill>
+            <a:srgbClr val="7C3AED"/>
           </a:solidFill>
           <a:ln>
-            <a:solidFill>
-              <a:srgbClr val="E2E8F0"/>
-            </a:solidFill>
+            <a:noFill/>
           </a:ln>
         </p:spPr>
         <p:style>
@@ -4682,51 +5251,32 @@
           </a:fontRef>
         </p:style>
         <p:txBody>
-          <a:bodyPr rtlCol="0" anchor="ctr" wrap="square"/>
-          <a:lstStyle/>
-          <a:p>
-            <a:pPr algn="ctr">
-              <a:defRPr sz="1500" b="1">
-                <a:solidFill>
-                  <a:srgbClr val="7C3AED"/>
-                </a:solidFill>
-              </a:defRPr>
-            </a:pPr>
-            <a:r>
-              <a:t>Phase 2: Venue Utility Scoring  —  </a:t>
-            </a:r>
-            <a:r>
-              <a:rPr sz="1300" b="0">
-                <a:solidFill>
-                  <a:srgbClr val="111827"/>
-                </a:solidFill>
-              </a:rPr>
-              <a:t>Classifies query results into Stays, Dining, and Attractions with utility scores (0-100) and cost estimates tailored for student travel.</a:t>
-            </a:r>
-          </a:p>
-        </p:txBody>
-      </p:sp>
-      <p:sp>
-        <p:nvSpPr>
-          <p:cNvPr id="6" name="Rounded Rectangle 5"/>
+          <a:bodyPr rtlCol="0" anchor="ctr"/>
+          <a:lstStyle/>
+          <a:p>
+            <a:pPr algn="ctr"/>
+          </a:p>
+        </p:txBody>
+      </p:sp>
+      <p:sp>
+        <p:nvSpPr>
+          <p:cNvPr id="4" name="Rounded Rectangle 3"/>
           <p:cNvSpPr/>
           <p:nvPr/>
         </p:nvSpPr>
         <p:spPr>
           <a:xfrm>
-            <a:off x="731520" y="3931920"/>
-            <a:ext cx="10698480" cy="1051560"/>
+            <a:off x="731520" y="164592"/>
+            <a:ext cx="2926080" cy="292608"/>
           </a:xfrm>
           <a:prstGeom prst="roundRect">
             <a:avLst/>
           </a:prstGeom>
           <a:solidFill>
-            <a:srgbClr val="FFFFFF"/>
+            <a:srgbClr val="7C3AED"/>
           </a:solidFill>
           <a:ln>
-            <a:solidFill>
-              <a:srgbClr val="E2E8F0"/>
-            </a:solidFill>
+            <a:noFill/>
           </a:ln>
         </p:spPr>
         <p:style>
@@ -4744,40 +5294,68 @@
           </a:fontRef>
         </p:style>
         <p:txBody>
-          <a:bodyPr rtlCol="0" anchor="ctr" wrap="square"/>
+          <a:bodyPr rtlCol="0" anchor="ctr"/>
           <a:lstStyle/>
           <a:p>
             <a:pPr algn="ctr">
-              <a:defRPr sz="1500" b="1">
-                <a:solidFill>
-                  <a:srgbClr val="7C3AED"/>
+              <a:defRPr sz="1000" b="1">
+                <a:solidFill>
+                  <a:srgbClr val="FFFFFF"/>
                 </a:solidFill>
               </a:defRPr>
             </a:pPr>
             <a:r>
-              <a:t>Phase 3: Constrained Partitioning  —  </a:t>
-            </a:r>
-            <a:r>
-              <a:rPr sz="1300" b="0">
-                <a:solidFill>
-                  <a:srgbClr val="111827"/>
-                </a:solidFill>
-              </a:rPr>
-              <a:t>Allocates funds across fixed categories (Transport, Accommodation, Food, Local Travel) with a minimum 10% safety buffer.</a:t>
-            </a:r>
-          </a:p>
-        </p:txBody>
-      </p:sp>
-      <p:sp>
-        <p:nvSpPr>
-          <p:cNvPr id="7" name="Rounded Rectangle 6"/>
+              <a:t>ALGORITHM PIPELINE</a:t>
+            </a:r>
+          </a:p>
+        </p:txBody>
+      </p:sp>
+      <p:sp>
+        <p:nvSpPr>
+          <p:cNvPr id="5" name="TextBox 4"/>
+          <p:cNvSpPr txBox="1"/>
+          <p:nvPr/>
+        </p:nvSpPr>
+        <p:spPr>
+          <a:xfrm>
+            <a:off x="731520" y="502920"/>
+            <a:ext cx="10515600" cy="502920"/>
+          </a:xfrm>
+          <a:prstGeom prst="rect">
+            <a:avLst/>
+          </a:prstGeom>
+          <a:noFill/>
+        </p:spPr>
+        <p:txBody>
+          <a:bodyPr wrap="none">
+            <a:spAutoFit/>
+          </a:bodyPr>
+          <a:lstStyle/>
+          <a:p>
+            <a:pPr>
+              <a:defRPr sz="2400" b="1">
+                <a:solidFill>
+                  <a:srgbClr val="0F172A"/>
+                </a:solidFill>
+                <a:latin typeface="Arial"/>
+              </a:defRPr>
+            </a:pPr>
+            <a:r>
+              <a:t>Optimization Heuristics &amp; Knapsack Execution</a:t>
+            </a:r>
+          </a:p>
+        </p:txBody>
+      </p:sp>
+      <p:sp>
+        <p:nvSpPr>
+          <p:cNvPr id="6" name="Rounded Rectangle 5"/>
           <p:cNvSpPr/>
           <p:nvPr/>
         </p:nvSpPr>
         <p:spPr>
           <a:xfrm>
-            <a:off x="731520" y="5120640"/>
-            <a:ext cx="10698480" cy="1051560"/>
+            <a:off x="731520" y="1463040"/>
+            <a:ext cx="10698480" cy="1097280"/>
           </a:xfrm>
           <a:prstGeom prst="roundRect">
             <a:avLst/>
@@ -4787,7 +5365,7 @@
           </a:solidFill>
           <a:ln>
             <a:solidFill>
-              <a:srgbClr val="E2E8F0"/>
+              <a:srgbClr val="CBD5E1"/>
             </a:solidFill>
           </a:ln>
         </p:spPr>
@@ -4817,16 +5395,374 @@
               </a:defRPr>
             </a:pPr>
             <a:r>
-              <a:t>Phase 4: Sequential Day Slotting  —  </a:t>
+              <a:t>  Phase 1: Bounding Box &amp; Geocoding  —  </a:t>
             </a:r>
             <a:r>
               <a:rPr sz="1300" b="0">
                 <a:solidFill>
-                  <a:srgbClr val="111827"/>
+                  <a:srgbClr val="0F172A"/>
+                </a:solidFill>
+              </a:rPr>
+              <a:t>Converts target city inputs into lat/lon coordinates. Applies a dense 5km radius bounding box cap for metro cities (Delhi, Mumbai) to optimize search latency.</a:t>
+            </a:r>
+          </a:p>
+        </p:txBody>
+      </p:sp>
+      <p:sp>
+        <p:nvSpPr>
+          <p:cNvPr id="7" name="Rectangle 6"/>
+          <p:cNvSpPr/>
+          <p:nvPr/>
+        </p:nvSpPr>
+        <p:spPr>
+          <a:xfrm>
+            <a:off x="731520" y="1463040"/>
+            <a:ext cx="109728" cy="1097280"/>
+          </a:xfrm>
+          <a:prstGeom prst="rect">
+            <a:avLst/>
+          </a:prstGeom>
+          <a:solidFill>
+            <a:srgbClr val="7C3AED"/>
+          </a:solidFill>
+          <a:ln>
+            <a:noFill/>
+          </a:ln>
+        </p:spPr>
+        <p:style>
+          <a:lnRef idx="1">
+            <a:schemeClr val="accent1"/>
+          </a:lnRef>
+          <a:fillRef idx="3">
+            <a:schemeClr val="accent1"/>
+          </a:fillRef>
+          <a:effectRef idx="2">
+            <a:schemeClr val="accent1"/>
+          </a:effectRef>
+          <a:fontRef idx="minor">
+            <a:schemeClr val="lt1"/>
+          </a:fontRef>
+        </p:style>
+        <p:txBody>
+          <a:bodyPr rtlCol="0" anchor="ctr"/>
+          <a:lstStyle/>
+          <a:p>
+            <a:pPr algn="ctr"/>
+          </a:p>
+        </p:txBody>
+      </p:sp>
+      <p:sp>
+        <p:nvSpPr>
+          <p:cNvPr id="8" name="Rounded Rectangle 7"/>
+          <p:cNvSpPr/>
+          <p:nvPr/>
+        </p:nvSpPr>
+        <p:spPr>
+          <a:xfrm>
+            <a:off x="731520" y="2697480"/>
+            <a:ext cx="10698480" cy="1097280"/>
+          </a:xfrm>
+          <a:prstGeom prst="roundRect">
+            <a:avLst/>
+          </a:prstGeom>
+          <a:solidFill>
+            <a:srgbClr val="FFFFFF"/>
+          </a:solidFill>
+          <a:ln>
+            <a:solidFill>
+              <a:srgbClr val="CBD5E1"/>
+            </a:solidFill>
+          </a:ln>
+        </p:spPr>
+        <p:style>
+          <a:lnRef idx="1">
+            <a:schemeClr val="accent1"/>
+          </a:lnRef>
+          <a:fillRef idx="3">
+            <a:schemeClr val="accent1"/>
+          </a:fillRef>
+          <a:effectRef idx="2">
+            <a:schemeClr val="accent1"/>
+          </a:effectRef>
+          <a:fontRef idx="minor">
+            <a:schemeClr val="lt1"/>
+          </a:fontRef>
+        </p:style>
+        <p:txBody>
+          <a:bodyPr rtlCol="0" anchor="ctr" wrap="square"/>
+          <a:lstStyle/>
+          <a:p>
+            <a:pPr algn="ctr">
+              <a:defRPr sz="1500" b="1">
+                <a:solidFill>
+                  <a:srgbClr val="7C3AED"/>
+                </a:solidFill>
+              </a:defRPr>
+            </a:pPr>
+            <a:r>
+              <a:t>  Phase 2: Venue Utility Scoring  —  </a:t>
+            </a:r>
+            <a:r>
+              <a:rPr sz="1300" b="0">
+                <a:solidFill>
+                  <a:srgbClr val="0F172A"/>
+                </a:solidFill>
+              </a:rPr>
+              <a:t>Classifies query results into Stays, Dining, and Attractions with utility scores (0-100) and cost estimates tailored for student travel.</a:t>
+            </a:r>
+          </a:p>
+        </p:txBody>
+      </p:sp>
+      <p:sp>
+        <p:nvSpPr>
+          <p:cNvPr id="9" name="Rectangle 8"/>
+          <p:cNvSpPr/>
+          <p:nvPr/>
+        </p:nvSpPr>
+        <p:spPr>
+          <a:xfrm>
+            <a:off x="731520" y="2697480"/>
+            <a:ext cx="109728" cy="1097280"/>
+          </a:xfrm>
+          <a:prstGeom prst="rect">
+            <a:avLst/>
+          </a:prstGeom>
+          <a:solidFill>
+            <a:srgbClr val="7C3AED"/>
+          </a:solidFill>
+          <a:ln>
+            <a:noFill/>
+          </a:ln>
+        </p:spPr>
+        <p:style>
+          <a:lnRef idx="1">
+            <a:schemeClr val="accent1"/>
+          </a:lnRef>
+          <a:fillRef idx="3">
+            <a:schemeClr val="accent1"/>
+          </a:fillRef>
+          <a:effectRef idx="2">
+            <a:schemeClr val="accent1"/>
+          </a:effectRef>
+          <a:fontRef idx="minor">
+            <a:schemeClr val="lt1"/>
+          </a:fontRef>
+        </p:style>
+        <p:txBody>
+          <a:bodyPr rtlCol="0" anchor="ctr"/>
+          <a:lstStyle/>
+          <a:p>
+            <a:pPr algn="ctr"/>
+          </a:p>
+        </p:txBody>
+      </p:sp>
+      <p:sp>
+        <p:nvSpPr>
+          <p:cNvPr id="10" name="Rounded Rectangle 9"/>
+          <p:cNvSpPr/>
+          <p:nvPr/>
+        </p:nvSpPr>
+        <p:spPr>
+          <a:xfrm>
+            <a:off x="731520" y="3931920"/>
+            <a:ext cx="10698480" cy="1097280"/>
+          </a:xfrm>
+          <a:prstGeom prst="roundRect">
+            <a:avLst/>
+          </a:prstGeom>
+          <a:solidFill>
+            <a:srgbClr val="FFFFFF"/>
+          </a:solidFill>
+          <a:ln>
+            <a:solidFill>
+              <a:srgbClr val="CBD5E1"/>
+            </a:solidFill>
+          </a:ln>
+        </p:spPr>
+        <p:style>
+          <a:lnRef idx="1">
+            <a:schemeClr val="accent1"/>
+          </a:lnRef>
+          <a:fillRef idx="3">
+            <a:schemeClr val="accent1"/>
+          </a:fillRef>
+          <a:effectRef idx="2">
+            <a:schemeClr val="accent1"/>
+          </a:effectRef>
+          <a:fontRef idx="minor">
+            <a:schemeClr val="lt1"/>
+          </a:fontRef>
+        </p:style>
+        <p:txBody>
+          <a:bodyPr rtlCol="0" anchor="ctr" wrap="square"/>
+          <a:lstStyle/>
+          <a:p>
+            <a:pPr algn="ctr">
+              <a:defRPr sz="1500" b="1">
+                <a:solidFill>
+                  <a:srgbClr val="7C3AED"/>
+                </a:solidFill>
+              </a:defRPr>
+            </a:pPr>
+            <a:r>
+              <a:t>  Phase 3: Constrained Partitioning  —  </a:t>
+            </a:r>
+            <a:r>
+              <a:rPr sz="1300" b="0">
+                <a:solidFill>
+                  <a:srgbClr val="0F172A"/>
+                </a:solidFill>
+              </a:rPr>
+              <a:t>Allocates funds across fixed categories (Transport, Accommodation, Food, Local Travel) with a minimum 10% safety buffer.</a:t>
+            </a:r>
+          </a:p>
+        </p:txBody>
+      </p:sp>
+      <p:sp>
+        <p:nvSpPr>
+          <p:cNvPr id="11" name="Rectangle 10"/>
+          <p:cNvSpPr/>
+          <p:nvPr/>
+        </p:nvSpPr>
+        <p:spPr>
+          <a:xfrm>
+            <a:off x="731520" y="3931920"/>
+            <a:ext cx="109728" cy="1097280"/>
+          </a:xfrm>
+          <a:prstGeom prst="rect">
+            <a:avLst/>
+          </a:prstGeom>
+          <a:solidFill>
+            <a:srgbClr val="7C3AED"/>
+          </a:solidFill>
+          <a:ln>
+            <a:noFill/>
+          </a:ln>
+        </p:spPr>
+        <p:style>
+          <a:lnRef idx="1">
+            <a:schemeClr val="accent1"/>
+          </a:lnRef>
+          <a:fillRef idx="3">
+            <a:schemeClr val="accent1"/>
+          </a:fillRef>
+          <a:effectRef idx="2">
+            <a:schemeClr val="accent1"/>
+          </a:effectRef>
+          <a:fontRef idx="minor">
+            <a:schemeClr val="lt1"/>
+          </a:fontRef>
+        </p:style>
+        <p:txBody>
+          <a:bodyPr rtlCol="0" anchor="ctr"/>
+          <a:lstStyle/>
+          <a:p>
+            <a:pPr algn="ctr"/>
+          </a:p>
+        </p:txBody>
+      </p:sp>
+      <p:sp>
+        <p:nvSpPr>
+          <p:cNvPr id="12" name="Rounded Rectangle 11"/>
+          <p:cNvSpPr/>
+          <p:nvPr/>
+        </p:nvSpPr>
+        <p:spPr>
+          <a:xfrm>
+            <a:off x="731520" y="5166360"/>
+            <a:ext cx="10698480" cy="1097280"/>
+          </a:xfrm>
+          <a:prstGeom prst="roundRect">
+            <a:avLst/>
+          </a:prstGeom>
+          <a:solidFill>
+            <a:srgbClr val="FFFFFF"/>
+          </a:solidFill>
+          <a:ln>
+            <a:solidFill>
+              <a:srgbClr val="CBD5E1"/>
+            </a:solidFill>
+          </a:ln>
+        </p:spPr>
+        <p:style>
+          <a:lnRef idx="1">
+            <a:schemeClr val="accent1"/>
+          </a:lnRef>
+          <a:fillRef idx="3">
+            <a:schemeClr val="accent1"/>
+          </a:fillRef>
+          <a:effectRef idx="2">
+            <a:schemeClr val="accent1"/>
+          </a:effectRef>
+          <a:fontRef idx="minor">
+            <a:schemeClr val="lt1"/>
+          </a:fontRef>
+        </p:style>
+        <p:txBody>
+          <a:bodyPr rtlCol="0" anchor="ctr" wrap="square"/>
+          <a:lstStyle/>
+          <a:p>
+            <a:pPr algn="ctr">
+              <a:defRPr sz="1500" b="1">
+                <a:solidFill>
+                  <a:srgbClr val="7C3AED"/>
+                </a:solidFill>
+              </a:defRPr>
+            </a:pPr>
+            <a:r>
+              <a:t>  Phase 4: Sequential Day Slotting  —  </a:t>
+            </a:r>
+            <a:r>
+              <a:rPr sz="1300" b="0">
+                <a:solidFill>
+                  <a:srgbClr val="0F172A"/>
                 </a:solidFill>
               </a:rPr>
               <a:t>Slots attractions sequentially into Morning, Afternoon, Evening, and Night timeline buckets, producing structured day-by-day plans.</a:t>
             </a:r>
+          </a:p>
+        </p:txBody>
+      </p:sp>
+      <p:sp>
+        <p:nvSpPr>
+          <p:cNvPr id="13" name="Rectangle 12"/>
+          <p:cNvSpPr/>
+          <p:nvPr/>
+        </p:nvSpPr>
+        <p:spPr>
+          <a:xfrm>
+            <a:off x="731520" y="5166360"/>
+            <a:ext cx="109728" cy="1097280"/>
+          </a:xfrm>
+          <a:prstGeom prst="rect">
+            <a:avLst/>
+          </a:prstGeom>
+          <a:solidFill>
+            <a:srgbClr val="7C3AED"/>
+          </a:solidFill>
+          <a:ln>
+            <a:noFill/>
+          </a:ln>
+        </p:spPr>
+        <p:style>
+          <a:lnRef idx="1">
+            <a:schemeClr val="accent1"/>
+          </a:lnRef>
+          <a:fillRef idx="3">
+            <a:schemeClr val="accent1"/>
+          </a:fillRef>
+          <a:effectRef idx="2">
+            <a:schemeClr val="accent1"/>
+          </a:effectRef>
+          <a:fontRef idx="minor">
+            <a:schemeClr val="lt1"/>
+          </a:fontRef>
+        </p:style>
+        <p:txBody>
+          <a:bodyPr rtlCol="0" anchor="ctr"/>
+          <a:lstStyle/>
+          <a:p>
+            <a:pPr algn="ctr"/>
           </a:p>
         </p:txBody>
       </p:sp>
@@ -4853,96 +5789,24 @@
       <p:grpSpPr/>
       <p:sp>
         <p:nvSpPr>
-          <p:cNvPr id="2" name="TextBox 1"/>
-          <p:cNvSpPr txBox="1"/>
-          <p:nvPr/>
-        </p:nvSpPr>
-        <p:spPr>
-          <a:xfrm>
-            <a:off x="731520" y="411480"/>
-            <a:ext cx="7315200" cy="320040"/>
+          <p:cNvPr id="2" name="Rectangle 1"/>
+          <p:cNvSpPr/>
+          <p:nvPr/>
+        </p:nvSpPr>
+        <p:spPr>
+          <a:xfrm>
+            <a:off x="0" y="0"/>
+            <a:ext cx="12191695" cy="1097280"/>
           </a:xfrm>
           <a:prstGeom prst="rect">
             <a:avLst/>
           </a:prstGeom>
-          <a:noFill/>
-        </p:spPr>
-        <p:txBody>
-          <a:bodyPr wrap="square">
-            <a:spAutoFit/>
-          </a:bodyPr>
-          <a:lstStyle/>
-          <a:p>
-            <a:pPr>
-              <a:defRPr sz="1000" b="1">
-                <a:solidFill>
-                  <a:srgbClr val="7C3AED"/>
-                </a:solidFill>
-                <a:latin typeface="Arial"/>
-              </a:defRPr>
-            </a:pPr>
-            <a:r>
-              <a:t>PLATFORM HIGHLIGHTS</a:t>
-            </a:r>
-          </a:p>
-        </p:txBody>
-      </p:sp>
-      <p:sp>
-        <p:nvSpPr>
-          <p:cNvPr id="3" name="TextBox 2"/>
-          <p:cNvSpPr txBox="1"/>
-          <p:nvPr/>
-        </p:nvSpPr>
-        <p:spPr>
-          <a:xfrm>
-            <a:off x="731520" y="685800"/>
-            <a:ext cx="10058400" cy="640080"/>
-          </a:xfrm>
-          <a:prstGeom prst="rect">
-            <a:avLst/>
-          </a:prstGeom>
-          <a:noFill/>
-        </p:spPr>
-        <p:txBody>
-          <a:bodyPr wrap="square">
-            <a:spAutoFit/>
-          </a:bodyPr>
-          <a:lstStyle/>
-          <a:p>
-            <a:pPr>
-              <a:defRPr sz="2600" b="1">
-                <a:solidFill>
-                  <a:srgbClr val="111827"/>
-                </a:solidFill>
-                <a:latin typeface="Arial"/>
-              </a:defRPr>
-            </a:pPr>
-            <a:r>
-              <a:t>India-Centric Features &amp; Capabilities</a:t>
-            </a:r>
-          </a:p>
-        </p:txBody>
-      </p:sp>
-      <p:sp>
-        <p:nvSpPr>
-          <p:cNvPr id="4" name="Rounded Rectangle 3"/>
-          <p:cNvSpPr/>
-          <p:nvPr/>
-        </p:nvSpPr>
-        <p:spPr>
-          <a:xfrm>
-            <a:off x="731520" y="1554480"/>
-            <a:ext cx="5120640" cy="2103120"/>
-          </a:xfrm>
-          <a:prstGeom prst="roundRect">
-            <a:avLst/>
-          </a:prstGeom>
-          <a:solidFill>
-            <a:srgbClr val="F8FAFC"/>
+          <a:solidFill>
+            <a:srgbClr val="F1F5F9"/>
           </a:solidFill>
           <a:ln>
             <a:solidFill>
-              <a:srgbClr val="E2E8F0"/>
+              <a:srgbClr val="CBD5E1"/>
             </a:solidFill>
           </a:ln>
         </p:spPr>
@@ -4961,13 +5825,189 @@
           </a:fontRef>
         </p:style>
         <p:txBody>
+          <a:bodyPr rtlCol="0" anchor="ctr"/>
+          <a:lstStyle/>
+          <a:p>
+            <a:pPr algn="ctr"/>
+          </a:p>
+        </p:txBody>
+      </p:sp>
+      <p:sp>
+        <p:nvSpPr>
+          <p:cNvPr id="3" name="Rectangle 2"/>
+          <p:cNvSpPr/>
+          <p:nvPr/>
+        </p:nvSpPr>
+        <p:spPr>
+          <a:xfrm>
+            <a:off x="0" y="0"/>
+            <a:ext cx="137160" cy="1097280"/>
+          </a:xfrm>
+          <a:prstGeom prst="rect">
+            <a:avLst/>
+          </a:prstGeom>
+          <a:solidFill>
+            <a:srgbClr val="7C3AED"/>
+          </a:solidFill>
+          <a:ln>
+            <a:noFill/>
+          </a:ln>
+        </p:spPr>
+        <p:style>
+          <a:lnRef idx="1">
+            <a:schemeClr val="accent1"/>
+          </a:lnRef>
+          <a:fillRef idx="3">
+            <a:schemeClr val="accent1"/>
+          </a:fillRef>
+          <a:effectRef idx="2">
+            <a:schemeClr val="accent1"/>
+          </a:effectRef>
+          <a:fontRef idx="minor">
+            <a:schemeClr val="lt1"/>
+          </a:fontRef>
+        </p:style>
+        <p:txBody>
+          <a:bodyPr rtlCol="0" anchor="ctr"/>
+          <a:lstStyle/>
+          <a:p>
+            <a:pPr algn="ctr"/>
+          </a:p>
+        </p:txBody>
+      </p:sp>
+      <p:sp>
+        <p:nvSpPr>
+          <p:cNvPr id="4" name="Rounded Rectangle 3"/>
+          <p:cNvSpPr/>
+          <p:nvPr/>
+        </p:nvSpPr>
+        <p:spPr>
+          <a:xfrm>
+            <a:off x="731520" y="164592"/>
+            <a:ext cx="2926080" cy="292608"/>
+          </a:xfrm>
+          <a:prstGeom prst="roundRect">
+            <a:avLst/>
+          </a:prstGeom>
+          <a:solidFill>
+            <a:srgbClr val="7C3AED"/>
+          </a:solidFill>
+          <a:ln>
+            <a:noFill/>
+          </a:ln>
+        </p:spPr>
+        <p:style>
+          <a:lnRef idx="1">
+            <a:schemeClr val="accent1"/>
+          </a:lnRef>
+          <a:fillRef idx="3">
+            <a:schemeClr val="accent1"/>
+          </a:fillRef>
+          <a:effectRef idx="2">
+            <a:schemeClr val="accent1"/>
+          </a:effectRef>
+          <a:fontRef idx="minor">
+            <a:schemeClr val="lt1"/>
+          </a:fontRef>
+        </p:style>
+        <p:txBody>
+          <a:bodyPr rtlCol="0" anchor="ctr"/>
+          <a:lstStyle/>
+          <a:p>
+            <a:pPr algn="ctr">
+              <a:defRPr sz="1000" b="1">
+                <a:solidFill>
+                  <a:srgbClr val="FFFFFF"/>
+                </a:solidFill>
+              </a:defRPr>
+            </a:pPr>
+            <a:r>
+              <a:t>PLATFORM HIGHLIGHTS</a:t>
+            </a:r>
+          </a:p>
+        </p:txBody>
+      </p:sp>
+      <p:sp>
+        <p:nvSpPr>
+          <p:cNvPr id="5" name="TextBox 4"/>
+          <p:cNvSpPr txBox="1"/>
+          <p:nvPr/>
+        </p:nvSpPr>
+        <p:spPr>
+          <a:xfrm>
+            <a:off x="731520" y="502920"/>
+            <a:ext cx="10515600" cy="502920"/>
+          </a:xfrm>
+          <a:prstGeom prst="rect">
+            <a:avLst/>
+          </a:prstGeom>
+          <a:noFill/>
+        </p:spPr>
+        <p:txBody>
+          <a:bodyPr wrap="none">
+            <a:spAutoFit/>
+          </a:bodyPr>
+          <a:lstStyle/>
+          <a:p>
+            <a:pPr>
+              <a:defRPr sz="2400" b="1">
+                <a:solidFill>
+                  <a:srgbClr val="0F172A"/>
+                </a:solidFill>
+                <a:latin typeface="Arial"/>
+              </a:defRPr>
+            </a:pPr>
+            <a:r>
+              <a:t>India-Centric Features &amp; Capabilities</a:t>
+            </a:r>
+          </a:p>
+        </p:txBody>
+      </p:sp>
+      <p:sp>
+        <p:nvSpPr>
+          <p:cNvPr id="6" name="Rounded Rectangle 5"/>
+          <p:cNvSpPr/>
+          <p:nvPr/>
+        </p:nvSpPr>
+        <p:spPr>
+          <a:xfrm>
+            <a:off x="731520" y="1463040"/>
+            <a:ext cx="5120640" cy="2148840"/>
+          </a:xfrm>
+          <a:prstGeom prst="roundRect">
+            <a:avLst/>
+          </a:prstGeom>
+          <a:solidFill>
+            <a:srgbClr val="F8FAFC"/>
+          </a:solidFill>
+          <a:ln>
+            <a:solidFill>
+              <a:srgbClr val="CBD5E1"/>
+            </a:solidFill>
+          </a:ln>
+        </p:spPr>
+        <p:style>
+          <a:lnRef idx="1">
+            <a:schemeClr val="accent1"/>
+          </a:lnRef>
+          <a:fillRef idx="3">
+            <a:schemeClr val="accent1"/>
+          </a:fillRef>
+          <a:effectRef idx="2">
+            <a:schemeClr val="accent1"/>
+          </a:effectRef>
+          <a:fontRef idx="minor">
+            <a:schemeClr val="lt1"/>
+          </a:fontRef>
+        </p:style>
+        <p:txBody>
           <a:bodyPr rtlCol="0" anchor="ctr" wrap="square"/>
           <a:lstStyle/>
           <a:p>
             <a:pPr algn="ctr">
               <a:defRPr sz="1700" b="1">
                 <a:solidFill>
-                  <a:srgbClr val="111827"/>
+                  <a:srgbClr val="0F172A"/>
                 </a:solidFill>
               </a:defRPr>
             </a:pPr>
@@ -4982,7 +6022,7 @@
               </a:spcBef>
               <a:defRPr sz="1300">
                 <a:solidFill>
-                  <a:srgbClr val="6B7280"/>
+                  <a:srgbClr val="475569"/>
                 </a:solidFill>
               </a:defRPr>
             </a:pPr>
@@ -4994,14 +6034,14 @@
       </p:sp>
       <p:sp>
         <p:nvSpPr>
-          <p:cNvPr id="5" name="Rounded Rectangle 4"/>
+          <p:cNvPr id="7" name="Rounded Rectangle 6"/>
           <p:cNvSpPr/>
           <p:nvPr/>
         </p:nvSpPr>
         <p:spPr>
           <a:xfrm>
-            <a:off x="6126480" y="1554480"/>
-            <a:ext cx="5120640" cy="2103120"/>
+            <a:off x="6126480" y="1463040"/>
+            <a:ext cx="5120640" cy="2148840"/>
           </a:xfrm>
           <a:prstGeom prst="roundRect">
             <a:avLst/>
@@ -5011,7 +6051,7 @@
           </a:solidFill>
           <a:ln>
             <a:solidFill>
-              <a:srgbClr val="E2E8F0"/>
+              <a:srgbClr val="CBD5E1"/>
             </a:solidFill>
           </a:ln>
         </p:spPr>
@@ -5036,7 +6076,7 @@
             <a:pPr algn="ctr">
               <a:defRPr sz="1700" b="1">
                 <a:solidFill>
-                  <a:srgbClr val="111827"/>
+                  <a:srgbClr val="0F172A"/>
                 </a:solidFill>
               </a:defRPr>
             </a:pPr>
@@ -5051,7 +6091,7 @@
               </a:spcBef>
               <a:defRPr sz="1300">
                 <a:solidFill>
-                  <a:srgbClr val="6B7280"/>
+                  <a:srgbClr val="475569"/>
                 </a:solidFill>
               </a:defRPr>
             </a:pPr>
@@ -5063,14 +6103,14 @@
       </p:sp>
       <p:sp>
         <p:nvSpPr>
-          <p:cNvPr id="6" name="Rounded Rectangle 5"/>
+          <p:cNvPr id="8" name="Rounded Rectangle 7"/>
           <p:cNvSpPr/>
           <p:nvPr/>
         </p:nvSpPr>
         <p:spPr>
           <a:xfrm>
             <a:off x="731520" y="3931920"/>
-            <a:ext cx="5120640" cy="2103120"/>
+            <a:ext cx="5120640" cy="2148840"/>
           </a:xfrm>
           <a:prstGeom prst="roundRect">
             <a:avLst/>
@@ -5080,7 +6120,7 @@
           </a:solidFill>
           <a:ln>
             <a:solidFill>
-              <a:srgbClr val="E2E8F0"/>
+              <a:srgbClr val="CBD5E1"/>
             </a:solidFill>
           </a:ln>
         </p:spPr>
@@ -5105,7 +6145,7 @@
             <a:pPr algn="ctr">
               <a:defRPr sz="1700" b="1">
                 <a:solidFill>
-                  <a:srgbClr val="111827"/>
+                  <a:srgbClr val="0F172A"/>
                 </a:solidFill>
               </a:defRPr>
             </a:pPr>
@@ -5120,7 +6160,7 @@
               </a:spcBef>
               <a:defRPr sz="1300">
                 <a:solidFill>
-                  <a:srgbClr val="6B7280"/>
+                  <a:srgbClr val="475569"/>
                 </a:solidFill>
               </a:defRPr>
             </a:pPr>
@@ -5132,14 +6172,14 @@
       </p:sp>
       <p:sp>
         <p:nvSpPr>
-          <p:cNvPr id="7" name="Rounded Rectangle 6"/>
+          <p:cNvPr id="9" name="Rounded Rectangle 8"/>
           <p:cNvSpPr/>
           <p:nvPr/>
         </p:nvSpPr>
         <p:spPr>
           <a:xfrm>
             <a:off x="6126480" y="3931920"/>
-            <a:ext cx="5120640" cy="2103120"/>
+            <a:ext cx="5120640" cy="2148840"/>
           </a:xfrm>
           <a:prstGeom prst="roundRect">
             <a:avLst/>
@@ -5149,7 +6189,7 @@
           </a:solidFill>
           <a:ln>
             <a:solidFill>
-              <a:srgbClr val="E2E8F0"/>
+              <a:srgbClr val="CBD5E1"/>
             </a:solidFill>
           </a:ln>
         </p:spPr>
@@ -5174,7 +6214,7 @@
             <a:pPr algn="ctr">
               <a:defRPr sz="1700" b="1">
                 <a:solidFill>
-                  <a:srgbClr val="111827"/>
+                  <a:srgbClr val="0F172A"/>
                 </a:solidFill>
               </a:defRPr>
             </a:pPr>
@@ -5189,7 +6229,7 @@
               </a:spcBef>
               <a:defRPr sz="1300">
                 <a:solidFill>
-                  <a:srgbClr val="6B7280"/>
+                  <a:srgbClr val="475569"/>
                 </a:solidFill>
               </a:defRPr>
             </a:pPr>
@@ -5222,14 +6262,154 @@
       <p:grpSpPr/>
       <p:sp>
         <p:nvSpPr>
-          <p:cNvPr id="2" name="TextBox 1"/>
+          <p:cNvPr id="2" name="Rectangle 1"/>
+          <p:cNvSpPr/>
+          <p:nvPr/>
+        </p:nvSpPr>
+        <p:spPr>
+          <a:xfrm>
+            <a:off x="0" y="0"/>
+            <a:ext cx="12191695" cy="1097280"/>
+          </a:xfrm>
+          <a:prstGeom prst="rect">
+            <a:avLst/>
+          </a:prstGeom>
+          <a:solidFill>
+            <a:srgbClr val="F1F5F9"/>
+          </a:solidFill>
+          <a:ln>
+            <a:solidFill>
+              <a:srgbClr val="CBD5E1"/>
+            </a:solidFill>
+          </a:ln>
+        </p:spPr>
+        <p:style>
+          <a:lnRef idx="1">
+            <a:schemeClr val="accent1"/>
+          </a:lnRef>
+          <a:fillRef idx="3">
+            <a:schemeClr val="accent1"/>
+          </a:fillRef>
+          <a:effectRef idx="2">
+            <a:schemeClr val="accent1"/>
+          </a:effectRef>
+          <a:fontRef idx="minor">
+            <a:schemeClr val="lt1"/>
+          </a:fontRef>
+        </p:style>
+        <p:txBody>
+          <a:bodyPr rtlCol="0" anchor="ctr"/>
+          <a:lstStyle/>
+          <a:p>
+            <a:pPr algn="ctr"/>
+          </a:p>
+        </p:txBody>
+      </p:sp>
+      <p:sp>
+        <p:nvSpPr>
+          <p:cNvPr id="3" name="Rectangle 2"/>
+          <p:cNvSpPr/>
+          <p:nvPr/>
+        </p:nvSpPr>
+        <p:spPr>
+          <a:xfrm>
+            <a:off x="0" y="0"/>
+            <a:ext cx="137160" cy="1097280"/>
+          </a:xfrm>
+          <a:prstGeom prst="rect">
+            <a:avLst/>
+          </a:prstGeom>
+          <a:solidFill>
+            <a:srgbClr val="7C3AED"/>
+          </a:solidFill>
+          <a:ln>
+            <a:noFill/>
+          </a:ln>
+        </p:spPr>
+        <p:style>
+          <a:lnRef idx="1">
+            <a:schemeClr val="accent1"/>
+          </a:lnRef>
+          <a:fillRef idx="3">
+            <a:schemeClr val="accent1"/>
+          </a:fillRef>
+          <a:effectRef idx="2">
+            <a:schemeClr val="accent1"/>
+          </a:effectRef>
+          <a:fontRef idx="minor">
+            <a:schemeClr val="lt1"/>
+          </a:fontRef>
+        </p:style>
+        <p:txBody>
+          <a:bodyPr rtlCol="0" anchor="ctr"/>
+          <a:lstStyle/>
+          <a:p>
+            <a:pPr algn="ctr"/>
+          </a:p>
+        </p:txBody>
+      </p:sp>
+      <p:sp>
+        <p:nvSpPr>
+          <p:cNvPr id="4" name="Rounded Rectangle 3"/>
+          <p:cNvSpPr/>
+          <p:nvPr/>
+        </p:nvSpPr>
+        <p:spPr>
+          <a:xfrm>
+            <a:off x="731520" y="164592"/>
+            <a:ext cx="2926080" cy="292608"/>
+          </a:xfrm>
+          <a:prstGeom prst="roundRect">
+            <a:avLst/>
+          </a:prstGeom>
+          <a:solidFill>
+            <a:srgbClr val="7C3AED"/>
+          </a:solidFill>
+          <a:ln>
+            <a:noFill/>
+          </a:ln>
+        </p:spPr>
+        <p:style>
+          <a:lnRef idx="1">
+            <a:schemeClr val="accent1"/>
+          </a:lnRef>
+          <a:fillRef idx="3">
+            <a:schemeClr val="accent1"/>
+          </a:fillRef>
+          <a:effectRef idx="2">
+            <a:schemeClr val="accent1"/>
+          </a:effectRef>
+          <a:fontRef idx="minor">
+            <a:schemeClr val="lt1"/>
+          </a:fontRef>
+        </p:style>
+        <p:txBody>
+          <a:bodyPr rtlCol="0" anchor="ctr"/>
+          <a:lstStyle/>
+          <a:p>
+            <a:pPr algn="ctr">
+              <a:defRPr sz="1000" b="1">
+                <a:solidFill>
+                  <a:srgbClr val="FFFFFF"/>
+                </a:solidFill>
+              </a:defRPr>
+            </a:pPr>
+            <a:r>
+              <a:t>FINANCIAL MANAGEMENT</a:t>
+            </a:r>
+          </a:p>
+        </p:txBody>
+      </p:sp>
+      <p:sp>
+        <p:nvSpPr>
+          <p:cNvPr id="5" name="TextBox 4"/>
           <p:cNvSpPr txBox="1"/>
           <p:nvPr/>
         </p:nvSpPr>
         <p:spPr>
           <a:xfrm>
-            <a:off x="731520" y="411480"/>
-            <a:ext cx="7315200" cy="320040"/>
+            <a:off x="731520" y="502920"/>
+            <a:ext cx="10515600" cy="502920"/>
           </a:xfrm>
           <a:prstGeom prst="rect">
             <a:avLst/>
@@ -5237,56 +6417,20 @@
           <a:noFill/>
         </p:spPr>
         <p:txBody>
-          <a:bodyPr wrap="square">
+          <a:bodyPr wrap="none">
             <a:spAutoFit/>
           </a:bodyPr>
           <a:lstStyle/>
           <a:p>
             <a:pPr>
-              <a:defRPr sz="1000" b="1">
-                <a:solidFill>
-                  <a:srgbClr val="7C3AED"/>
+              <a:defRPr sz="2400" b="1">
+                <a:solidFill>
+                  <a:srgbClr val="0F172A"/>
                 </a:solidFill>
                 <a:latin typeface="Arial"/>
               </a:defRPr>
             </a:pPr>
             <a:r>
-              <a:t>FINANCIAL MANAGEMENT</a:t>
-            </a:r>
-          </a:p>
-        </p:txBody>
-      </p:sp>
-      <p:sp>
-        <p:nvSpPr>
-          <p:cNvPr id="3" name="TextBox 2"/>
-          <p:cNvSpPr txBox="1"/>
-          <p:nvPr/>
-        </p:nvSpPr>
-        <p:spPr>
-          <a:xfrm>
-            <a:off x="731520" y="685800"/>
-            <a:ext cx="10058400" cy="640080"/>
-          </a:xfrm>
-          <a:prstGeom prst="rect">
-            <a:avLst/>
-          </a:prstGeom>
-          <a:noFill/>
-        </p:spPr>
-        <p:txBody>
-          <a:bodyPr wrap="square">
-            <a:spAutoFit/>
-          </a:bodyPr>
-          <a:lstStyle/>
-          <a:p>
-            <a:pPr>
-              <a:defRPr sz="2600" b="1">
-                <a:solidFill>
-                  <a:srgbClr val="111827"/>
-                </a:solidFill>
-                <a:latin typeface="Arial"/>
-              </a:defRPr>
-            </a:pPr>
-            <a:r>
               <a:t>Group Expense Splitter (Ledger Engine)</a:t>
             </a:r>
           </a:p>
@@ -5294,14 +6438,14 @@
       </p:sp>
       <p:sp>
         <p:nvSpPr>
-          <p:cNvPr id="4" name="Rounded Rectangle 3"/>
+          <p:cNvPr id="6" name="Rounded Rectangle 5"/>
           <p:cNvSpPr/>
           <p:nvPr/>
         </p:nvSpPr>
         <p:spPr>
           <a:xfrm>
-            <a:off x="731520" y="1554480"/>
-            <a:ext cx="2560320" cy="4663440"/>
+            <a:off x="731520" y="1463040"/>
+            <a:ext cx="2560320" cy="4754880"/>
           </a:xfrm>
           <a:prstGeom prst="roundRect">
             <a:avLst/>
@@ -5336,7 +6480,7 @@
             <a:pPr algn="ctr">
               <a:defRPr sz="1700" b="1">
                 <a:solidFill>
-                  <a:srgbClr val="111827"/>
+                  <a:srgbClr val="0F172A"/>
                 </a:solidFill>
               </a:defRPr>
             </a:pPr>
@@ -5351,7 +6495,7 @@
               </a:spcBef>
               <a:defRPr sz="1300">
                 <a:solidFill>
-                  <a:srgbClr val="6B7280"/>
+                  <a:srgbClr val="475569"/>
                 </a:solidFill>
               </a:defRPr>
             </a:pPr>
@@ -5363,14 +6507,57 @@
       </p:sp>
       <p:sp>
         <p:nvSpPr>
-          <p:cNvPr id="5" name="Rounded Rectangle 4"/>
+          <p:cNvPr id="7" name="Rectangle 6"/>
           <p:cNvSpPr/>
           <p:nvPr/>
         </p:nvSpPr>
         <p:spPr>
           <a:xfrm>
-            <a:off x="3429000" y="1554480"/>
-            <a:ext cx="2560320" cy="4663440"/>
+            <a:off x="731520" y="1463040"/>
+            <a:ext cx="2560320" cy="109728"/>
+          </a:xfrm>
+          <a:prstGeom prst="rect">
+            <a:avLst/>
+          </a:prstGeom>
+          <a:solidFill>
+            <a:srgbClr val="10B981"/>
+          </a:solidFill>
+          <a:ln>
+            <a:noFill/>
+          </a:ln>
+        </p:spPr>
+        <p:style>
+          <a:lnRef idx="1">
+            <a:schemeClr val="accent1"/>
+          </a:lnRef>
+          <a:fillRef idx="3">
+            <a:schemeClr val="accent1"/>
+          </a:fillRef>
+          <a:effectRef idx="2">
+            <a:schemeClr val="accent1"/>
+          </a:effectRef>
+          <a:fontRef idx="minor">
+            <a:schemeClr val="lt1"/>
+          </a:fontRef>
+        </p:style>
+        <p:txBody>
+          <a:bodyPr rtlCol="0" anchor="ctr"/>
+          <a:lstStyle/>
+          <a:p>
+            <a:pPr algn="ctr"/>
+          </a:p>
+        </p:txBody>
+      </p:sp>
+      <p:sp>
+        <p:nvSpPr>
+          <p:cNvPr id="8" name="Rounded Rectangle 7"/>
+          <p:cNvSpPr/>
+          <p:nvPr/>
+        </p:nvSpPr>
+        <p:spPr>
+          <a:xfrm>
+            <a:off x="3429000" y="1463040"/>
+            <a:ext cx="2560320" cy="4754880"/>
           </a:xfrm>
           <a:prstGeom prst="roundRect">
             <a:avLst/>
@@ -5405,7 +6592,7 @@
             <a:pPr algn="ctr">
               <a:defRPr sz="1700" b="1">
                 <a:solidFill>
-                  <a:srgbClr val="111827"/>
+                  <a:srgbClr val="0F172A"/>
                 </a:solidFill>
               </a:defRPr>
             </a:pPr>
@@ -5420,7 +6607,7 @@
               </a:spcBef>
               <a:defRPr sz="1300">
                 <a:solidFill>
-                  <a:srgbClr val="6B7280"/>
+                  <a:srgbClr val="475569"/>
                 </a:solidFill>
               </a:defRPr>
             </a:pPr>
@@ -5432,14 +6619,57 @@
       </p:sp>
       <p:sp>
         <p:nvSpPr>
-          <p:cNvPr id="6" name="Rounded Rectangle 5"/>
+          <p:cNvPr id="9" name="Rectangle 8"/>
           <p:cNvSpPr/>
           <p:nvPr/>
         </p:nvSpPr>
         <p:spPr>
           <a:xfrm>
-            <a:off x="6126480" y="1554480"/>
-            <a:ext cx="2560320" cy="4663440"/>
+            <a:off x="3429000" y="1463040"/>
+            <a:ext cx="2560320" cy="109728"/>
+          </a:xfrm>
+          <a:prstGeom prst="rect">
+            <a:avLst/>
+          </a:prstGeom>
+          <a:solidFill>
+            <a:srgbClr val="10B981"/>
+          </a:solidFill>
+          <a:ln>
+            <a:noFill/>
+          </a:ln>
+        </p:spPr>
+        <p:style>
+          <a:lnRef idx="1">
+            <a:schemeClr val="accent1"/>
+          </a:lnRef>
+          <a:fillRef idx="3">
+            <a:schemeClr val="accent1"/>
+          </a:fillRef>
+          <a:effectRef idx="2">
+            <a:schemeClr val="accent1"/>
+          </a:effectRef>
+          <a:fontRef idx="minor">
+            <a:schemeClr val="lt1"/>
+          </a:fontRef>
+        </p:style>
+        <p:txBody>
+          <a:bodyPr rtlCol="0" anchor="ctr"/>
+          <a:lstStyle/>
+          <a:p>
+            <a:pPr algn="ctr"/>
+          </a:p>
+        </p:txBody>
+      </p:sp>
+      <p:sp>
+        <p:nvSpPr>
+          <p:cNvPr id="10" name="Rounded Rectangle 9"/>
+          <p:cNvSpPr/>
+          <p:nvPr/>
+        </p:nvSpPr>
+        <p:spPr>
+          <a:xfrm>
+            <a:off x="6126480" y="1463040"/>
+            <a:ext cx="2560320" cy="4754880"/>
           </a:xfrm>
           <a:prstGeom prst="roundRect">
             <a:avLst/>
@@ -5474,12 +6704,12 @@
             <a:pPr algn="ctr">
               <a:defRPr sz="1700" b="1">
                 <a:solidFill>
-                  <a:srgbClr val="111827"/>
+                  <a:srgbClr val="0F172A"/>
                 </a:solidFill>
               </a:defRPr>
             </a:pPr>
             <a:r>
-              <a:t>Net Settlement Reduction</a:t>
+              <a:t>Net Debt Reduction</a:t>
             </a:r>
           </a:p>
           <a:p>
@@ -5489,7 +6719,7 @@
               </a:spcBef>
               <a:defRPr sz="1300">
                 <a:solidFill>
-                  <a:srgbClr val="6B7280"/>
+                  <a:srgbClr val="475569"/>
                 </a:solidFill>
               </a:defRPr>
             </a:pPr>
@@ -5501,14 +6731,57 @@
       </p:sp>
       <p:sp>
         <p:nvSpPr>
-          <p:cNvPr id="7" name="Rounded Rectangle 6"/>
+          <p:cNvPr id="11" name="Rectangle 10"/>
           <p:cNvSpPr/>
           <p:nvPr/>
         </p:nvSpPr>
         <p:spPr>
           <a:xfrm>
-            <a:off x="8823960" y="1554480"/>
-            <a:ext cx="2560320" cy="4663440"/>
+            <a:off x="6126480" y="1463040"/>
+            <a:ext cx="2560320" cy="109728"/>
+          </a:xfrm>
+          <a:prstGeom prst="rect">
+            <a:avLst/>
+          </a:prstGeom>
+          <a:solidFill>
+            <a:srgbClr val="10B981"/>
+          </a:solidFill>
+          <a:ln>
+            <a:noFill/>
+          </a:ln>
+        </p:spPr>
+        <p:style>
+          <a:lnRef idx="1">
+            <a:schemeClr val="accent1"/>
+          </a:lnRef>
+          <a:fillRef idx="3">
+            <a:schemeClr val="accent1"/>
+          </a:fillRef>
+          <a:effectRef idx="2">
+            <a:schemeClr val="accent1"/>
+          </a:effectRef>
+          <a:fontRef idx="minor">
+            <a:schemeClr val="lt1"/>
+          </a:fontRef>
+        </p:style>
+        <p:txBody>
+          <a:bodyPr rtlCol="0" anchor="ctr"/>
+          <a:lstStyle/>
+          <a:p>
+            <a:pPr algn="ctr"/>
+          </a:p>
+        </p:txBody>
+      </p:sp>
+      <p:sp>
+        <p:nvSpPr>
+          <p:cNvPr id="12" name="Rounded Rectangle 11"/>
+          <p:cNvSpPr/>
+          <p:nvPr/>
+        </p:nvSpPr>
+        <p:spPr>
+          <a:xfrm>
+            <a:off x="8823960" y="1463040"/>
+            <a:ext cx="2560320" cy="4754880"/>
           </a:xfrm>
           <a:prstGeom prst="roundRect">
             <a:avLst/>
@@ -5543,12 +6816,12 @@
             <a:pPr algn="ctr">
               <a:defRPr sz="1700" b="1">
                 <a:solidFill>
-                  <a:srgbClr val="111827"/>
+                  <a:srgbClr val="0F172A"/>
                 </a:solidFill>
               </a:defRPr>
             </a:pPr>
             <a:r>
-              <a:t>Category Visualizations</a:t>
+              <a:t>Category Analytics</a:t>
             </a:r>
           </a:p>
           <a:p>
@@ -5558,13 +6831,56 @@
               </a:spcBef>
               <a:defRPr sz="1300">
                 <a:solidFill>
-                  <a:srgbClr val="6B7280"/>
+                  <a:srgbClr val="475569"/>
                 </a:solidFill>
               </a:defRPr>
             </a:pPr>
             <a:r>
               <a:t>Generates category-wise expense pie and bar charts for transparent trip financial audits.</a:t>
             </a:r>
+          </a:p>
+        </p:txBody>
+      </p:sp>
+      <p:sp>
+        <p:nvSpPr>
+          <p:cNvPr id="13" name="Rectangle 12"/>
+          <p:cNvSpPr/>
+          <p:nvPr/>
+        </p:nvSpPr>
+        <p:spPr>
+          <a:xfrm>
+            <a:off x="8823960" y="1463040"/>
+            <a:ext cx="2560320" cy="109728"/>
+          </a:xfrm>
+          <a:prstGeom prst="rect">
+            <a:avLst/>
+          </a:prstGeom>
+          <a:solidFill>
+            <a:srgbClr val="10B981"/>
+          </a:solidFill>
+          <a:ln>
+            <a:noFill/>
+          </a:ln>
+        </p:spPr>
+        <p:style>
+          <a:lnRef idx="1">
+            <a:schemeClr val="accent1"/>
+          </a:lnRef>
+          <a:fillRef idx="3">
+            <a:schemeClr val="accent1"/>
+          </a:fillRef>
+          <a:effectRef idx="2">
+            <a:schemeClr val="accent1"/>
+          </a:effectRef>
+          <a:fontRef idx="minor">
+            <a:schemeClr val="lt1"/>
+          </a:fontRef>
+        </p:style>
+        <p:txBody>
+          <a:bodyPr rtlCol="0" anchor="ctr"/>
+          <a:lstStyle/>
+          <a:p>
+            <a:pPr algn="ctr"/>
           </a:p>
         </p:txBody>
       </p:sp>
@@ -5591,96 +6907,24 @@
       <p:grpSpPr/>
       <p:sp>
         <p:nvSpPr>
-          <p:cNvPr id="2" name="TextBox 1"/>
-          <p:cNvSpPr txBox="1"/>
-          <p:nvPr/>
-        </p:nvSpPr>
-        <p:spPr>
-          <a:xfrm>
-            <a:off x="731520" y="411480"/>
-            <a:ext cx="7315200" cy="320040"/>
+          <p:cNvPr id="2" name="Rectangle 1"/>
+          <p:cNvSpPr/>
+          <p:nvPr/>
+        </p:nvSpPr>
+        <p:spPr>
+          <a:xfrm>
+            <a:off x="0" y="0"/>
+            <a:ext cx="12191695" cy="1097280"/>
           </a:xfrm>
           <a:prstGeom prst="rect">
             <a:avLst/>
           </a:prstGeom>
-          <a:noFill/>
-        </p:spPr>
-        <p:txBody>
-          <a:bodyPr wrap="square">
-            <a:spAutoFit/>
-          </a:bodyPr>
-          <a:lstStyle/>
-          <a:p>
-            <a:pPr>
-              <a:defRPr sz="1000" b="1">
-                <a:solidFill>
-                  <a:srgbClr val="7C3AED"/>
-                </a:solidFill>
-                <a:latin typeface="Arial"/>
-              </a:defRPr>
-            </a:pPr>
-            <a:r>
-              <a:t>PERFORMANCE OPTIMIZATIONS</a:t>
-            </a:r>
-          </a:p>
-        </p:txBody>
-      </p:sp>
-      <p:sp>
-        <p:nvSpPr>
-          <p:cNvPr id="3" name="TextBox 2"/>
-          <p:cNvSpPr txBox="1"/>
-          <p:nvPr/>
-        </p:nvSpPr>
-        <p:spPr>
-          <a:xfrm>
-            <a:off x="731520" y="685800"/>
-            <a:ext cx="10058400" cy="640080"/>
-          </a:xfrm>
-          <a:prstGeom prst="rect">
-            <a:avLst/>
-          </a:prstGeom>
-          <a:noFill/>
-        </p:spPr>
-        <p:txBody>
-          <a:bodyPr wrap="square">
-            <a:spAutoFit/>
-          </a:bodyPr>
-          <a:lstStyle/>
-          <a:p>
-            <a:pPr>
-              <a:defRPr sz="2600" b="1">
-                <a:solidFill>
-                  <a:srgbClr val="111827"/>
-                </a:solidFill>
-                <a:latin typeface="Arial"/>
-              </a:defRPr>
-            </a:pPr>
-            <a:r>
-              <a:t>Vercel Serverless &amp; Deployment Stability</a:t>
-            </a:r>
-          </a:p>
-        </p:txBody>
-      </p:sp>
-      <p:sp>
-        <p:nvSpPr>
-          <p:cNvPr id="4" name="Rounded Rectangle 3"/>
-          <p:cNvSpPr/>
-          <p:nvPr/>
-        </p:nvSpPr>
-        <p:spPr>
-          <a:xfrm>
-            <a:off x="731520" y="1554480"/>
-            <a:ext cx="10698480" cy="1051560"/>
-          </a:xfrm>
-          <a:prstGeom prst="roundRect">
-            <a:avLst/>
-          </a:prstGeom>
-          <a:solidFill>
-            <a:srgbClr val="F8FAFC"/>
+          <a:solidFill>
+            <a:srgbClr val="F1F5F9"/>
           </a:solidFill>
           <a:ln>
             <a:solidFill>
-              <a:srgbClr val="E2E8F0"/>
+              <a:srgbClr val="CBD5E1"/>
             </a:solidFill>
           </a:ln>
         </p:spPr>
@@ -5699,51 +6943,32 @@
           </a:fontRef>
         </p:style>
         <p:txBody>
-          <a:bodyPr rtlCol="0" anchor="ctr" wrap="square"/>
-          <a:lstStyle/>
-          <a:p>
-            <a:pPr algn="ctr">
-              <a:defRPr sz="1500" b="1">
-                <a:solidFill>
-                  <a:srgbClr val="7C3AED"/>
-                </a:solidFill>
-              </a:defRPr>
-            </a:pPr>
-            <a:r>
-              <a:t>Vercel Serverless Architecture: </a:t>
-            </a:r>
-            <a:r>
-              <a:rPr sz="1300" b="0">
-                <a:solidFill>
-                  <a:srgbClr val="111827"/>
-                </a:solidFill>
-              </a:rPr>
-              <a:t>Configured using @vercel/python with API route handlers (/api/*) and static asset delivery.</a:t>
-            </a:r>
-          </a:p>
-        </p:txBody>
-      </p:sp>
-      <p:sp>
-        <p:nvSpPr>
-          <p:cNvPr id="5" name="Rounded Rectangle 4"/>
+          <a:bodyPr rtlCol="0" anchor="ctr"/>
+          <a:lstStyle/>
+          <a:p>
+            <a:pPr algn="ctr"/>
+          </a:p>
+        </p:txBody>
+      </p:sp>
+      <p:sp>
+        <p:nvSpPr>
+          <p:cNvPr id="3" name="Rectangle 2"/>
           <p:cNvSpPr/>
           <p:nvPr/>
         </p:nvSpPr>
         <p:spPr>
           <a:xfrm>
-            <a:off x="731520" y="2743200"/>
-            <a:ext cx="10698480" cy="1051560"/>
-          </a:xfrm>
-          <a:prstGeom prst="roundRect">
-            <a:avLst/>
-          </a:prstGeom>
-          <a:solidFill>
-            <a:srgbClr val="F8FAFC"/>
+            <a:off x="0" y="0"/>
+            <a:ext cx="137160" cy="1097280"/>
+          </a:xfrm>
+          <a:prstGeom prst="rect">
+            <a:avLst/>
+          </a:prstGeom>
+          <a:solidFill>
+            <a:srgbClr val="7C3AED"/>
           </a:solidFill>
           <a:ln>
-            <a:solidFill>
-              <a:srgbClr val="E2E8F0"/>
-            </a:solidFill>
+            <a:noFill/>
           </a:ln>
         </p:spPr>
         <p:style>
@@ -5761,51 +6986,32 @@
           </a:fontRef>
         </p:style>
         <p:txBody>
-          <a:bodyPr rtlCol="0" anchor="ctr" wrap="square"/>
-          <a:lstStyle/>
-          <a:p>
-            <a:pPr algn="ctr">
-              <a:defRPr sz="1500" b="1">
-                <a:solidFill>
-                  <a:srgbClr val="7C3AED"/>
-                </a:solidFill>
-              </a:defRPr>
-            </a:pPr>
-            <a:r>
-              <a:t>Strict 3-Second Timeout Capping: </a:t>
-            </a:r>
-            <a:r>
-              <a:rPr sz="1300" b="0">
-                <a:solidFill>
-                  <a:srgbClr val="111827"/>
-                </a:solidFill>
-              </a:rPr>
-              <a:t>Capped HTTP timeouts across external API calls to guarantee complete response execution within Vercel serverless limits.</a:t>
-            </a:r>
-          </a:p>
-        </p:txBody>
-      </p:sp>
-      <p:sp>
-        <p:nvSpPr>
-          <p:cNvPr id="6" name="Rounded Rectangle 5"/>
+          <a:bodyPr rtlCol="0" anchor="ctr"/>
+          <a:lstStyle/>
+          <a:p>
+            <a:pPr algn="ctr"/>
+          </a:p>
+        </p:txBody>
+      </p:sp>
+      <p:sp>
+        <p:nvSpPr>
+          <p:cNvPr id="4" name="Rounded Rectangle 3"/>
           <p:cNvSpPr/>
           <p:nvPr/>
         </p:nvSpPr>
         <p:spPr>
           <a:xfrm>
-            <a:off x="731520" y="3931920"/>
-            <a:ext cx="10698480" cy="1051560"/>
+            <a:off x="731520" y="164592"/>
+            <a:ext cx="2926080" cy="292608"/>
           </a:xfrm>
           <a:prstGeom prst="roundRect">
             <a:avLst/>
           </a:prstGeom>
           <a:solidFill>
-            <a:srgbClr val="F8FAFC"/>
+            <a:srgbClr val="7C3AED"/>
           </a:solidFill>
           <a:ln>
-            <a:solidFill>
-              <a:srgbClr val="E2E8F0"/>
-            </a:solidFill>
+            <a:noFill/>
           </a:ln>
         </p:spPr>
         <p:style>
@@ -5823,40 +7029,68 @@
           </a:fontRef>
         </p:style>
         <p:txBody>
-          <a:bodyPr rtlCol="0" anchor="ctr" wrap="square"/>
+          <a:bodyPr rtlCol="0" anchor="ctr"/>
           <a:lstStyle/>
           <a:p>
             <a:pPr algn="ctr">
-              <a:defRPr sz="1500" b="1">
-                <a:solidFill>
-                  <a:srgbClr val="7C3AED"/>
+              <a:defRPr sz="1000" b="1">
+                <a:solidFill>
+                  <a:srgbClr val="FFFFFF"/>
                 </a:solidFill>
               </a:defRPr>
             </a:pPr>
             <a:r>
-              <a:t>Read-Only Filesystem Handling: </a:t>
-            </a:r>
-            <a:r>
-              <a:rPr sz="1300" b="0">
-                <a:solidFill>
-                  <a:srgbClr val="111827"/>
-                </a:solidFill>
-              </a:rPr>
-              <a:t>Safely catches file creation errors and redirects transient database operations to /tmp/tripsplit_cache.db.</a:t>
-            </a:r>
-          </a:p>
-        </p:txBody>
-      </p:sp>
-      <p:sp>
-        <p:nvSpPr>
-          <p:cNvPr id="7" name="Rounded Rectangle 6"/>
+              <a:t>PERFORMANCE OPTIMIZATIONS</a:t>
+            </a:r>
+          </a:p>
+        </p:txBody>
+      </p:sp>
+      <p:sp>
+        <p:nvSpPr>
+          <p:cNvPr id="5" name="TextBox 4"/>
+          <p:cNvSpPr txBox="1"/>
+          <p:nvPr/>
+        </p:nvSpPr>
+        <p:spPr>
+          <a:xfrm>
+            <a:off x="731520" y="502920"/>
+            <a:ext cx="10515600" cy="502920"/>
+          </a:xfrm>
+          <a:prstGeom prst="rect">
+            <a:avLst/>
+          </a:prstGeom>
+          <a:noFill/>
+        </p:spPr>
+        <p:txBody>
+          <a:bodyPr wrap="none">
+            <a:spAutoFit/>
+          </a:bodyPr>
+          <a:lstStyle/>
+          <a:p>
+            <a:pPr>
+              <a:defRPr sz="2400" b="1">
+                <a:solidFill>
+                  <a:srgbClr val="0F172A"/>
+                </a:solidFill>
+                <a:latin typeface="Arial"/>
+              </a:defRPr>
+            </a:pPr>
+            <a:r>
+              <a:t>Vercel Serverless &amp; Deployment Stability</a:t>
+            </a:r>
+          </a:p>
+        </p:txBody>
+      </p:sp>
+      <p:sp>
+        <p:nvSpPr>
+          <p:cNvPr id="6" name="Rounded Rectangle 5"/>
           <p:cNvSpPr/>
           <p:nvPr/>
         </p:nvSpPr>
         <p:spPr>
           <a:xfrm>
-            <a:off x="731520" y="5120640"/>
-            <a:ext cx="10698480" cy="1051560"/>
+            <a:off x="731520" y="1463040"/>
+            <a:ext cx="10698480" cy="1097280"/>
           </a:xfrm>
           <a:prstGeom prst="roundRect">
             <a:avLst/>
@@ -5866,7 +7100,7 @@
           </a:solidFill>
           <a:ln>
             <a:solidFill>
-              <a:srgbClr val="E2E8F0"/>
+              <a:srgbClr val="CBD5E1"/>
             </a:solidFill>
           </a:ln>
         </p:spPr>
@@ -5891,21 +7125,379 @@
             <a:pPr algn="ctr">
               <a:defRPr sz="1500" b="1">
                 <a:solidFill>
-                  <a:srgbClr val="7C3AED"/>
+                  <a:srgbClr val="10B981"/>
                 </a:solidFill>
               </a:defRPr>
             </a:pPr>
             <a:r>
-              <a:t>Client Storage Persistence: </a:t>
+              <a:t>  Vercel Serverless Architecture: </a:t>
             </a:r>
             <a:r>
               <a:rPr sz="1300" b="0">
                 <a:solidFill>
-                  <a:srgbClr val="111827"/>
+                  <a:srgbClr val="0F172A"/>
+                </a:solidFill>
+              </a:rPr>
+              <a:t>Configured using @vercel/python with API route handlers (/api/*) and static asset delivery.</a:t>
+            </a:r>
+          </a:p>
+        </p:txBody>
+      </p:sp>
+      <p:sp>
+        <p:nvSpPr>
+          <p:cNvPr id="7" name="Rectangle 6"/>
+          <p:cNvSpPr/>
+          <p:nvPr/>
+        </p:nvSpPr>
+        <p:spPr>
+          <a:xfrm>
+            <a:off x="731520" y="1463040"/>
+            <a:ext cx="109728" cy="1097280"/>
+          </a:xfrm>
+          <a:prstGeom prst="rect">
+            <a:avLst/>
+          </a:prstGeom>
+          <a:solidFill>
+            <a:srgbClr val="10B981"/>
+          </a:solidFill>
+          <a:ln>
+            <a:noFill/>
+          </a:ln>
+        </p:spPr>
+        <p:style>
+          <a:lnRef idx="1">
+            <a:schemeClr val="accent1"/>
+          </a:lnRef>
+          <a:fillRef idx="3">
+            <a:schemeClr val="accent1"/>
+          </a:fillRef>
+          <a:effectRef idx="2">
+            <a:schemeClr val="accent1"/>
+          </a:effectRef>
+          <a:fontRef idx="minor">
+            <a:schemeClr val="lt1"/>
+          </a:fontRef>
+        </p:style>
+        <p:txBody>
+          <a:bodyPr rtlCol="0" anchor="ctr"/>
+          <a:lstStyle/>
+          <a:p>
+            <a:pPr algn="ctr"/>
+          </a:p>
+        </p:txBody>
+      </p:sp>
+      <p:sp>
+        <p:nvSpPr>
+          <p:cNvPr id="8" name="Rounded Rectangle 7"/>
+          <p:cNvSpPr/>
+          <p:nvPr/>
+        </p:nvSpPr>
+        <p:spPr>
+          <a:xfrm>
+            <a:off x="731520" y="2697480"/>
+            <a:ext cx="10698480" cy="1097280"/>
+          </a:xfrm>
+          <a:prstGeom prst="roundRect">
+            <a:avLst/>
+          </a:prstGeom>
+          <a:solidFill>
+            <a:srgbClr val="F8FAFC"/>
+          </a:solidFill>
+          <a:ln>
+            <a:solidFill>
+              <a:srgbClr val="CBD5E1"/>
+            </a:solidFill>
+          </a:ln>
+        </p:spPr>
+        <p:style>
+          <a:lnRef idx="1">
+            <a:schemeClr val="accent1"/>
+          </a:lnRef>
+          <a:fillRef idx="3">
+            <a:schemeClr val="accent1"/>
+          </a:fillRef>
+          <a:effectRef idx="2">
+            <a:schemeClr val="accent1"/>
+          </a:effectRef>
+          <a:fontRef idx="minor">
+            <a:schemeClr val="lt1"/>
+          </a:fontRef>
+        </p:style>
+        <p:txBody>
+          <a:bodyPr rtlCol="0" anchor="ctr" wrap="square"/>
+          <a:lstStyle/>
+          <a:p>
+            <a:pPr algn="ctr">
+              <a:defRPr sz="1500" b="1">
+                <a:solidFill>
+                  <a:srgbClr val="10B981"/>
+                </a:solidFill>
+              </a:defRPr>
+            </a:pPr>
+            <a:r>
+              <a:t>  Strict 3-Second Timeout Capping: </a:t>
+            </a:r>
+            <a:r>
+              <a:rPr sz="1300" b="0">
+                <a:solidFill>
+                  <a:srgbClr val="0F172A"/>
+                </a:solidFill>
+              </a:rPr>
+              <a:t>Capped HTTP timeouts across external API calls to guarantee complete response execution within Vercel serverless limits.</a:t>
+            </a:r>
+          </a:p>
+        </p:txBody>
+      </p:sp>
+      <p:sp>
+        <p:nvSpPr>
+          <p:cNvPr id="9" name="Rectangle 8"/>
+          <p:cNvSpPr/>
+          <p:nvPr/>
+        </p:nvSpPr>
+        <p:spPr>
+          <a:xfrm>
+            <a:off x="731520" y="2697480"/>
+            <a:ext cx="109728" cy="1097280"/>
+          </a:xfrm>
+          <a:prstGeom prst="rect">
+            <a:avLst/>
+          </a:prstGeom>
+          <a:solidFill>
+            <a:srgbClr val="10B981"/>
+          </a:solidFill>
+          <a:ln>
+            <a:noFill/>
+          </a:ln>
+        </p:spPr>
+        <p:style>
+          <a:lnRef idx="1">
+            <a:schemeClr val="accent1"/>
+          </a:lnRef>
+          <a:fillRef idx="3">
+            <a:schemeClr val="accent1"/>
+          </a:fillRef>
+          <a:effectRef idx="2">
+            <a:schemeClr val="accent1"/>
+          </a:effectRef>
+          <a:fontRef idx="minor">
+            <a:schemeClr val="lt1"/>
+          </a:fontRef>
+        </p:style>
+        <p:txBody>
+          <a:bodyPr rtlCol="0" anchor="ctr"/>
+          <a:lstStyle/>
+          <a:p>
+            <a:pPr algn="ctr"/>
+          </a:p>
+        </p:txBody>
+      </p:sp>
+      <p:sp>
+        <p:nvSpPr>
+          <p:cNvPr id="10" name="Rounded Rectangle 9"/>
+          <p:cNvSpPr/>
+          <p:nvPr/>
+        </p:nvSpPr>
+        <p:spPr>
+          <a:xfrm>
+            <a:off x="731520" y="3931920"/>
+            <a:ext cx="10698480" cy="1097280"/>
+          </a:xfrm>
+          <a:prstGeom prst="roundRect">
+            <a:avLst/>
+          </a:prstGeom>
+          <a:solidFill>
+            <a:srgbClr val="F8FAFC"/>
+          </a:solidFill>
+          <a:ln>
+            <a:solidFill>
+              <a:srgbClr val="CBD5E1"/>
+            </a:solidFill>
+          </a:ln>
+        </p:spPr>
+        <p:style>
+          <a:lnRef idx="1">
+            <a:schemeClr val="accent1"/>
+          </a:lnRef>
+          <a:fillRef idx="3">
+            <a:schemeClr val="accent1"/>
+          </a:fillRef>
+          <a:effectRef idx="2">
+            <a:schemeClr val="accent1"/>
+          </a:effectRef>
+          <a:fontRef idx="minor">
+            <a:schemeClr val="lt1"/>
+          </a:fontRef>
+        </p:style>
+        <p:txBody>
+          <a:bodyPr rtlCol="0" anchor="ctr" wrap="square"/>
+          <a:lstStyle/>
+          <a:p>
+            <a:pPr algn="ctr">
+              <a:defRPr sz="1500" b="1">
+                <a:solidFill>
+                  <a:srgbClr val="10B981"/>
+                </a:solidFill>
+              </a:defRPr>
+            </a:pPr>
+            <a:r>
+              <a:t>  Read-Only Filesystem Handling: </a:t>
+            </a:r>
+            <a:r>
+              <a:rPr sz="1300" b="0">
+                <a:solidFill>
+                  <a:srgbClr val="0F172A"/>
+                </a:solidFill>
+              </a:rPr>
+              <a:t>Safely catches file creation errors and redirects transient database operations to /tmp/tripsplit_cache.db.</a:t>
+            </a:r>
+          </a:p>
+        </p:txBody>
+      </p:sp>
+      <p:sp>
+        <p:nvSpPr>
+          <p:cNvPr id="11" name="Rectangle 10"/>
+          <p:cNvSpPr/>
+          <p:nvPr/>
+        </p:nvSpPr>
+        <p:spPr>
+          <a:xfrm>
+            <a:off x="731520" y="3931920"/>
+            <a:ext cx="109728" cy="1097280"/>
+          </a:xfrm>
+          <a:prstGeom prst="rect">
+            <a:avLst/>
+          </a:prstGeom>
+          <a:solidFill>
+            <a:srgbClr val="10B981"/>
+          </a:solidFill>
+          <a:ln>
+            <a:noFill/>
+          </a:ln>
+        </p:spPr>
+        <p:style>
+          <a:lnRef idx="1">
+            <a:schemeClr val="accent1"/>
+          </a:lnRef>
+          <a:fillRef idx="3">
+            <a:schemeClr val="accent1"/>
+          </a:fillRef>
+          <a:effectRef idx="2">
+            <a:schemeClr val="accent1"/>
+          </a:effectRef>
+          <a:fontRef idx="minor">
+            <a:schemeClr val="lt1"/>
+          </a:fontRef>
+        </p:style>
+        <p:txBody>
+          <a:bodyPr rtlCol="0" anchor="ctr"/>
+          <a:lstStyle/>
+          <a:p>
+            <a:pPr algn="ctr"/>
+          </a:p>
+        </p:txBody>
+      </p:sp>
+      <p:sp>
+        <p:nvSpPr>
+          <p:cNvPr id="12" name="Rounded Rectangle 11"/>
+          <p:cNvSpPr/>
+          <p:nvPr/>
+        </p:nvSpPr>
+        <p:spPr>
+          <a:xfrm>
+            <a:off x="731520" y="5166360"/>
+            <a:ext cx="10698480" cy="1097280"/>
+          </a:xfrm>
+          <a:prstGeom prst="roundRect">
+            <a:avLst/>
+          </a:prstGeom>
+          <a:solidFill>
+            <a:srgbClr val="F8FAFC"/>
+          </a:solidFill>
+          <a:ln>
+            <a:solidFill>
+              <a:srgbClr val="CBD5E1"/>
+            </a:solidFill>
+          </a:ln>
+        </p:spPr>
+        <p:style>
+          <a:lnRef idx="1">
+            <a:schemeClr val="accent1"/>
+          </a:lnRef>
+          <a:fillRef idx="3">
+            <a:schemeClr val="accent1"/>
+          </a:fillRef>
+          <a:effectRef idx="2">
+            <a:schemeClr val="accent1"/>
+          </a:effectRef>
+          <a:fontRef idx="minor">
+            <a:schemeClr val="lt1"/>
+          </a:fontRef>
+        </p:style>
+        <p:txBody>
+          <a:bodyPr rtlCol="0" anchor="ctr" wrap="square"/>
+          <a:lstStyle/>
+          <a:p>
+            <a:pPr algn="ctr">
+              <a:defRPr sz="1500" b="1">
+                <a:solidFill>
+                  <a:srgbClr val="10B981"/>
+                </a:solidFill>
+              </a:defRPr>
+            </a:pPr>
+            <a:r>
+              <a:t>  Client Storage Persistence: </a:t>
+            </a:r>
+            <a:r>
+              <a:rPr sz="1300" b="0">
+                <a:solidFill>
+                  <a:srgbClr val="0F172A"/>
                 </a:solidFill>
               </a:rPr>
               <a:t>Leverages browser LocalStorage to store active user preferences, group rosters, and saved venue bookmarks.</a:t>
             </a:r>
+          </a:p>
+        </p:txBody>
+      </p:sp>
+      <p:sp>
+        <p:nvSpPr>
+          <p:cNvPr id="13" name="Rectangle 12"/>
+          <p:cNvSpPr/>
+          <p:nvPr/>
+        </p:nvSpPr>
+        <p:spPr>
+          <a:xfrm>
+            <a:off x="731520" y="5166360"/>
+            <a:ext cx="109728" cy="1097280"/>
+          </a:xfrm>
+          <a:prstGeom prst="rect">
+            <a:avLst/>
+          </a:prstGeom>
+          <a:solidFill>
+            <a:srgbClr val="10B981"/>
+          </a:solidFill>
+          <a:ln>
+            <a:noFill/>
+          </a:ln>
+        </p:spPr>
+        <p:style>
+          <a:lnRef idx="1">
+            <a:schemeClr val="accent1"/>
+          </a:lnRef>
+          <a:fillRef idx="3">
+            <a:schemeClr val="accent1"/>
+          </a:fillRef>
+          <a:effectRef idx="2">
+            <a:schemeClr val="accent1"/>
+          </a:effectRef>
+          <a:fontRef idx="minor">
+            <a:schemeClr val="lt1"/>
+          </a:fontRef>
+        </p:style>
+        <p:txBody>
+          <a:bodyPr rtlCol="0" anchor="ctr"/>
+          <a:lstStyle/>
+          <a:p>
+            <a:pPr algn="ctr"/>
           </a:p>
         </p:txBody>
       </p:sp>
@@ -5932,14 +7524,154 @@
       <p:grpSpPr/>
       <p:sp>
         <p:nvSpPr>
-          <p:cNvPr id="2" name="TextBox 1"/>
+          <p:cNvPr id="2" name="Rectangle 1"/>
+          <p:cNvSpPr/>
+          <p:nvPr/>
+        </p:nvSpPr>
+        <p:spPr>
+          <a:xfrm>
+            <a:off x="0" y="0"/>
+            <a:ext cx="12191695" cy="1097280"/>
+          </a:xfrm>
+          <a:prstGeom prst="rect">
+            <a:avLst/>
+          </a:prstGeom>
+          <a:solidFill>
+            <a:srgbClr val="F1F5F9"/>
+          </a:solidFill>
+          <a:ln>
+            <a:solidFill>
+              <a:srgbClr val="CBD5E1"/>
+            </a:solidFill>
+          </a:ln>
+        </p:spPr>
+        <p:style>
+          <a:lnRef idx="1">
+            <a:schemeClr val="accent1"/>
+          </a:lnRef>
+          <a:fillRef idx="3">
+            <a:schemeClr val="accent1"/>
+          </a:fillRef>
+          <a:effectRef idx="2">
+            <a:schemeClr val="accent1"/>
+          </a:effectRef>
+          <a:fontRef idx="minor">
+            <a:schemeClr val="lt1"/>
+          </a:fontRef>
+        </p:style>
+        <p:txBody>
+          <a:bodyPr rtlCol="0" anchor="ctr"/>
+          <a:lstStyle/>
+          <a:p>
+            <a:pPr algn="ctr"/>
+          </a:p>
+        </p:txBody>
+      </p:sp>
+      <p:sp>
+        <p:nvSpPr>
+          <p:cNvPr id="3" name="Rectangle 2"/>
+          <p:cNvSpPr/>
+          <p:nvPr/>
+        </p:nvSpPr>
+        <p:spPr>
+          <a:xfrm>
+            <a:off x="0" y="0"/>
+            <a:ext cx="137160" cy="1097280"/>
+          </a:xfrm>
+          <a:prstGeom prst="rect">
+            <a:avLst/>
+          </a:prstGeom>
+          <a:solidFill>
+            <a:srgbClr val="7C3AED"/>
+          </a:solidFill>
+          <a:ln>
+            <a:noFill/>
+          </a:ln>
+        </p:spPr>
+        <p:style>
+          <a:lnRef idx="1">
+            <a:schemeClr val="accent1"/>
+          </a:lnRef>
+          <a:fillRef idx="3">
+            <a:schemeClr val="accent1"/>
+          </a:fillRef>
+          <a:effectRef idx="2">
+            <a:schemeClr val="accent1"/>
+          </a:effectRef>
+          <a:fontRef idx="minor">
+            <a:schemeClr val="lt1"/>
+          </a:fontRef>
+        </p:style>
+        <p:txBody>
+          <a:bodyPr rtlCol="0" anchor="ctr"/>
+          <a:lstStyle/>
+          <a:p>
+            <a:pPr algn="ctr"/>
+          </a:p>
+        </p:txBody>
+      </p:sp>
+      <p:sp>
+        <p:nvSpPr>
+          <p:cNvPr id="4" name="Rounded Rectangle 3"/>
+          <p:cNvSpPr/>
+          <p:nvPr/>
+        </p:nvSpPr>
+        <p:spPr>
+          <a:xfrm>
+            <a:off x="731520" y="164592"/>
+            <a:ext cx="2926080" cy="292608"/>
+          </a:xfrm>
+          <a:prstGeom prst="roundRect">
+            <a:avLst/>
+          </a:prstGeom>
+          <a:solidFill>
+            <a:srgbClr val="7C3AED"/>
+          </a:solidFill>
+          <a:ln>
+            <a:noFill/>
+          </a:ln>
+        </p:spPr>
+        <p:style>
+          <a:lnRef idx="1">
+            <a:schemeClr val="accent1"/>
+          </a:lnRef>
+          <a:fillRef idx="3">
+            <a:schemeClr val="accent1"/>
+          </a:fillRef>
+          <a:effectRef idx="2">
+            <a:schemeClr val="accent1"/>
+          </a:effectRef>
+          <a:fontRef idx="minor">
+            <a:schemeClr val="lt1"/>
+          </a:fontRef>
+        </p:style>
+        <p:txBody>
+          <a:bodyPr rtlCol="0" anchor="ctr"/>
+          <a:lstStyle/>
+          <a:p>
+            <a:pPr algn="ctr">
+              <a:defRPr sz="1000" b="1">
+                <a:solidFill>
+                  <a:srgbClr val="FFFFFF"/>
+                </a:solidFill>
+              </a:defRPr>
+            </a:pPr>
+            <a:r>
+              <a:t>PROJECT ROADMAP</a:t>
+            </a:r>
+          </a:p>
+        </p:txBody>
+      </p:sp>
+      <p:sp>
+        <p:nvSpPr>
+          <p:cNvPr id="5" name="TextBox 4"/>
           <p:cNvSpPr txBox="1"/>
           <p:nvPr/>
         </p:nvSpPr>
         <p:spPr>
           <a:xfrm>
-            <a:off x="731520" y="411480"/>
-            <a:ext cx="7315200" cy="320040"/>
+            <a:off x="731520" y="502920"/>
+            <a:ext cx="10515600" cy="502920"/>
           </a:xfrm>
           <a:prstGeom prst="rect">
             <a:avLst/>
@@ -5947,56 +7679,20 @@
           <a:noFill/>
         </p:spPr>
         <p:txBody>
-          <a:bodyPr wrap="square">
+          <a:bodyPr wrap="none">
             <a:spAutoFit/>
           </a:bodyPr>
           <a:lstStyle/>
           <a:p>
             <a:pPr>
-              <a:defRPr sz="1000" b="1">
-                <a:solidFill>
-                  <a:srgbClr val="7C3AED"/>
+              <a:defRPr sz="2400" b="1">
+                <a:solidFill>
+                  <a:srgbClr val="0F172A"/>
                 </a:solidFill>
                 <a:latin typeface="Arial"/>
               </a:defRPr>
             </a:pPr>
             <a:r>
-              <a:t>PROJECT ROADMAP</a:t>
-            </a:r>
-          </a:p>
-        </p:txBody>
-      </p:sp>
-      <p:sp>
-        <p:nvSpPr>
-          <p:cNvPr id="3" name="TextBox 2"/>
-          <p:cNvSpPr txBox="1"/>
-          <p:nvPr/>
-        </p:nvSpPr>
-        <p:spPr>
-          <a:xfrm>
-            <a:off x="731520" y="685800"/>
-            <a:ext cx="10058400" cy="640080"/>
-          </a:xfrm>
-          <a:prstGeom prst="rect">
-            <a:avLst/>
-          </a:prstGeom>
-          <a:noFill/>
-        </p:spPr>
-        <p:txBody>
-          <a:bodyPr wrap="square">
-            <a:spAutoFit/>
-          </a:bodyPr>
-          <a:lstStyle/>
-          <a:p>
-            <a:pPr>
-              <a:defRPr sz="2600" b="1">
-                <a:solidFill>
-                  <a:srgbClr val="111827"/>
-                </a:solidFill>
-                <a:latin typeface="Arial"/>
-              </a:defRPr>
-            </a:pPr>
-            <a:r>
               <a:t>Future Enhancements &amp; Roadmap</a:t>
             </a:r>
           </a:p>
@@ -6004,14 +7700,14 @@
       </p:sp>
       <p:sp>
         <p:nvSpPr>
-          <p:cNvPr id="4" name="Rounded Rectangle 3"/>
+          <p:cNvPr id="6" name="Rounded Rectangle 5"/>
           <p:cNvSpPr/>
           <p:nvPr/>
         </p:nvSpPr>
         <p:spPr>
           <a:xfrm>
-            <a:off x="731520" y="1554480"/>
-            <a:ext cx="5120640" cy="2103120"/>
+            <a:off x="731520" y="1463040"/>
+            <a:ext cx="5120640" cy="2148840"/>
           </a:xfrm>
           <a:prstGeom prst="roundRect">
             <a:avLst/>
@@ -6061,7 +7757,7 @@
               </a:spcBef>
               <a:defRPr sz="1300">
                 <a:solidFill>
-                  <a:srgbClr val="111827"/>
+                  <a:srgbClr val="0F172A"/>
                 </a:solidFill>
               </a:defRPr>
             </a:pPr>
@@ -6073,14 +7769,14 @@
       </p:sp>
       <p:sp>
         <p:nvSpPr>
-          <p:cNvPr id="5" name="Rounded Rectangle 4"/>
+          <p:cNvPr id="7" name="Rounded Rectangle 6"/>
           <p:cNvSpPr/>
           <p:nvPr/>
         </p:nvSpPr>
         <p:spPr>
           <a:xfrm>
-            <a:off x="6126480" y="1554480"/>
-            <a:ext cx="5120640" cy="2103120"/>
+            <a:off x="6126480" y="1463040"/>
+            <a:ext cx="5120640" cy="2148840"/>
           </a:xfrm>
           <a:prstGeom prst="roundRect">
             <a:avLst/>
@@ -6130,7 +7826,7 @@
               </a:spcBef>
               <a:defRPr sz="1300">
                 <a:solidFill>
-                  <a:srgbClr val="111827"/>
+                  <a:srgbClr val="0F172A"/>
                 </a:solidFill>
               </a:defRPr>
             </a:pPr>
@@ -6142,14 +7838,14 @@
       </p:sp>
       <p:sp>
         <p:nvSpPr>
-          <p:cNvPr id="6" name="Rounded Rectangle 5"/>
+          <p:cNvPr id="8" name="Rounded Rectangle 7"/>
           <p:cNvSpPr/>
           <p:nvPr/>
         </p:nvSpPr>
         <p:spPr>
           <a:xfrm>
             <a:off x="731520" y="3931920"/>
-            <a:ext cx="5120640" cy="2103120"/>
+            <a:ext cx="5120640" cy="2148840"/>
           </a:xfrm>
           <a:prstGeom prst="roundRect">
             <a:avLst/>
@@ -6199,7 +7895,7 @@
               </a:spcBef>
               <a:defRPr sz="1300">
                 <a:solidFill>
-                  <a:srgbClr val="111827"/>
+                  <a:srgbClr val="0F172A"/>
                 </a:solidFill>
               </a:defRPr>
             </a:pPr>
@@ -6211,14 +7907,14 @@
       </p:sp>
       <p:sp>
         <p:nvSpPr>
-          <p:cNvPr id="7" name="Rounded Rectangle 6"/>
+          <p:cNvPr id="9" name="Rounded Rectangle 8"/>
           <p:cNvSpPr/>
           <p:nvPr/>
         </p:nvSpPr>
         <p:spPr>
           <a:xfrm>
             <a:off x="6126480" y="3931920"/>
-            <a:ext cx="5120640" cy="2103120"/>
+            <a:ext cx="5120640" cy="2148840"/>
           </a:xfrm>
           <a:prstGeom prst="roundRect">
             <a:avLst/>
@@ -6268,7 +7964,7 @@
               </a:spcBef>
               <a:defRPr sz="1300">
                 <a:solidFill>
-                  <a:srgbClr val="111827"/>
+                  <a:srgbClr val="0F172A"/>
                 </a:solidFill>
               </a:defRPr>
             </a:pPr>

</xml_diff>